<commit_message>
style: upgrade presentation to Prismatic Obsidian Neon theme with live QR code and visual timing pills
</commit_message>
<xml_diff>
--- a/Prismatic_Shark_Tank_Pitch_Deck.pptx
+++ b/Prismatic_Shark_Tank_Pitch_Deck.pptx
@@ -505,18 +505,34 @@
           <a:lstStyle/>
           <a:p>
             <a:r>
-              <a:t>THE 25-SECOND HOOK:</a:t>
-            </a:r>
-          </a:p>
-          <a:p>
-            <a:r>
-              <a:t>Judges, picture a 300-person lecture hall right here at Howard or UMD. The professor spends 75 minutes covering one complex concept. Half the class nods; the other half walks out completely lost, staring at a 40-page slide deck with intense brain fog.</a:t>
+              <a:t>OFFICIAL TIMED SCRIPT (0:00 - 0:35):</a:t>
             </a:r>
           </a:p>
           <a:p/>
           <a:p>
             <a:r>
-              <a:t>The problem isn't that college students aren't smart. The problem is that white light contains every color, but a flat chalkboard only projects one shade. Professors teach in one rigid format, while human brains process information in completely different spectrums.</a:t>
+              <a:t>[0:00 - 0:10] SEGMENT 1: TEAM NAME (10s)</a:t>
+            </a:r>
+          </a:p>
+          <a:p>
+            <a:r>
+              <a:t>"Good afternoon, judges and fellow builders! We are PRISMATIC—and we are here to refract the way college students learn!"</a:t>
+            </a:r>
+          </a:p>
+          <a:p/>
+          <a:p>
+            <a:r>
+              <a:t>[0:10 - 0:35] SEGMENT 2: THE HOOK (25s)</a:t>
+            </a:r>
+          </a:p>
+          <a:p>
+            <a:r>
+              <a:t>"Picture a 300-person lecture hall right here at Howard or UMD. The professor spends 75 minutes covering one complex concept. Half the class nods; the other half walks out completely lost with intense brain fog.</a:t>
+            </a:r>
+          </a:p>
+          <a:p>
+            <a:r>
+              <a:t>The problem isn't student intellect. White light contains every color, but a flat chalkboard only projects one shade. Professors teach in one rigid format, while human brains process knowledge in completely different spectrums."</a:t>
             </a:r>
           </a:p>
         </p:txBody>
@@ -586,22 +602,43 @@
           <a:lstStyle/>
           <a:p>
             <a:r>
-              <a:t>THE SOLUTION PITCH:</a:t>
-            </a:r>
-          </a:p>
-          <a:p>
-            <a:r>
-              <a:t>That is why we built Prismatic. Prismatic is an agentic learning engine on Amazon Quick that acts as a cognitive prism.</a:t>
-            </a:r>
-          </a:p>
-          <a:p>
-            <a:r>
-              <a:t>In under 30 seconds, a rapid 5-question diagnostic maps how your brain actually absorbs information—whether you need analogies, visual flowcharts, Socratic active recall, or an emergency 15-minute action sprint.</a:t>
-            </a:r>
-          </a:p>
-          <a:p>
-            <a:r>
-              <a:t>Instead of forcing you to adapt to the syllabus, Prismatic adapts the syllabus to you.</a:t>
+              <a:t>OFFICIAL TIMED SCRIPT (0:35 - 1:20):</a:t>
+            </a:r>
+          </a:p>
+          <a:p/>
+          <a:p>
+            <a:r>
+              <a:t>[0:35 - 1:20] SEGMENT 3: YOUR APP (45s)</a:t>
+            </a:r>
+          </a:p>
+          <a:p>
+            <a:r>
+              <a:t>"We built Prismatic on Amazon Quick—an agentic cognitive engine that turns 1 static lecture into 4 tailored learning modalities in under 30 seconds.</a:t>
+            </a:r>
+          </a:p>
+          <a:p>
+            <a:r>
+              <a:t>First, a rapid 5-question diagnostic maps how your brain absorbs information. Then, our Amazon Bedrock pipeline instantly refracts the material:</a:t>
+            </a:r>
+          </a:p>
+          <a:p>
+            <a:r>
+              <a:t>- Spectrum 1 translates abstract theory into relatable dorm and dining hall analogies.</a:t>
+            </a:r>
+          </a:p>
+          <a:p>
+            <a:r>
+              <a:t>- Spectrum 2 renders structural ASCII concept maps.</a:t>
+            </a:r>
+          </a:p>
+          <a:p>
+            <a:r>
+              <a:t>- Spectrum 3 launches a Socratic Sparring Partner that quizzes you one edge-case at a time without spoiling answers.</a:t>
+            </a:r>
+          </a:p>
+          <a:p>
+            <a:r>
+              <a:t>- And Spectrum 4 builds a 4-slide micro-deck exposing the exact trap questions professors test on midterms."</a:t>
             </a:r>
           </a:p>
         </p:txBody>
@@ -671,37 +708,33 @@
           <a:lstStyle/>
           <a:p>
             <a:r>
-              <a:t>LIVE APPLICATION WALKTHROUGH:</a:t>
-            </a:r>
-          </a:p>
-          <a:p>
-            <a:r>
-              <a:t>Here is Prismatic running live on Amazon Quick:</a:t>
-            </a:r>
-          </a:p>
-          <a:p>
-            <a:r>
-              <a:t>When you paste in a notoriously brutal topic—like Dijkstra’s Algorithm or Cellular Respiration:</a:t>
-            </a:r>
-          </a:p>
-          <a:p>
-            <a:r>
-              <a:t>1. For conceptual thinkers, Spectrum 1 translates the math into a relatable campus dining hall rush.</a:t>
-            </a:r>
-          </a:p>
-          <a:p>
-            <a:r>
-              <a:t>2. For visual learners, Spectrum 2 renders an interactive ASCII concept map.</a:t>
-            </a:r>
-          </a:p>
-          <a:p>
-            <a:r>
-              <a:t>3. For active crammers, Spectrum 3 launches our Socratic Sparring Partner—an AI that quizzes you with high-yield edge cases.</a:t>
-            </a:r>
-          </a:p>
-          <a:p>
-            <a:r>
-              <a:t>4. And for exam morning, it builds a 4-slide micro-deck exposing the exact trap questions professors love to test.</a:t>
+              <a:t>OFFICIAL TIMED SCRIPT (1:20 - 1:45):</a:t>
+            </a:r>
+          </a:p>
+          <a:p/>
+          <a:p>
+            <a:r>
+              <a:t>[1:20 - 1:45] SEGMENT 4: WHY IT WINS (25s)</a:t>
+            </a:r>
+          </a:p>
+          <a:p>
+            <a:r>
+              <a:t>"Over 20 million college students face academic paralysis every semester.</a:t>
+            </a:r>
+          </a:p>
+          <a:p>
+            <a:r>
+              <a:t>Generic tools like ChatGPT just dump dry walls of text that students glaze over.</a:t>
+            </a:r>
+          </a:p>
+          <a:p>
+            <a:r>
+              <a:t>Private tutoring costs $80 an hour, and professor office hours are only 2 hours a week.</a:t>
+            </a:r>
+          </a:p>
+          <a:p>
+            <a:r>
+              <a:t>Prismatic is active, multi-modal, and adapts the syllabus to the student—democratizing elite private tutoring for pennies."</a:t>
             </a:r>
           </a:p>
         </p:txBody>
@@ -771,17 +804,28 @@
           <a:lstStyle/>
           <a:p>
             <a:r>
-              <a:t>THE SHARK TANK CLOSE:</a:t>
-            </a:r>
-          </a:p>
-          <a:p>
-            <a:r>
-              <a:t>Private tutors cost $80 an hour. University office hours are 2 hours a week. Prismatic democratizes elite, personalized cognitive tutoring for every college student on campus with zero barriers to entry.</a:t>
-            </a:r>
-          </a:p>
-          <a:p>
-            <a:r>
-              <a:t>We don't just help students pass exams; we eliminate academic paralysis and unlock confidence. We are Prismatic—refracting complex knowledge into your native spectrum. Thank you!</a:t>
+              <a:t>OFFICIAL TIMED SCRIPT (1:45 - 2:00):</a:t>
+            </a:r>
+          </a:p>
+          <a:p/>
+          <a:p>
+            <a:r>
+              <a:t>[1:45 - 2:00] SEGMENT 5: THE CLOSE (15s)</a:t>
+            </a:r>
+          </a:p>
+          <a:p>
+            <a:r>
+              <a:t>"With more time, we’d add live Canvas and syllabus LMS integration, automatically syncing weekly exam dates and generating proactive 15-minute micro-sprints before every morning class.</a:t>
+            </a:r>
+          </a:p>
+          <a:p>
+            <a:r>
+              <a:t>We are PRISMATIC—refracting complex knowledge into your native spectrum.</a:t>
+            </a:r>
+          </a:p>
+          <a:p>
+            <a:r>
+              <a:t>Vote Prismatic for your room champion! Thank you!"</a:t>
             </a:r>
           </a:p>
         </p:txBody>
@@ -3802,7 +3846,7 @@
             <a:avLst/>
           </a:prstGeom>
           <a:solidFill>
-            <a:srgbClr val="0B0F19"/>
+            <a:srgbClr val="080B13"/>
           </a:solidFill>
           <a:ln>
             <a:noFill/>
@@ -3838,18 +3882,18 @@
         </p:nvSpPr>
         <p:spPr>
           <a:xfrm>
-            <a:off x="731520" y="914400"/>
-            <a:ext cx="4114800" cy="365760"/>
+            <a:off x="731520" y="594360"/>
+            <a:ext cx="5120640" cy="384048"/>
           </a:xfrm>
           <a:prstGeom prst="roundRect">
             <a:avLst/>
           </a:prstGeom>
           <a:solidFill>
-            <a:srgbClr val="1A2234"/>
+            <a:srgbClr val="161E30"/>
           </a:solidFill>
           <a:ln w="15240">
             <a:solidFill>
-              <a:srgbClr val="00D4FF"/>
+              <a:srgbClr val="00E5FF"/>
             </a:solidFill>
           </a:ln>
         </p:spPr>
@@ -3883,8 +3927,8 @@
         </p:nvSpPr>
         <p:spPr>
           <a:xfrm>
-            <a:off x="822960" y="960120"/>
-            <a:ext cx="3931920" cy="274320"/>
+            <a:off x="822960" y="640080"/>
+            <a:ext cx="4937760" cy="292608"/>
           </a:xfrm>
           <a:prstGeom prst="rect">
             <a:avLst/>
@@ -3900,13 +3944,13 @@
             <a:pPr>
               <a:defRPr sz="950" b="1">
                 <a:solidFill>
-                  <a:srgbClr val="00D4FF"/>
+                  <a:srgbClr val="00E5FF"/>
                 </a:solidFill>
                 <a:latin typeface="Segoe UI"/>
               </a:defRPr>
             </a:pPr>
             <a:r>
-              <a:t>CLOUD CONNECT — HOWARD 2026 | AWS × MLU × BEN TECH</a:t>
+              <a:t>CLOUD CONNECT 2026 · AWS × MLU × BEN TECH · HOWARD UNIVERSITY</a:t>
             </a:r>
           </a:p>
         </p:txBody>
@@ -3919,8 +3963,8 @@
         </p:nvSpPr>
         <p:spPr>
           <a:xfrm>
-            <a:off x="731520" y="1463040"/>
-            <a:ext cx="10698480" cy="1280160"/>
+            <a:off x="731520" y="1115568"/>
+            <a:ext cx="7772400" cy="1371600"/>
           </a:xfrm>
           <a:prstGeom prst="rect">
             <a:avLst/>
@@ -3928,13 +3972,13 @@
           <a:noFill/>
         </p:spPr>
         <p:txBody>
-          <a:bodyPr wrap="square">
+          <a:bodyPr wrap="square" lIns="0" tIns="0" rIns="0" bIns="0">
             <a:spAutoFit/>
           </a:bodyPr>
           <a:lstStyle/>
           <a:p>
             <a:pPr>
-              <a:defRPr sz="4600" b="1">
+              <a:defRPr sz="4800" b="1">
                 <a:solidFill>
                   <a:srgbClr val="FFFFFF"/>
                 </a:solidFill>
@@ -3947,9 +3991,9 @@
           </a:p>
           <a:p>
             <a:pPr>
-              <a:defRPr sz="2000">
-                <a:solidFill>
-                  <a:srgbClr val="A855F7"/>
+              <a:defRPr sz="1900">
+                <a:solidFill>
+                  <a:srgbClr val="B464FF"/>
                 </a:solidFill>
                 <a:latin typeface="Segoe UI"/>
               </a:defRPr>
@@ -3968,18 +4012,18 @@
         </p:nvSpPr>
         <p:spPr>
           <a:xfrm>
-            <a:off x="731520" y="3108960"/>
-            <a:ext cx="3383280" cy="2926080"/>
+            <a:off x="8961120" y="594360"/>
+            <a:ext cx="2499055" cy="1920240"/>
           </a:xfrm>
           <a:prstGeom prst="roundRect">
             <a:avLst/>
           </a:prstGeom>
           <a:solidFill>
-            <a:srgbClr val="121826"/>
+            <a:srgbClr val="101622"/>
           </a:solidFill>
-          <a:ln w="15240">
+          <a:ln w="12700">
             <a:solidFill>
-              <a:srgbClr val="283855"/>
+              <a:srgbClr val="202D46"/>
             </a:solidFill>
           </a:ln>
         </p:spPr>
@@ -4005,16 +4049,40 @@
           </a:p>
         </p:txBody>
       </p:sp>
-      <p:sp>
-        <p:nvSpPr>
-          <p:cNvPr id="7" name="TextBox 6"/>
+      <p:pic>
+        <p:nvPicPr>
+          <p:cNvPr id="7" name="Picture 6" descr="prismatic_github_qr.png"/>
+          <p:cNvPicPr>
+            <a:picLocks noChangeAspect="1"/>
+          </p:cNvPicPr>
+          <p:nvPr/>
+        </p:nvPicPr>
+        <p:blipFill>
+          <a:blip r:embed="rId2"/>
+          <a:stretch>
+            <a:fillRect/>
+          </a:stretch>
+        </p:blipFill>
+        <p:spPr>
+          <a:xfrm>
+            <a:off x="9144000" y="713232"/>
+            <a:ext cx="1097280" cy="1097280"/>
+          </a:xfrm>
+          <a:prstGeom prst="rect">
+            <a:avLst/>
+          </a:prstGeom>
+        </p:spPr>
+      </p:pic>
+      <p:sp>
+        <p:nvSpPr>
+          <p:cNvPr id="8" name="TextBox 7"/>
           <p:cNvSpPr txBox="1"/>
           <p:nvPr/>
         </p:nvSpPr>
         <p:spPr>
           <a:xfrm>
-            <a:off x="960120" y="3383280"/>
-            <a:ext cx="2926080" cy="457200"/>
+            <a:off x="10332720" y="749808"/>
+            <a:ext cx="1051560" cy="1097280"/>
           </a:xfrm>
           <a:prstGeom prst="rect">
             <a:avLst/>
@@ -4022,117 +4090,58 @@
           <a:noFill/>
         </p:spPr>
         <p:txBody>
-          <a:bodyPr wrap="none">
+          <a:bodyPr wrap="square" lIns="0" tIns="0" rIns="0" bIns="0">
             <a:spAutoFit/>
           </a:bodyPr>
           <a:lstStyle/>
           <a:p>
             <a:pPr>
-              <a:defRPr sz="1600" b="1">
-                <a:solidFill>
-                  <a:srgbClr val="F43F5E"/>
+              <a:defRPr sz="1000" b="1">
+                <a:solidFill>
+                  <a:srgbClr val="00E5FF"/>
                 </a:solidFill>
                 <a:latin typeface="Segoe UI"/>
               </a:defRPr>
             </a:pPr>
             <a:r>
-              <a:t>300 STUDENTS, 1 FORMAT</a:t>
-            </a:r>
-          </a:p>
-        </p:txBody>
-      </p:sp>
-      <p:sp>
-        <p:nvSpPr>
-          <p:cNvPr id="8" name="TextBox 7"/>
-          <p:cNvSpPr txBox="1"/>
-          <p:nvPr/>
-        </p:nvSpPr>
-        <p:spPr>
-          <a:xfrm>
-            <a:off x="960120" y="3886200"/>
-            <a:ext cx="2926080" cy="365760"/>
-          </a:xfrm>
-          <a:prstGeom prst="rect">
-            <a:avLst/>
-          </a:prstGeom>
-          <a:noFill/>
-        </p:spPr>
-        <p:txBody>
-          <a:bodyPr wrap="none">
-            <a:spAutoFit/>
-          </a:bodyPr>
-          <a:lstStyle/>
+              <a:t>SCAN TO VIEW</a:t>
+            </a:r>
+          </a:p>
           <a:p>
             <a:pPr>
-              <a:defRPr sz="1300" b="1">
-                <a:solidFill>
-                  <a:srgbClr val="FFFFFF"/>
+              <a:defRPr sz="850">
+                <a:solidFill>
+                  <a:srgbClr val="94A3B8"/>
                 </a:solidFill>
                 <a:latin typeface="Segoe UI"/>
               </a:defRPr>
             </a:pPr>
             <a:r>
-              <a:t>Lecture Hall Asymmetry</a:t>
-            </a:r>
-          </a:p>
-        </p:txBody>
-      </p:sp>
-      <p:sp>
-        <p:nvSpPr>
-          <p:cNvPr id="9" name="TextBox 8"/>
-          <p:cNvSpPr txBox="1"/>
-          <p:nvPr/>
-        </p:nvSpPr>
-        <p:spPr>
-          <a:xfrm>
-            <a:off x="960120" y="4343400"/>
-            <a:ext cx="2926080" cy="1280160"/>
-          </a:xfrm>
-          <a:prstGeom prst="rect">
-            <a:avLst/>
-          </a:prstGeom>
-          <a:noFill/>
-        </p:spPr>
-        <p:txBody>
-          <a:bodyPr wrap="none">
-            <a:spAutoFit/>
-          </a:bodyPr>
-          <a:lstStyle/>
-          <a:p>
-            <a:pPr>
-              <a:defRPr sz="1150">
-                <a:solidFill>
-                  <a:srgbClr val="94A3B8"/>
-                </a:solidFill>
-                <a:latin typeface="Segoe UI"/>
-              </a:defRPr>
-            </a:pPr>
-            <a:r>
-              <a:t>Professors teach one way. Half the room absorbs it; the other half walks out with intense brain fog.</a:t>
-            </a:r>
-          </a:p>
-        </p:txBody>
-      </p:sp>
-      <p:sp>
-        <p:nvSpPr>
-          <p:cNvPr id="10" name="Rounded Rectangle 9"/>
+              <a:t>Live GitHub repo, prompts, and Quick specs.</a:t>
+            </a:r>
+          </a:p>
+        </p:txBody>
+      </p:sp>
+      <p:sp>
+        <p:nvSpPr>
+          <p:cNvPr id="9" name="Rounded Rectangle 8"/>
           <p:cNvSpPr/>
           <p:nvPr/>
         </p:nvSpPr>
         <p:spPr>
           <a:xfrm>
-            <a:off x="4389120" y="3108960"/>
-            <a:ext cx="3383280" cy="2926080"/>
+            <a:off x="731520" y="2697480"/>
+            <a:ext cx="3383280" cy="3749039"/>
           </a:xfrm>
           <a:prstGeom prst="roundRect">
             <a:avLst/>
           </a:prstGeom>
           <a:solidFill>
-            <a:srgbClr val="121826"/>
+            <a:srgbClr val="101622"/>
           </a:solidFill>
-          <a:ln w="15240">
+          <a:ln w="17780">
             <a:solidFill>
-              <a:srgbClr val="283855"/>
+              <a:srgbClr val="00E5FF"/>
             </a:solidFill>
           </a:ln>
         </p:spPr>
@@ -4160,132 +4169,24 @@
       </p:sp>
       <p:sp>
         <p:nvSpPr>
-          <p:cNvPr id="11" name="TextBox 10"/>
-          <p:cNvSpPr txBox="1"/>
-          <p:nvPr/>
-        </p:nvSpPr>
-        <p:spPr>
-          <a:xfrm>
-            <a:off x="4617720" y="3383280"/>
-            <a:ext cx="2926080" cy="457200"/>
-          </a:xfrm>
-          <a:prstGeom prst="rect">
-            <a:avLst/>
-          </a:prstGeom>
-          <a:noFill/>
-        </p:spPr>
-        <p:txBody>
-          <a:bodyPr wrap="none">
-            <a:spAutoFit/>
-          </a:bodyPr>
-          <a:lstStyle/>
-          <a:p>
-            <a:pPr>
-              <a:defRPr sz="1600" b="1">
-                <a:solidFill>
-                  <a:srgbClr val="F59E0B"/>
-                </a:solidFill>
-                <a:latin typeface="Segoe UI"/>
-              </a:defRPr>
-            </a:pPr>
-            <a:r>
-              <a:t>78% TASK PARALYSIS</a:t>
-            </a:r>
-          </a:p>
-        </p:txBody>
-      </p:sp>
-      <p:sp>
-        <p:nvSpPr>
-          <p:cNvPr id="12" name="TextBox 11"/>
-          <p:cNvSpPr txBox="1"/>
-          <p:nvPr/>
-        </p:nvSpPr>
-        <p:spPr>
-          <a:xfrm>
-            <a:off x="4617720" y="3886200"/>
-            <a:ext cx="2926080" cy="365760"/>
-          </a:xfrm>
-          <a:prstGeom prst="rect">
-            <a:avLst/>
-          </a:prstGeom>
-          <a:noFill/>
-        </p:spPr>
-        <p:txBody>
-          <a:bodyPr wrap="none">
-            <a:spAutoFit/>
-          </a:bodyPr>
-          <a:lstStyle/>
-          <a:p>
-            <a:pPr>
-              <a:defRPr sz="1300" b="1">
-                <a:solidFill>
-                  <a:srgbClr val="FFFFFF"/>
-                </a:solidFill>
-                <a:latin typeface="Segoe UI"/>
-              </a:defRPr>
-            </a:pPr>
-            <a:r>
-              <a:t>The 2026 Reality</a:t>
-            </a:r>
-          </a:p>
-        </p:txBody>
-      </p:sp>
-      <p:sp>
-        <p:nvSpPr>
-          <p:cNvPr id="13" name="TextBox 12"/>
-          <p:cNvSpPr txBox="1"/>
-          <p:nvPr/>
-        </p:nvSpPr>
-        <p:spPr>
-          <a:xfrm>
-            <a:off x="4617720" y="4343400"/>
-            <a:ext cx="2926080" cy="1280160"/>
-          </a:xfrm>
-          <a:prstGeom prst="rect">
-            <a:avLst/>
-          </a:prstGeom>
-          <a:noFill/>
-        </p:spPr>
-        <p:txBody>
-          <a:bodyPr wrap="none">
-            <a:spAutoFit/>
-          </a:bodyPr>
-          <a:lstStyle/>
-          <a:p>
-            <a:pPr>
-              <a:defRPr sz="1150">
-                <a:solidFill>
-                  <a:srgbClr val="94A3B8"/>
-                </a:solidFill>
-                <a:latin typeface="Segoe UI"/>
-              </a:defRPr>
-            </a:pPr>
-            <a:r>
-              <a:t>Students don't fail from lack of intellect; they freeze when staring at 40-page PDFs with zero cognitive adaptation.</a:t>
-            </a:r>
-          </a:p>
-        </p:txBody>
-      </p:sp>
-      <p:sp>
-        <p:nvSpPr>
-          <p:cNvPr id="14" name="Rounded Rectangle 13"/>
+          <p:cNvPr id="10" name="Rounded Rectangle 9"/>
           <p:cNvSpPr/>
           <p:nvPr/>
         </p:nvSpPr>
         <p:spPr>
           <a:xfrm>
-            <a:off x="8046720" y="3108960"/>
-            <a:ext cx="3383280" cy="2926080"/>
+            <a:off x="1005840" y="3017520"/>
+            <a:ext cx="2011680" cy="292608"/>
           </a:xfrm>
           <a:prstGeom prst="roundRect">
             <a:avLst/>
           </a:prstGeom>
           <a:solidFill>
-            <a:srgbClr val="121826"/>
+            <a:srgbClr val="161E30"/>
           </a:solidFill>
-          <a:ln w="15240">
+          <a:ln w="12700">
             <a:solidFill>
-              <a:srgbClr val="283855"/>
+              <a:srgbClr val="00E5FF"/>
             </a:solidFill>
           </a:ln>
         </p:spPr>
@@ -4313,14 +4214,14 @@
       </p:sp>
       <p:sp>
         <p:nvSpPr>
-          <p:cNvPr id="15" name="TextBox 14"/>
+          <p:cNvPr id="11" name="TextBox 10"/>
           <p:cNvSpPr txBox="1"/>
           <p:nvPr/>
         </p:nvSpPr>
         <p:spPr>
           <a:xfrm>
-            <a:off x="8275320" y="3383280"/>
-            <a:ext cx="2926080" cy="457200"/>
+            <a:off x="1051560" y="3054096"/>
+            <a:ext cx="1920240" cy="228600"/>
           </a:xfrm>
           <a:prstGeom prst="rect">
             <a:avLst/>
@@ -4334,29 +4235,29 @@
           <a:lstStyle/>
           <a:p>
             <a:pPr>
-              <a:defRPr sz="1600" b="1">
-                <a:solidFill>
-                  <a:srgbClr val="10B981"/>
+              <a:defRPr sz="900" b="1">
+                <a:solidFill>
+                  <a:srgbClr val="00E5FF"/>
                 </a:solidFill>
                 <a:latin typeface="Segoe UI"/>
               </a:defRPr>
             </a:pPr>
             <a:r>
-              <a:t>&lt; 30 SEC DIAGNOSTIC</a:t>
-            </a:r>
-          </a:p>
-        </p:txBody>
-      </p:sp>
-      <p:sp>
-        <p:nvSpPr>
-          <p:cNvPr id="16" name="TextBox 15"/>
+              <a:t>TEAM ENERGY</a:t>
+            </a:r>
+          </a:p>
+        </p:txBody>
+      </p:sp>
+      <p:sp>
+        <p:nvSpPr>
+          <p:cNvPr id="12" name="TextBox 11"/>
           <p:cNvSpPr txBox="1"/>
           <p:nvPr/>
         </p:nvSpPr>
         <p:spPr>
           <a:xfrm>
-            <a:off x="8275320" y="3886200"/>
-            <a:ext cx="2926080" cy="365760"/>
+            <a:off x="1005840" y="3474720"/>
+            <a:ext cx="2834640" cy="320040"/>
           </a:xfrm>
           <a:prstGeom prst="rect">
             <a:avLst/>
@@ -4370,29 +4271,29 @@
           <a:lstStyle/>
           <a:p>
             <a:pPr>
-              <a:defRPr sz="1300" b="1">
-                <a:solidFill>
-                  <a:srgbClr val="FFFFFF"/>
+              <a:defRPr sz="1200" b="1">
+                <a:solidFill>
+                  <a:srgbClr val="00E5FF"/>
                 </a:solidFill>
                 <a:latin typeface="Segoe UI"/>
               </a:defRPr>
             </a:pPr>
             <a:r>
-              <a:t>The Prismatic Answer</a:t>
-            </a:r>
-          </a:p>
-        </p:txBody>
-      </p:sp>
-      <p:sp>
-        <p:nvSpPr>
-          <p:cNvPr id="17" name="TextBox 16"/>
+              <a:t>SEGMENT 1: 10 SECONDS</a:t>
+            </a:r>
+          </a:p>
+        </p:txBody>
+      </p:sp>
+      <p:sp>
+        <p:nvSpPr>
+          <p:cNvPr id="13" name="TextBox 12"/>
           <p:cNvSpPr txBox="1"/>
           <p:nvPr/>
         </p:nvSpPr>
         <p:spPr>
           <a:xfrm>
-            <a:off x="8275320" y="4343400"/>
-            <a:ext cx="2926080" cy="1280160"/>
+            <a:off x="1005840" y="3840480"/>
+            <a:ext cx="2834640" cy="411480"/>
           </a:xfrm>
           <a:prstGeom prst="rect">
             <a:avLst/>
@@ -4406,7 +4307,43 @@
           <a:lstStyle/>
           <a:p>
             <a:pPr>
-              <a:defRPr sz="1150">
+              <a:defRPr sz="1500" b="1">
+                <a:solidFill>
+                  <a:srgbClr val="FFFFFF"/>
+                </a:solidFill>
+                <a:latin typeface="Segoe UI"/>
+              </a:defRPr>
+            </a:pPr>
+            <a:r>
+              <a:t>High-Energy Intro</a:t>
+            </a:r>
+          </a:p>
+        </p:txBody>
+      </p:sp>
+      <p:sp>
+        <p:nvSpPr>
+          <p:cNvPr id="14" name="TextBox 13"/>
+          <p:cNvSpPr txBox="1"/>
+          <p:nvPr/>
+        </p:nvSpPr>
+        <p:spPr>
+          <a:xfrm>
+            <a:off x="1005840" y="4389120"/>
+            <a:ext cx="2834640" cy="1828800"/>
+          </a:xfrm>
+          <a:prstGeom prst="rect">
+            <a:avLst/>
+          </a:prstGeom>
+          <a:noFill/>
+        </p:spPr>
+        <p:txBody>
+          <a:bodyPr wrap="none">
+            <a:spAutoFit/>
+          </a:bodyPr>
+          <a:lstStyle/>
+          <a:p>
+            <a:pPr>
+              <a:defRPr sz="1200">
                 <a:solidFill>
                   <a:srgbClr val="94A3B8"/>
                 </a:solidFill>
@@ -4414,7 +4351,475 @@
               </a:defRPr>
             </a:pPr>
             <a:r>
-              <a:t>5 scenario questions map your cognitive profile and refract any topic into 4 personalized learning modalities.</a:t>
+              <a:t>We are Prismatic — 10 builders solving college cognitive overload.</a:t>
+            </a:r>
+          </a:p>
+        </p:txBody>
+      </p:sp>
+      <p:sp>
+        <p:nvSpPr>
+          <p:cNvPr id="15" name="Rounded Rectangle 14"/>
+          <p:cNvSpPr/>
+          <p:nvPr/>
+        </p:nvSpPr>
+        <p:spPr>
+          <a:xfrm>
+            <a:off x="4389120" y="2697480"/>
+            <a:ext cx="3383280" cy="3749039"/>
+          </a:xfrm>
+          <a:prstGeom prst="roundRect">
+            <a:avLst/>
+          </a:prstGeom>
+          <a:solidFill>
+            <a:srgbClr val="101622"/>
+          </a:solidFill>
+          <a:ln w="12700">
+            <a:solidFill>
+              <a:srgbClr val="202D46"/>
+            </a:solidFill>
+          </a:ln>
+        </p:spPr>
+        <p:style>
+          <a:lnRef idx="1">
+            <a:schemeClr val="accent1"/>
+          </a:lnRef>
+          <a:fillRef idx="3">
+            <a:schemeClr val="accent1"/>
+          </a:fillRef>
+          <a:effectRef idx="2">
+            <a:schemeClr val="accent1"/>
+          </a:effectRef>
+          <a:fontRef idx="minor">
+            <a:schemeClr val="lt1"/>
+          </a:fontRef>
+        </p:style>
+        <p:txBody>
+          <a:bodyPr rtlCol="0" anchor="ctr"/>
+          <a:lstStyle/>
+          <a:p>
+            <a:pPr algn="ctr"/>
+          </a:p>
+        </p:txBody>
+      </p:sp>
+      <p:sp>
+        <p:nvSpPr>
+          <p:cNvPr id="16" name="Rounded Rectangle 15"/>
+          <p:cNvSpPr/>
+          <p:nvPr/>
+        </p:nvSpPr>
+        <p:spPr>
+          <a:xfrm>
+            <a:off x="4663440" y="3017520"/>
+            <a:ext cx="2011680" cy="292608"/>
+          </a:xfrm>
+          <a:prstGeom prst="roundRect">
+            <a:avLst/>
+          </a:prstGeom>
+          <a:solidFill>
+            <a:srgbClr val="161E30"/>
+          </a:solidFill>
+          <a:ln w="12700">
+            <a:solidFill>
+              <a:srgbClr val="FF6B6B"/>
+            </a:solidFill>
+          </a:ln>
+        </p:spPr>
+        <p:style>
+          <a:lnRef idx="1">
+            <a:schemeClr val="accent1"/>
+          </a:lnRef>
+          <a:fillRef idx="3">
+            <a:schemeClr val="accent1"/>
+          </a:fillRef>
+          <a:effectRef idx="2">
+            <a:schemeClr val="accent1"/>
+          </a:effectRef>
+          <a:fontRef idx="minor">
+            <a:schemeClr val="lt1"/>
+          </a:fontRef>
+        </p:style>
+        <p:txBody>
+          <a:bodyPr rtlCol="0" anchor="ctr"/>
+          <a:lstStyle/>
+          <a:p>
+            <a:pPr algn="ctr"/>
+          </a:p>
+        </p:txBody>
+      </p:sp>
+      <p:sp>
+        <p:nvSpPr>
+          <p:cNvPr id="17" name="TextBox 16"/>
+          <p:cNvSpPr txBox="1"/>
+          <p:nvPr/>
+        </p:nvSpPr>
+        <p:spPr>
+          <a:xfrm>
+            <a:off x="4709160" y="3054096"/>
+            <a:ext cx="1920240" cy="228600"/>
+          </a:xfrm>
+          <a:prstGeom prst="rect">
+            <a:avLst/>
+          </a:prstGeom>
+          <a:noFill/>
+        </p:spPr>
+        <p:txBody>
+          <a:bodyPr wrap="none">
+            <a:spAutoFit/>
+          </a:bodyPr>
+          <a:lstStyle/>
+          <a:p>
+            <a:pPr>
+              <a:defRPr sz="900" b="1">
+                <a:solidFill>
+                  <a:srgbClr val="FF6B6B"/>
+                </a:solidFill>
+                <a:latin typeface="Segoe UI"/>
+              </a:defRPr>
+            </a:pPr>
+            <a:r>
+              <a:t>THE CRISIS</a:t>
+            </a:r>
+          </a:p>
+        </p:txBody>
+      </p:sp>
+      <p:sp>
+        <p:nvSpPr>
+          <p:cNvPr id="18" name="TextBox 17"/>
+          <p:cNvSpPr txBox="1"/>
+          <p:nvPr/>
+        </p:nvSpPr>
+        <p:spPr>
+          <a:xfrm>
+            <a:off x="4663440" y="3474720"/>
+            <a:ext cx="2834640" cy="320040"/>
+          </a:xfrm>
+          <a:prstGeom prst="rect">
+            <a:avLst/>
+          </a:prstGeom>
+          <a:noFill/>
+        </p:spPr>
+        <p:txBody>
+          <a:bodyPr wrap="none">
+            <a:spAutoFit/>
+          </a:bodyPr>
+          <a:lstStyle/>
+          <a:p>
+            <a:pPr>
+              <a:defRPr sz="1200" b="1">
+                <a:solidFill>
+                  <a:srgbClr val="FF6B6B"/>
+                </a:solidFill>
+                <a:latin typeface="Segoe UI"/>
+              </a:defRPr>
+            </a:pPr>
+            <a:r>
+              <a:t>SEGMENT 2: 25 SECONDS</a:t>
+            </a:r>
+          </a:p>
+        </p:txBody>
+      </p:sp>
+      <p:sp>
+        <p:nvSpPr>
+          <p:cNvPr id="19" name="TextBox 18"/>
+          <p:cNvSpPr txBox="1"/>
+          <p:nvPr/>
+        </p:nvSpPr>
+        <p:spPr>
+          <a:xfrm>
+            <a:off x="4663440" y="3840480"/>
+            <a:ext cx="2834640" cy="411480"/>
+          </a:xfrm>
+          <a:prstGeom prst="rect">
+            <a:avLst/>
+          </a:prstGeom>
+          <a:noFill/>
+        </p:spPr>
+        <p:txBody>
+          <a:bodyPr wrap="none">
+            <a:spAutoFit/>
+          </a:bodyPr>
+          <a:lstStyle/>
+          <a:p>
+            <a:pPr>
+              <a:defRPr sz="1500" b="1">
+                <a:solidFill>
+                  <a:srgbClr val="FFFFFF"/>
+                </a:solidFill>
+                <a:latin typeface="Segoe UI"/>
+              </a:defRPr>
+            </a:pPr>
+            <a:r>
+              <a:t>The 300-Student Hook</a:t>
+            </a:r>
+          </a:p>
+        </p:txBody>
+      </p:sp>
+      <p:sp>
+        <p:nvSpPr>
+          <p:cNvPr id="20" name="TextBox 19"/>
+          <p:cNvSpPr txBox="1"/>
+          <p:nvPr/>
+        </p:nvSpPr>
+        <p:spPr>
+          <a:xfrm>
+            <a:off x="4663440" y="4389120"/>
+            <a:ext cx="2834640" cy="1828800"/>
+          </a:xfrm>
+          <a:prstGeom prst="rect">
+            <a:avLst/>
+          </a:prstGeom>
+          <a:noFill/>
+        </p:spPr>
+        <p:txBody>
+          <a:bodyPr wrap="none">
+            <a:spAutoFit/>
+          </a:bodyPr>
+          <a:lstStyle/>
+          <a:p>
+            <a:pPr>
+              <a:defRPr sz="1200">
+                <a:solidFill>
+                  <a:srgbClr val="94A3B8"/>
+                </a:solidFill>
+                <a:latin typeface="Segoe UI"/>
+              </a:defRPr>
+            </a:pPr>
+            <a:r>
+              <a:t>1 professor. 300 students. 1 static format. White light has every color, but lectures project only one shade.</a:t>
+            </a:r>
+          </a:p>
+        </p:txBody>
+      </p:sp>
+      <p:sp>
+        <p:nvSpPr>
+          <p:cNvPr id="21" name="Rounded Rectangle 20"/>
+          <p:cNvSpPr/>
+          <p:nvPr/>
+        </p:nvSpPr>
+        <p:spPr>
+          <a:xfrm>
+            <a:off x="8046720" y="2697480"/>
+            <a:ext cx="3383280" cy="3749039"/>
+          </a:xfrm>
+          <a:prstGeom prst="roundRect">
+            <a:avLst/>
+          </a:prstGeom>
+          <a:solidFill>
+            <a:srgbClr val="101622"/>
+          </a:solidFill>
+          <a:ln w="17780">
+            <a:solidFill>
+              <a:srgbClr val="10B981"/>
+            </a:solidFill>
+          </a:ln>
+        </p:spPr>
+        <p:style>
+          <a:lnRef idx="1">
+            <a:schemeClr val="accent1"/>
+          </a:lnRef>
+          <a:fillRef idx="3">
+            <a:schemeClr val="accent1"/>
+          </a:fillRef>
+          <a:effectRef idx="2">
+            <a:schemeClr val="accent1"/>
+          </a:effectRef>
+          <a:fontRef idx="minor">
+            <a:schemeClr val="lt1"/>
+          </a:fontRef>
+        </p:style>
+        <p:txBody>
+          <a:bodyPr rtlCol="0" anchor="ctr"/>
+          <a:lstStyle/>
+          <a:p>
+            <a:pPr algn="ctr"/>
+          </a:p>
+        </p:txBody>
+      </p:sp>
+      <p:sp>
+        <p:nvSpPr>
+          <p:cNvPr id="22" name="Rounded Rectangle 21"/>
+          <p:cNvSpPr/>
+          <p:nvPr/>
+        </p:nvSpPr>
+        <p:spPr>
+          <a:xfrm>
+            <a:off x="8321040" y="3017520"/>
+            <a:ext cx="2011680" cy="292608"/>
+          </a:xfrm>
+          <a:prstGeom prst="roundRect">
+            <a:avLst/>
+          </a:prstGeom>
+          <a:solidFill>
+            <a:srgbClr val="161E30"/>
+          </a:solidFill>
+          <a:ln w="12700">
+            <a:solidFill>
+              <a:srgbClr val="34D399"/>
+            </a:solidFill>
+          </a:ln>
+        </p:spPr>
+        <p:style>
+          <a:lnRef idx="1">
+            <a:schemeClr val="accent1"/>
+          </a:lnRef>
+          <a:fillRef idx="3">
+            <a:schemeClr val="accent1"/>
+          </a:fillRef>
+          <a:effectRef idx="2">
+            <a:schemeClr val="accent1"/>
+          </a:effectRef>
+          <a:fontRef idx="minor">
+            <a:schemeClr val="lt1"/>
+          </a:fontRef>
+        </p:style>
+        <p:txBody>
+          <a:bodyPr rtlCol="0" anchor="ctr"/>
+          <a:lstStyle/>
+          <a:p>
+            <a:pPr algn="ctr"/>
+          </a:p>
+        </p:txBody>
+      </p:sp>
+      <p:sp>
+        <p:nvSpPr>
+          <p:cNvPr id="23" name="TextBox 22"/>
+          <p:cNvSpPr txBox="1"/>
+          <p:nvPr/>
+        </p:nvSpPr>
+        <p:spPr>
+          <a:xfrm>
+            <a:off x="8366760" y="3054096"/>
+            <a:ext cx="1920240" cy="228600"/>
+          </a:xfrm>
+          <a:prstGeom prst="rect">
+            <a:avLst/>
+          </a:prstGeom>
+          <a:noFill/>
+        </p:spPr>
+        <p:txBody>
+          <a:bodyPr wrap="none">
+            <a:spAutoFit/>
+          </a:bodyPr>
+          <a:lstStyle/>
+          <a:p>
+            <a:pPr>
+              <a:defRPr sz="900" b="1">
+                <a:solidFill>
+                  <a:srgbClr val="34D399"/>
+                </a:solidFill>
+                <a:latin typeface="Segoe UI"/>
+              </a:defRPr>
+            </a:pPr>
+            <a:r>
+              <a:t>THE CORE MISSION</a:t>
+            </a:r>
+          </a:p>
+        </p:txBody>
+      </p:sp>
+      <p:sp>
+        <p:nvSpPr>
+          <p:cNvPr id="24" name="TextBox 23"/>
+          <p:cNvSpPr txBox="1"/>
+          <p:nvPr/>
+        </p:nvSpPr>
+        <p:spPr>
+          <a:xfrm>
+            <a:off x="8321040" y="3474720"/>
+            <a:ext cx="2834640" cy="320040"/>
+          </a:xfrm>
+          <a:prstGeom prst="rect">
+            <a:avLst/>
+          </a:prstGeom>
+          <a:noFill/>
+        </p:spPr>
+        <p:txBody>
+          <a:bodyPr wrap="none">
+            <a:spAutoFit/>
+          </a:bodyPr>
+          <a:lstStyle/>
+          <a:p>
+            <a:pPr>
+              <a:defRPr sz="1200" b="1">
+                <a:solidFill>
+                  <a:srgbClr val="34D399"/>
+                </a:solidFill>
+                <a:latin typeface="Segoe UI"/>
+              </a:defRPr>
+            </a:pPr>
+            <a:r>
+              <a:t>THE EMOTIONAL TRUTH</a:t>
+            </a:r>
+          </a:p>
+        </p:txBody>
+      </p:sp>
+      <p:sp>
+        <p:nvSpPr>
+          <p:cNvPr id="25" name="TextBox 24"/>
+          <p:cNvSpPr txBox="1"/>
+          <p:nvPr/>
+        </p:nvSpPr>
+        <p:spPr>
+          <a:xfrm>
+            <a:off x="8321040" y="3840480"/>
+            <a:ext cx="2834640" cy="411480"/>
+          </a:xfrm>
+          <a:prstGeom prst="rect">
+            <a:avLst/>
+          </a:prstGeom>
+          <a:noFill/>
+        </p:spPr>
+        <p:txBody>
+          <a:bodyPr wrap="none">
+            <a:spAutoFit/>
+          </a:bodyPr>
+          <a:lstStyle/>
+          <a:p>
+            <a:pPr>
+              <a:defRPr sz="1500" b="1">
+                <a:solidFill>
+                  <a:srgbClr val="FFFFFF"/>
+                </a:solidFill>
+                <a:latin typeface="Segoe UI"/>
+              </a:defRPr>
+            </a:pPr>
+            <a:r>
+              <a:t>Cognitive Mismatch</a:t>
+            </a:r>
+          </a:p>
+        </p:txBody>
+      </p:sp>
+      <p:sp>
+        <p:nvSpPr>
+          <p:cNvPr id="26" name="TextBox 25"/>
+          <p:cNvSpPr txBox="1"/>
+          <p:nvPr/>
+        </p:nvSpPr>
+        <p:spPr>
+          <a:xfrm>
+            <a:off x="8321040" y="4389120"/>
+            <a:ext cx="2834640" cy="1828800"/>
+          </a:xfrm>
+          <a:prstGeom prst="rect">
+            <a:avLst/>
+          </a:prstGeom>
+          <a:noFill/>
+        </p:spPr>
+        <p:txBody>
+          <a:bodyPr wrap="none">
+            <a:spAutoFit/>
+          </a:bodyPr>
+          <a:lstStyle/>
+          <a:p>
+            <a:pPr>
+              <a:defRPr sz="1200">
+                <a:solidFill>
+                  <a:srgbClr val="94A3B8"/>
+                </a:solidFill>
+                <a:latin typeface="Segoe UI"/>
+              </a:defRPr>
+            </a:pPr>
+            <a:r>
+              <a:t>Students don't freeze from lack of intelligence; they freeze when raw syllabus format clashes with their brain.</a:t>
             </a:r>
           </a:p>
         </p:txBody>
@@ -4452,7 +4857,7 @@
             <a:avLst/>
           </a:prstGeom>
           <a:solidFill>
-            <a:srgbClr val="0B0F19"/>
+            <a:srgbClr val="080B13"/>
           </a:solidFill>
           <a:ln>
             <a:noFill/>
@@ -4488,8 +4893,8 @@
         </p:nvSpPr>
         <p:spPr>
           <a:xfrm>
-            <a:off x="731520" y="365760"/>
-            <a:ext cx="10698480" cy="320040"/>
+            <a:off x="731520" y="347472"/>
+            <a:ext cx="8229600" cy="292608"/>
           </a:xfrm>
           <a:prstGeom prst="rect">
             <a:avLst/>
@@ -4505,109 +4910,37 @@
             <a:pPr>
               <a:defRPr sz="1100" b="1">
                 <a:solidFill>
-                  <a:srgbClr val="00D4FF"/>
+                  <a:srgbClr val="00E5FF"/>
                 </a:solidFill>
                 <a:latin typeface="Segoe UI"/>
               </a:defRPr>
             </a:pPr>
             <a:r>
-              <a:t>SYSTEM ARCHITECTURE</a:t>
-            </a:r>
-          </a:p>
-        </p:txBody>
-      </p:sp>
-      <p:sp>
-        <p:nvSpPr>
-          <p:cNvPr id="4" name="TextBox 3"/>
-          <p:cNvSpPr txBox="1"/>
-          <p:nvPr/>
-        </p:nvSpPr>
-        <p:spPr>
-          <a:xfrm>
-            <a:off x="731520" y="685800"/>
-            <a:ext cx="10698480" cy="502920"/>
-          </a:xfrm>
-          <a:prstGeom prst="rect">
-            <a:avLst/>
-          </a:prstGeom>
-          <a:noFill/>
-        </p:spPr>
-        <p:txBody>
-          <a:bodyPr wrap="square" lIns="0" tIns="0" rIns="0" bIns="0">
-            <a:spAutoFit/>
-          </a:bodyPr>
-          <a:lstStyle/>
-          <a:p>
-            <a:pPr>
-              <a:defRPr sz="2200" b="1">
-                <a:solidFill>
-                  <a:srgbClr val="FFFFFF"/>
-                </a:solidFill>
-                <a:latin typeface="Segoe UI"/>
-              </a:defRPr>
-            </a:pPr>
-            <a:r>
-              <a:t>The Cognitive Prism Engine: Ingest, Diagnose &amp; Refract</a:t>
-            </a:r>
-          </a:p>
-        </p:txBody>
-      </p:sp>
-      <p:sp>
-        <p:nvSpPr>
-          <p:cNvPr id="5" name="TextBox 4"/>
-          <p:cNvSpPr txBox="1"/>
-          <p:nvPr/>
-        </p:nvSpPr>
-        <p:spPr>
-          <a:xfrm>
-            <a:off x="731520" y="1234440"/>
-            <a:ext cx="10698480" cy="320040"/>
-          </a:xfrm>
-          <a:prstGeom prst="rect">
-            <a:avLst/>
-          </a:prstGeom>
-          <a:noFill/>
-        </p:spPr>
-        <p:txBody>
-          <a:bodyPr wrap="square" lIns="0" tIns="0" rIns="0" bIns="0">
-            <a:spAutoFit/>
-          </a:bodyPr>
-          <a:lstStyle/>
-          <a:p>
-            <a:pPr>
-              <a:defRPr sz="1200">
-                <a:solidFill>
-                  <a:srgbClr val="94A3B8"/>
-                </a:solidFill>
-                <a:latin typeface="Segoe UI"/>
-              </a:defRPr>
-            </a:pPr>
-            <a:r>
-              <a:t>Engineered in 60 minutes on Amazon Quick with agentic multi-widget pipeline orchestration</a:t>
-            </a:r>
-          </a:p>
-        </p:txBody>
-      </p:sp>
-      <p:sp>
-        <p:nvSpPr>
-          <p:cNvPr id="6" name="Rounded Rectangle 5"/>
+              <a:t>SEGMENT 3: APP OVERVIEW (45S)</a:t>
+            </a:r>
+          </a:p>
+        </p:txBody>
+      </p:sp>
+      <p:sp>
+        <p:nvSpPr>
+          <p:cNvPr id="4" name="Rounded Rectangle 3"/>
           <p:cNvSpPr/>
           <p:nvPr/>
         </p:nvSpPr>
         <p:spPr>
           <a:xfrm>
-            <a:off x="731520" y="1691640"/>
-            <a:ext cx="3383280" cy="4480560"/>
+            <a:off x="9448495" y="320040"/>
+            <a:ext cx="2011680" cy="347472"/>
           </a:xfrm>
           <a:prstGeom prst="roundRect">
             <a:avLst/>
           </a:prstGeom>
           <a:solidFill>
-            <a:srgbClr val="121826"/>
+            <a:srgbClr val="161E30"/>
           </a:solidFill>
           <a:ln w="15240">
             <a:solidFill>
-              <a:srgbClr val="283855"/>
+              <a:srgbClr val="00E5FF"/>
             </a:solidFill>
           </a:ln>
         </p:spPr>
@@ -4626,23 +4959,33 @@
           </a:fontRef>
         </p:style>
         <p:txBody>
-          <a:bodyPr rtlCol="0" anchor="ctr"/>
-          <a:lstStyle/>
-          <a:p>
-            <a:pPr algn="ctr"/>
-          </a:p>
-        </p:txBody>
-      </p:sp>
-      <p:sp>
-        <p:nvSpPr>
-          <p:cNvPr id="7" name="TextBox 6"/>
+          <a:bodyPr rtlCol="0" anchor="ctr" lIns="0" rIns="0" tIns="0" bIns="0"/>
+          <a:lstStyle/>
+          <a:p>
+            <a:pPr algn="ctr">
+              <a:defRPr sz="1000" b="1">
+                <a:solidFill>
+                  <a:srgbClr val="00E5FF"/>
+                </a:solidFill>
+                <a:latin typeface="Segoe UI"/>
+              </a:defRPr>
+            </a:pPr>
+            <a:r>
+              <a:t>45 SECONDS</a:t>
+            </a:r>
+          </a:p>
+        </p:txBody>
+      </p:sp>
+      <p:sp>
+        <p:nvSpPr>
+          <p:cNvPr id="5" name="TextBox 4"/>
           <p:cNvSpPr txBox="1"/>
           <p:nvPr/>
         </p:nvSpPr>
         <p:spPr>
           <a:xfrm>
-            <a:off x="1005840" y="2057400"/>
-            <a:ext cx="2834640" cy="365760"/>
+            <a:off x="731520" y="658368"/>
+            <a:ext cx="10728655" cy="502920"/>
           </a:xfrm>
           <a:prstGeom prst="rect">
             <a:avLst/>
@@ -4650,35 +4993,35 @@
           <a:noFill/>
         </p:spPr>
         <p:txBody>
-          <a:bodyPr wrap="none">
+          <a:bodyPr wrap="square" lIns="0" tIns="0" rIns="0" bIns="0">
             <a:spAutoFit/>
           </a:bodyPr>
           <a:lstStyle/>
           <a:p>
             <a:pPr>
-              <a:defRPr sz="1400" b="1">
-                <a:solidFill>
-                  <a:srgbClr val="00D4FF"/>
+              <a:defRPr sz="2300" b="1">
+                <a:solidFill>
+                  <a:srgbClr val="FFFFFF"/>
                 </a:solidFill>
                 <a:latin typeface="Segoe UI"/>
               </a:defRPr>
             </a:pPr>
             <a:r>
-              <a:t>STEP 1: INGEST</a:t>
-            </a:r>
-          </a:p>
-        </p:txBody>
-      </p:sp>
-      <p:sp>
-        <p:nvSpPr>
-          <p:cNvPr id="8" name="TextBox 7"/>
+              <a:t>The 4 Refracted Learning Spectrums: Zero Errors, Pure Retention</a:t>
+            </a:r>
+          </a:p>
+        </p:txBody>
+      </p:sp>
+      <p:sp>
+        <p:nvSpPr>
+          <p:cNvPr id="6" name="TextBox 5"/>
           <p:cNvSpPr txBox="1"/>
           <p:nvPr/>
         </p:nvSpPr>
         <p:spPr>
           <a:xfrm>
-            <a:off x="1005840" y="2514600"/>
-            <a:ext cx="2834640" cy="457200"/>
+            <a:off x="731520" y="1188720"/>
+            <a:ext cx="10728655" cy="320040"/>
           </a:xfrm>
           <a:prstGeom prst="rect">
             <a:avLst/>
@@ -4686,81 +5029,45 @@
           <a:noFill/>
         </p:spPr>
         <p:txBody>
-          <a:bodyPr wrap="none">
+          <a:bodyPr wrap="square" lIns="0" tIns="0" rIns="0" bIns="0">
             <a:spAutoFit/>
           </a:bodyPr>
           <a:lstStyle/>
           <a:p>
             <a:pPr>
-              <a:defRPr sz="1500" b="1">
-                <a:solidFill>
-                  <a:srgbClr val="FFFFFF"/>
+              <a:defRPr sz="1200">
+                <a:solidFill>
+                  <a:srgbClr val="94A3B8"/>
                 </a:solidFill>
                 <a:latin typeface="Segoe UI"/>
               </a:defRPr>
             </a:pPr>
             <a:r>
-              <a:t>Raw Academic Material</a:t>
-            </a:r>
-          </a:p>
-        </p:txBody>
-      </p:sp>
-      <p:sp>
-        <p:nvSpPr>
-          <p:cNvPr id="9" name="TextBox 8"/>
-          <p:cNvSpPr txBox="1"/>
-          <p:nvPr/>
-        </p:nvSpPr>
-        <p:spPr>
-          <a:xfrm>
-            <a:off x="1005840" y="3063240"/>
-            <a:ext cx="2834640" cy="2560320"/>
-          </a:xfrm>
-          <a:prstGeom prst="rect">
-            <a:avLst/>
-          </a:prstGeom>
-          <a:noFill/>
-        </p:spPr>
-        <p:txBody>
-          <a:bodyPr wrap="none">
-            <a:spAutoFit/>
-          </a:bodyPr>
-          <a:lstStyle/>
-          <a:p>
-            <a:pPr>
-              <a:defRPr sz="1200">
-                <a:solidFill>
-                  <a:srgbClr val="94A3B8"/>
-                </a:solidFill>
-                <a:latin typeface="Segoe UI"/>
-              </a:defRPr>
-            </a:pPr>
-            <a:r>
-              <a:t>Student pastes confusing lecture slides, a syllabus link, or a brutal midterm exam review sheet.</a:t>
-            </a:r>
-          </a:p>
-        </p:txBody>
-      </p:sp>
-      <p:sp>
-        <p:nvSpPr>
-          <p:cNvPr id="10" name="Rounded Rectangle 9"/>
+              <a:t>A pipelined architecture orchestrated in 60 minutes on Amazon Quick &amp; Amazon Bedrock</a:t>
+            </a:r>
+          </a:p>
+        </p:txBody>
+      </p:sp>
+      <p:sp>
+        <p:nvSpPr>
+          <p:cNvPr id="7" name="Rounded Rectangle 6"/>
           <p:cNvSpPr/>
           <p:nvPr/>
         </p:nvSpPr>
         <p:spPr>
           <a:xfrm>
-            <a:off x="4389120" y="1691640"/>
-            <a:ext cx="3383280" cy="4480560"/>
+            <a:off x="731520" y="1645920"/>
+            <a:ext cx="5212080" cy="2240280"/>
           </a:xfrm>
           <a:prstGeom prst="roundRect">
             <a:avLst/>
           </a:prstGeom>
           <a:solidFill>
-            <a:srgbClr val="121826"/>
+            <a:srgbClr val="101622"/>
           </a:solidFill>
-          <a:ln w="15240">
+          <a:ln w="16510">
             <a:solidFill>
-              <a:srgbClr val="283855"/>
+              <a:srgbClr val="00E5FF"/>
             </a:solidFill>
           </a:ln>
         </p:spPr>
@@ -4788,132 +5095,24 @@
       </p:sp>
       <p:sp>
         <p:nvSpPr>
-          <p:cNvPr id="11" name="TextBox 10"/>
-          <p:cNvSpPr txBox="1"/>
-          <p:nvPr/>
-        </p:nvSpPr>
-        <p:spPr>
-          <a:xfrm>
-            <a:off x="4663440" y="2057400"/>
-            <a:ext cx="2834640" cy="365760"/>
-          </a:xfrm>
-          <a:prstGeom prst="rect">
-            <a:avLst/>
-          </a:prstGeom>
-          <a:noFill/>
-        </p:spPr>
-        <p:txBody>
-          <a:bodyPr wrap="none">
-            <a:spAutoFit/>
-          </a:bodyPr>
-          <a:lstStyle/>
-          <a:p>
-            <a:pPr>
-              <a:defRPr sz="1400" b="1">
-                <a:solidFill>
-                  <a:srgbClr val="A855F7"/>
-                </a:solidFill>
-                <a:latin typeface="Segoe UI"/>
-              </a:defRPr>
-            </a:pPr>
-            <a:r>
-              <a:t>STEP 2: DIAGNOSE</a:t>
-            </a:r>
-          </a:p>
-        </p:txBody>
-      </p:sp>
-      <p:sp>
-        <p:nvSpPr>
-          <p:cNvPr id="12" name="TextBox 11"/>
-          <p:cNvSpPr txBox="1"/>
-          <p:nvPr/>
-        </p:nvSpPr>
-        <p:spPr>
-          <a:xfrm>
-            <a:off x="4663440" y="2514600"/>
-            <a:ext cx="2834640" cy="457200"/>
-          </a:xfrm>
-          <a:prstGeom prst="rect">
-            <a:avLst/>
-          </a:prstGeom>
-          <a:noFill/>
-        </p:spPr>
-        <p:txBody>
-          <a:bodyPr wrap="none">
-            <a:spAutoFit/>
-          </a:bodyPr>
-          <a:lstStyle/>
-          <a:p>
-            <a:pPr>
-              <a:defRPr sz="1500" b="1">
-                <a:solidFill>
-                  <a:srgbClr val="FFFFFF"/>
-                </a:solidFill>
-                <a:latin typeface="Segoe UI"/>
-              </a:defRPr>
-            </a:pPr>
-            <a:r>
-              <a:t>30-Second Cognitive Triage</a:t>
-            </a:r>
-          </a:p>
-        </p:txBody>
-      </p:sp>
-      <p:sp>
-        <p:nvSpPr>
-          <p:cNvPr id="13" name="TextBox 12"/>
-          <p:cNvSpPr txBox="1"/>
-          <p:nvPr/>
-        </p:nvSpPr>
-        <p:spPr>
-          <a:xfrm>
-            <a:off x="4663440" y="3063240"/>
-            <a:ext cx="2834640" cy="2560320"/>
-          </a:xfrm>
-          <a:prstGeom prst="rect">
-            <a:avLst/>
-          </a:prstGeom>
-          <a:noFill/>
-        </p:spPr>
-        <p:txBody>
-          <a:bodyPr wrap="none">
-            <a:spAutoFit/>
-          </a:bodyPr>
-          <a:lstStyle/>
-          <a:p>
-            <a:pPr>
-              <a:defRPr sz="1200">
-                <a:solidFill>
-                  <a:srgbClr val="94A3B8"/>
-                </a:solidFill>
-                <a:latin typeface="Segoe UI"/>
-              </a:defRPr>
-            </a:pPr>
-            <a:r>
-              <a:t>5 scenario questions identify primary learning modality, friction bottlenecks, and exam countdown.</a:t>
-            </a:r>
-          </a:p>
-        </p:txBody>
-      </p:sp>
-      <p:sp>
-        <p:nvSpPr>
-          <p:cNvPr id="14" name="Rounded Rectangle 13"/>
+          <p:cNvPr id="8" name="Rounded Rectangle 7"/>
           <p:cNvSpPr/>
           <p:nvPr/>
         </p:nvSpPr>
         <p:spPr>
           <a:xfrm>
-            <a:off x="8046720" y="1691640"/>
-            <a:ext cx="3383280" cy="4480560"/>
+            <a:off x="987552" y="1874520"/>
+            <a:ext cx="1645920" cy="256032"/>
           </a:xfrm>
           <a:prstGeom prst="roundRect">
             <a:avLst/>
           </a:prstGeom>
           <a:solidFill>
-            <a:srgbClr val="121826"/>
+            <a:srgbClr val="161E30"/>
           </a:solidFill>
-          <a:ln w="15240">
+          <a:ln w="12700">
             <a:solidFill>
-              <a:srgbClr val="283855"/>
+              <a:srgbClr val="00E5FF"/>
             </a:solidFill>
           </a:ln>
         </p:spPr>
@@ -4941,14 +5140,14 @@
       </p:sp>
       <p:sp>
         <p:nvSpPr>
-          <p:cNvPr id="15" name="TextBox 14"/>
+          <p:cNvPr id="9" name="TextBox 8"/>
           <p:cNvSpPr txBox="1"/>
           <p:nvPr/>
         </p:nvSpPr>
         <p:spPr>
           <a:xfrm>
-            <a:off x="8321040" y="2057400"/>
-            <a:ext cx="2834640" cy="365760"/>
+            <a:off x="1005840" y="1892808"/>
+            <a:ext cx="1609344" cy="228600"/>
           </a:xfrm>
           <a:prstGeom prst="rect">
             <a:avLst/>
@@ -4961,30 +5160,30 @@
           </a:bodyPr>
           <a:lstStyle/>
           <a:p>
-            <a:pPr>
-              <a:defRPr sz="1400" b="1">
-                <a:solidFill>
-                  <a:srgbClr val="10B981"/>
+            <a:pPr algn="ctr">
+              <a:defRPr sz="850" b="1">
+                <a:solidFill>
+                  <a:srgbClr val="00E5FF"/>
                 </a:solidFill>
                 <a:latin typeface="Segoe UI"/>
               </a:defRPr>
             </a:pPr>
             <a:r>
-              <a:t>STEP 3: REFRACT</a:t>
-            </a:r>
-          </a:p>
-        </p:txBody>
-      </p:sp>
-      <p:sp>
-        <p:nvSpPr>
-          <p:cNvPr id="16" name="TextBox 15"/>
+              <a:t>METAPHORICAL</a:t>
+            </a:r>
+          </a:p>
+        </p:txBody>
+      </p:sp>
+      <p:sp>
+        <p:nvSpPr>
+          <p:cNvPr id="10" name="TextBox 9"/>
           <p:cNvSpPr txBox="1"/>
           <p:nvPr/>
         </p:nvSpPr>
         <p:spPr>
           <a:xfrm>
-            <a:off x="8321040" y="2514600"/>
-            <a:ext cx="2834640" cy="457200"/>
+            <a:off x="987552" y="2240280"/>
+            <a:ext cx="4700016" cy="411480"/>
           </a:xfrm>
           <a:prstGeom prst="rect">
             <a:avLst/>
@@ -4998,7 +5197,7 @@
           <a:lstStyle/>
           <a:p>
             <a:pPr>
-              <a:defRPr sz="1500" b="1">
+              <a:defRPr sz="1450" b="1">
                 <a:solidFill>
                   <a:srgbClr val="FFFFFF"/>
                 </a:solidFill>
@@ -5006,21 +5205,21 @@
               </a:defRPr>
             </a:pPr>
             <a:r>
-              <a:t>Multi-Modal Synthesis</a:t>
-            </a:r>
-          </a:p>
-        </p:txBody>
-      </p:sp>
-      <p:sp>
-        <p:nvSpPr>
-          <p:cNvPr id="17" name="TextBox 16"/>
+              <a:t>Dorm &amp; Dining Hall Metaphors</a:t>
+            </a:r>
+          </a:p>
+        </p:txBody>
+      </p:sp>
+      <p:sp>
+        <p:nvSpPr>
+          <p:cNvPr id="11" name="TextBox 10"/>
           <p:cNvSpPr txBox="1"/>
           <p:nvPr/>
         </p:nvSpPr>
         <p:spPr>
           <a:xfrm>
-            <a:off x="8321040" y="3063240"/>
-            <a:ext cx="2834640" cy="2560320"/>
+            <a:off x="987552" y="2606040"/>
+            <a:ext cx="4700016" cy="274320"/>
           </a:xfrm>
           <a:prstGeom prst="rect">
             <a:avLst/>
@@ -5034,7 +5233,43 @@
           <a:lstStyle/>
           <a:p>
             <a:pPr>
-              <a:defRPr sz="1200">
+              <a:defRPr sz="1050" b="1">
+                <a:solidFill>
+                  <a:srgbClr val="00E5FF"/>
+                </a:solidFill>
+                <a:latin typeface="Segoe UI"/>
+              </a:defRPr>
+            </a:pPr>
+            <a:r>
+              <a:t>SPECTRUM 1: ANALOGY</a:t>
+            </a:r>
+          </a:p>
+        </p:txBody>
+      </p:sp>
+      <p:sp>
+        <p:nvSpPr>
+          <p:cNvPr id="12" name="TextBox 11"/>
+          <p:cNvSpPr txBox="1"/>
+          <p:nvPr/>
+        </p:nvSpPr>
+        <p:spPr>
+          <a:xfrm>
+            <a:off x="987552" y="2926080"/>
+            <a:ext cx="4700016" cy="868680"/>
+          </a:xfrm>
+          <a:prstGeom prst="rect">
+            <a:avLst/>
+          </a:prstGeom>
+          <a:noFill/>
+        </p:spPr>
+        <p:txBody>
+          <a:bodyPr wrap="none">
+            <a:spAutoFit/>
+          </a:bodyPr>
+          <a:lstStyle/>
+          <a:p>
+            <a:pPr>
+              <a:defRPr sz="1100">
                 <a:solidFill>
                   <a:srgbClr val="94A3B8"/>
                 </a:solidFill>
@@ -5042,7 +5277,709 @@
               </a:defRPr>
             </a:pPr>
             <a:r>
-              <a:t>Amazon Quick orchestrates Amazon Bedrock models into 4 distinct, simultaneous learning spectrums.</a:t>
+              <a:t>Translates abstract theory into daily campus reality. E.g., Dijkstra's shortest path = navigating peak dining hall line rush.</a:t>
+            </a:r>
+          </a:p>
+        </p:txBody>
+      </p:sp>
+      <p:sp>
+        <p:nvSpPr>
+          <p:cNvPr id="13" name="Rounded Rectangle 12"/>
+          <p:cNvSpPr/>
+          <p:nvPr/>
+        </p:nvSpPr>
+        <p:spPr>
+          <a:xfrm>
+            <a:off x="6217920" y="1645920"/>
+            <a:ext cx="5212080" cy="2240280"/>
+          </a:xfrm>
+          <a:prstGeom prst="roundRect">
+            <a:avLst/>
+          </a:prstGeom>
+          <a:solidFill>
+            <a:srgbClr val="101622"/>
+          </a:solidFill>
+          <a:ln w="16510">
+            <a:solidFill>
+              <a:srgbClr val="A855F7"/>
+            </a:solidFill>
+          </a:ln>
+        </p:spPr>
+        <p:style>
+          <a:lnRef idx="1">
+            <a:schemeClr val="accent1"/>
+          </a:lnRef>
+          <a:fillRef idx="3">
+            <a:schemeClr val="accent1"/>
+          </a:fillRef>
+          <a:effectRef idx="2">
+            <a:schemeClr val="accent1"/>
+          </a:effectRef>
+          <a:fontRef idx="minor">
+            <a:schemeClr val="lt1"/>
+          </a:fontRef>
+        </p:style>
+        <p:txBody>
+          <a:bodyPr rtlCol="0" anchor="ctr"/>
+          <a:lstStyle/>
+          <a:p>
+            <a:pPr algn="ctr"/>
+          </a:p>
+        </p:txBody>
+      </p:sp>
+      <p:sp>
+        <p:nvSpPr>
+          <p:cNvPr id="14" name="Rounded Rectangle 13"/>
+          <p:cNvSpPr/>
+          <p:nvPr/>
+        </p:nvSpPr>
+        <p:spPr>
+          <a:xfrm>
+            <a:off x="6473952" y="1874520"/>
+            <a:ext cx="1645920" cy="256032"/>
+          </a:xfrm>
+          <a:prstGeom prst="roundRect">
+            <a:avLst/>
+          </a:prstGeom>
+          <a:solidFill>
+            <a:srgbClr val="161E30"/>
+          </a:solidFill>
+          <a:ln w="12700">
+            <a:solidFill>
+              <a:srgbClr val="B464FF"/>
+            </a:solidFill>
+          </a:ln>
+        </p:spPr>
+        <p:style>
+          <a:lnRef idx="1">
+            <a:schemeClr val="accent1"/>
+          </a:lnRef>
+          <a:fillRef idx="3">
+            <a:schemeClr val="accent1"/>
+          </a:fillRef>
+          <a:effectRef idx="2">
+            <a:schemeClr val="accent1"/>
+          </a:effectRef>
+          <a:fontRef idx="minor">
+            <a:schemeClr val="lt1"/>
+          </a:fontRef>
+        </p:style>
+        <p:txBody>
+          <a:bodyPr rtlCol="0" anchor="ctr"/>
+          <a:lstStyle/>
+          <a:p>
+            <a:pPr algn="ctr"/>
+          </a:p>
+        </p:txBody>
+      </p:sp>
+      <p:sp>
+        <p:nvSpPr>
+          <p:cNvPr id="15" name="TextBox 14"/>
+          <p:cNvSpPr txBox="1"/>
+          <p:nvPr/>
+        </p:nvSpPr>
+        <p:spPr>
+          <a:xfrm>
+            <a:off x="6492240" y="1892808"/>
+            <a:ext cx="1609344" cy="228600"/>
+          </a:xfrm>
+          <a:prstGeom prst="rect">
+            <a:avLst/>
+          </a:prstGeom>
+          <a:noFill/>
+        </p:spPr>
+        <p:txBody>
+          <a:bodyPr wrap="none">
+            <a:spAutoFit/>
+          </a:bodyPr>
+          <a:lstStyle/>
+          <a:p>
+            <a:pPr algn="ctr">
+              <a:defRPr sz="850" b="1">
+                <a:solidFill>
+                  <a:srgbClr val="B464FF"/>
+                </a:solidFill>
+                <a:latin typeface="Segoe UI"/>
+              </a:defRPr>
+            </a:pPr>
+            <a:r>
+              <a:t>SCHEMATIC</a:t>
+            </a:r>
+          </a:p>
+        </p:txBody>
+      </p:sp>
+      <p:sp>
+        <p:nvSpPr>
+          <p:cNvPr id="16" name="TextBox 15"/>
+          <p:cNvSpPr txBox="1"/>
+          <p:nvPr/>
+        </p:nvSpPr>
+        <p:spPr>
+          <a:xfrm>
+            <a:off x="6473952" y="2240280"/>
+            <a:ext cx="4700016" cy="411480"/>
+          </a:xfrm>
+          <a:prstGeom prst="rect">
+            <a:avLst/>
+          </a:prstGeom>
+          <a:noFill/>
+        </p:spPr>
+        <p:txBody>
+          <a:bodyPr wrap="none">
+            <a:spAutoFit/>
+          </a:bodyPr>
+          <a:lstStyle/>
+          <a:p>
+            <a:pPr>
+              <a:defRPr sz="1450" b="1">
+                <a:solidFill>
+                  <a:srgbClr val="FFFFFF"/>
+                </a:solidFill>
+                <a:latin typeface="Segoe UI"/>
+              </a:defRPr>
+            </a:pPr>
+            <a:r>
+              <a:t>ASCII &amp; Schematic Blueprints</a:t>
+            </a:r>
+          </a:p>
+        </p:txBody>
+      </p:sp>
+      <p:sp>
+        <p:nvSpPr>
+          <p:cNvPr id="17" name="TextBox 16"/>
+          <p:cNvSpPr txBox="1"/>
+          <p:nvPr/>
+        </p:nvSpPr>
+        <p:spPr>
+          <a:xfrm>
+            <a:off x="6473952" y="2606040"/>
+            <a:ext cx="4700016" cy="274320"/>
+          </a:xfrm>
+          <a:prstGeom prst="rect">
+            <a:avLst/>
+          </a:prstGeom>
+          <a:noFill/>
+        </p:spPr>
+        <p:txBody>
+          <a:bodyPr wrap="none">
+            <a:spAutoFit/>
+          </a:bodyPr>
+          <a:lstStyle/>
+          <a:p>
+            <a:pPr>
+              <a:defRPr sz="1050" b="1">
+                <a:solidFill>
+                  <a:srgbClr val="B464FF"/>
+                </a:solidFill>
+                <a:latin typeface="Segoe UI"/>
+              </a:defRPr>
+            </a:pPr>
+            <a:r>
+              <a:t>SPECTRUM 2: VISUAL MAP</a:t>
+            </a:r>
+          </a:p>
+        </p:txBody>
+      </p:sp>
+      <p:sp>
+        <p:nvSpPr>
+          <p:cNvPr id="18" name="TextBox 17"/>
+          <p:cNvSpPr txBox="1"/>
+          <p:nvPr/>
+        </p:nvSpPr>
+        <p:spPr>
+          <a:xfrm>
+            <a:off x="6473952" y="2926080"/>
+            <a:ext cx="4700016" cy="868680"/>
+          </a:xfrm>
+          <a:prstGeom prst="rect">
+            <a:avLst/>
+          </a:prstGeom>
+          <a:noFill/>
+        </p:spPr>
+        <p:txBody>
+          <a:bodyPr wrap="none">
+            <a:spAutoFit/>
+          </a:bodyPr>
+          <a:lstStyle/>
+          <a:p>
+            <a:pPr>
+              <a:defRPr sz="1100">
+                <a:solidFill>
+                  <a:srgbClr val="94A3B8"/>
+                </a:solidFill>
+                <a:latin typeface="Segoe UI"/>
+              </a:defRPr>
+            </a:pPr>
+            <a:r>
+              <a:t>Renders execution trees, logical branches, and state machines into structural mental schemas for STEM/CS.</a:t>
+            </a:r>
+          </a:p>
+        </p:txBody>
+      </p:sp>
+      <p:sp>
+        <p:nvSpPr>
+          <p:cNvPr id="19" name="Rounded Rectangle 18"/>
+          <p:cNvSpPr/>
+          <p:nvPr/>
+        </p:nvSpPr>
+        <p:spPr>
+          <a:xfrm>
+            <a:off x="731520" y="4142232"/>
+            <a:ext cx="5212080" cy="2240280"/>
+          </a:xfrm>
+          <a:prstGeom prst="roundRect">
+            <a:avLst/>
+          </a:prstGeom>
+          <a:solidFill>
+            <a:srgbClr val="101622"/>
+          </a:solidFill>
+          <a:ln w="16510">
+            <a:solidFill>
+              <a:srgbClr val="10B981"/>
+            </a:solidFill>
+          </a:ln>
+        </p:spPr>
+        <p:style>
+          <a:lnRef idx="1">
+            <a:schemeClr val="accent1"/>
+          </a:lnRef>
+          <a:fillRef idx="3">
+            <a:schemeClr val="accent1"/>
+          </a:fillRef>
+          <a:effectRef idx="2">
+            <a:schemeClr val="accent1"/>
+          </a:effectRef>
+          <a:fontRef idx="minor">
+            <a:schemeClr val="lt1"/>
+          </a:fontRef>
+        </p:style>
+        <p:txBody>
+          <a:bodyPr rtlCol="0" anchor="ctr"/>
+          <a:lstStyle/>
+          <a:p>
+            <a:pPr algn="ctr"/>
+          </a:p>
+        </p:txBody>
+      </p:sp>
+      <p:sp>
+        <p:nvSpPr>
+          <p:cNvPr id="20" name="Rounded Rectangle 19"/>
+          <p:cNvSpPr/>
+          <p:nvPr/>
+        </p:nvSpPr>
+        <p:spPr>
+          <a:xfrm>
+            <a:off x="987552" y="4370832"/>
+            <a:ext cx="1645920" cy="256032"/>
+          </a:xfrm>
+          <a:prstGeom prst="roundRect">
+            <a:avLst/>
+          </a:prstGeom>
+          <a:solidFill>
+            <a:srgbClr val="161E30"/>
+          </a:solidFill>
+          <a:ln w="12700">
+            <a:solidFill>
+              <a:srgbClr val="34D399"/>
+            </a:solidFill>
+          </a:ln>
+        </p:spPr>
+        <p:style>
+          <a:lnRef idx="1">
+            <a:schemeClr val="accent1"/>
+          </a:lnRef>
+          <a:fillRef idx="3">
+            <a:schemeClr val="accent1"/>
+          </a:fillRef>
+          <a:effectRef idx="2">
+            <a:schemeClr val="accent1"/>
+          </a:effectRef>
+          <a:fontRef idx="minor">
+            <a:schemeClr val="lt1"/>
+          </a:fontRef>
+        </p:style>
+        <p:txBody>
+          <a:bodyPr rtlCol="0" anchor="ctr"/>
+          <a:lstStyle/>
+          <a:p>
+            <a:pPr algn="ctr"/>
+          </a:p>
+        </p:txBody>
+      </p:sp>
+      <p:sp>
+        <p:nvSpPr>
+          <p:cNvPr id="21" name="TextBox 20"/>
+          <p:cNvSpPr txBox="1"/>
+          <p:nvPr/>
+        </p:nvSpPr>
+        <p:spPr>
+          <a:xfrm>
+            <a:off x="1005840" y="4389120"/>
+            <a:ext cx="1609344" cy="228600"/>
+          </a:xfrm>
+          <a:prstGeom prst="rect">
+            <a:avLst/>
+          </a:prstGeom>
+          <a:noFill/>
+        </p:spPr>
+        <p:txBody>
+          <a:bodyPr wrap="none">
+            <a:spAutoFit/>
+          </a:bodyPr>
+          <a:lstStyle/>
+          <a:p>
+            <a:pPr algn="ctr">
+              <a:defRPr sz="850" b="1">
+                <a:solidFill>
+                  <a:srgbClr val="34D399"/>
+                </a:solidFill>
+                <a:latin typeface="Segoe UI"/>
+              </a:defRPr>
+            </a:pPr>
+            <a:r>
+              <a:t>KINESTHETIC</a:t>
+            </a:r>
+          </a:p>
+        </p:txBody>
+      </p:sp>
+      <p:sp>
+        <p:nvSpPr>
+          <p:cNvPr id="22" name="TextBox 21"/>
+          <p:cNvSpPr txBox="1"/>
+          <p:nvPr/>
+        </p:nvSpPr>
+        <p:spPr>
+          <a:xfrm>
+            <a:off x="987552" y="4736592"/>
+            <a:ext cx="4700016" cy="411480"/>
+          </a:xfrm>
+          <a:prstGeom prst="rect">
+            <a:avLst/>
+          </a:prstGeom>
+          <a:noFill/>
+        </p:spPr>
+        <p:txBody>
+          <a:bodyPr wrap="none">
+            <a:spAutoFit/>
+          </a:bodyPr>
+          <a:lstStyle/>
+          <a:p>
+            <a:pPr>
+              <a:defRPr sz="1450" b="1">
+                <a:solidFill>
+                  <a:srgbClr val="FFFFFF"/>
+                </a:solidFill>
+                <a:latin typeface="Segoe UI"/>
+              </a:defRPr>
+            </a:pPr>
+            <a:r>
+              <a:t>Active Retrieval Partner</a:t>
+            </a:r>
+          </a:p>
+        </p:txBody>
+      </p:sp>
+      <p:sp>
+        <p:nvSpPr>
+          <p:cNvPr id="23" name="TextBox 22"/>
+          <p:cNvSpPr txBox="1"/>
+          <p:nvPr/>
+        </p:nvSpPr>
+        <p:spPr>
+          <a:xfrm>
+            <a:off x="987552" y="5102352"/>
+            <a:ext cx="4700016" cy="274320"/>
+          </a:xfrm>
+          <a:prstGeom prst="rect">
+            <a:avLst/>
+          </a:prstGeom>
+          <a:noFill/>
+        </p:spPr>
+        <p:txBody>
+          <a:bodyPr wrap="none">
+            <a:spAutoFit/>
+          </a:bodyPr>
+          <a:lstStyle/>
+          <a:p>
+            <a:pPr>
+              <a:defRPr sz="1050" b="1">
+                <a:solidFill>
+                  <a:srgbClr val="34D399"/>
+                </a:solidFill>
+                <a:latin typeface="Segoe UI"/>
+              </a:defRPr>
+            </a:pPr>
+            <a:r>
+              <a:t>SPECTRUM 3: SOCRATIC SPARRING</a:t>
+            </a:r>
+          </a:p>
+        </p:txBody>
+      </p:sp>
+      <p:sp>
+        <p:nvSpPr>
+          <p:cNvPr id="24" name="TextBox 23"/>
+          <p:cNvSpPr txBox="1"/>
+          <p:nvPr/>
+        </p:nvSpPr>
+        <p:spPr>
+          <a:xfrm>
+            <a:off x="987552" y="5422392"/>
+            <a:ext cx="4700016" cy="868680"/>
+          </a:xfrm>
+          <a:prstGeom prst="rect">
+            <a:avLst/>
+          </a:prstGeom>
+          <a:noFill/>
+        </p:spPr>
+        <p:txBody>
+          <a:bodyPr wrap="none">
+            <a:spAutoFit/>
+          </a:bodyPr>
+          <a:lstStyle/>
+          <a:p>
+            <a:pPr>
+              <a:defRPr sz="1100">
+                <a:solidFill>
+                  <a:srgbClr val="94A3B8"/>
+                </a:solidFill>
+                <a:latin typeface="Segoe UI"/>
+              </a:defRPr>
+            </a:pPr>
+            <a:r>
+              <a:t>Chatbot strictly capped at 2 sentences; never lectures; fires progressive edge cases to force active recall.</a:t>
+            </a:r>
+          </a:p>
+        </p:txBody>
+      </p:sp>
+      <p:sp>
+        <p:nvSpPr>
+          <p:cNvPr id="25" name="Rounded Rectangle 24"/>
+          <p:cNvSpPr/>
+          <p:nvPr/>
+        </p:nvSpPr>
+        <p:spPr>
+          <a:xfrm>
+            <a:off x="6217920" y="4142232"/>
+            <a:ext cx="5212080" cy="2240280"/>
+          </a:xfrm>
+          <a:prstGeom prst="roundRect">
+            <a:avLst/>
+          </a:prstGeom>
+          <a:solidFill>
+            <a:srgbClr val="101622"/>
+          </a:solidFill>
+          <a:ln w="16510">
+            <a:solidFill>
+              <a:srgbClr val="202D46"/>
+            </a:solidFill>
+          </a:ln>
+        </p:spPr>
+        <p:style>
+          <a:lnRef idx="1">
+            <a:schemeClr val="accent1"/>
+          </a:lnRef>
+          <a:fillRef idx="3">
+            <a:schemeClr val="accent1"/>
+          </a:fillRef>
+          <a:effectRef idx="2">
+            <a:schemeClr val="accent1"/>
+          </a:effectRef>
+          <a:fontRef idx="minor">
+            <a:schemeClr val="lt1"/>
+          </a:fontRef>
+        </p:style>
+        <p:txBody>
+          <a:bodyPr rtlCol="0" anchor="ctr"/>
+          <a:lstStyle/>
+          <a:p>
+            <a:pPr algn="ctr"/>
+          </a:p>
+        </p:txBody>
+      </p:sp>
+      <p:sp>
+        <p:nvSpPr>
+          <p:cNvPr id="26" name="Rounded Rectangle 25"/>
+          <p:cNvSpPr/>
+          <p:nvPr/>
+        </p:nvSpPr>
+        <p:spPr>
+          <a:xfrm>
+            <a:off x="6473952" y="4370832"/>
+            <a:ext cx="1645920" cy="256032"/>
+          </a:xfrm>
+          <a:prstGeom prst="roundRect">
+            <a:avLst/>
+          </a:prstGeom>
+          <a:solidFill>
+            <a:srgbClr val="161E30"/>
+          </a:solidFill>
+          <a:ln w="12700">
+            <a:solidFill>
+              <a:srgbClr val="FBBF24"/>
+            </a:solidFill>
+          </a:ln>
+        </p:spPr>
+        <p:style>
+          <a:lnRef idx="1">
+            <a:schemeClr val="accent1"/>
+          </a:lnRef>
+          <a:fillRef idx="3">
+            <a:schemeClr val="accent1"/>
+          </a:fillRef>
+          <a:effectRef idx="2">
+            <a:schemeClr val="accent1"/>
+          </a:effectRef>
+          <a:fontRef idx="minor">
+            <a:schemeClr val="lt1"/>
+          </a:fontRef>
+        </p:style>
+        <p:txBody>
+          <a:bodyPr rtlCol="0" anchor="ctr"/>
+          <a:lstStyle/>
+          <a:p>
+            <a:pPr algn="ctr"/>
+          </a:p>
+        </p:txBody>
+      </p:sp>
+      <p:sp>
+        <p:nvSpPr>
+          <p:cNvPr id="27" name="TextBox 26"/>
+          <p:cNvSpPr txBox="1"/>
+          <p:nvPr/>
+        </p:nvSpPr>
+        <p:spPr>
+          <a:xfrm>
+            <a:off x="6492240" y="4389120"/>
+            <a:ext cx="1609344" cy="228600"/>
+          </a:xfrm>
+          <a:prstGeom prst="rect">
+            <a:avLst/>
+          </a:prstGeom>
+          <a:noFill/>
+        </p:spPr>
+        <p:txBody>
+          <a:bodyPr wrap="none">
+            <a:spAutoFit/>
+          </a:bodyPr>
+          <a:lstStyle/>
+          <a:p>
+            <a:pPr algn="ctr">
+              <a:defRPr sz="850" b="1">
+                <a:solidFill>
+                  <a:srgbClr val="FBBF24"/>
+                </a:solidFill>
+                <a:latin typeface="Segoe UI"/>
+              </a:defRPr>
+            </a:pPr>
+            <a:r>
+              <a:t>SYNTHESIS</a:t>
+            </a:r>
+          </a:p>
+        </p:txBody>
+      </p:sp>
+      <p:sp>
+        <p:nvSpPr>
+          <p:cNvPr id="28" name="TextBox 27"/>
+          <p:cNvSpPr txBox="1"/>
+          <p:nvPr/>
+        </p:nvSpPr>
+        <p:spPr>
+          <a:xfrm>
+            <a:off x="6473952" y="4736592"/>
+            <a:ext cx="4700016" cy="411480"/>
+          </a:xfrm>
+          <a:prstGeom prst="rect">
+            <a:avLst/>
+          </a:prstGeom>
+          <a:noFill/>
+        </p:spPr>
+        <p:txBody>
+          <a:bodyPr wrap="none">
+            <a:spAutoFit/>
+          </a:bodyPr>
+          <a:lstStyle/>
+          <a:p>
+            <a:pPr>
+              <a:defRPr sz="1450" b="1">
+                <a:solidFill>
+                  <a:srgbClr val="FFFFFF"/>
+                </a:solidFill>
+                <a:latin typeface="Segoe UI"/>
+              </a:defRPr>
+            </a:pPr>
+            <a:r>
+              <a:t>4-Slide Micro-Presentation</a:t>
+            </a:r>
+          </a:p>
+        </p:txBody>
+      </p:sp>
+      <p:sp>
+        <p:nvSpPr>
+          <p:cNvPr id="29" name="TextBox 28"/>
+          <p:cNvSpPr txBox="1"/>
+          <p:nvPr/>
+        </p:nvSpPr>
+        <p:spPr>
+          <a:xfrm>
+            <a:off x="6473952" y="5102352"/>
+            <a:ext cx="4700016" cy="274320"/>
+          </a:xfrm>
+          <a:prstGeom prst="rect">
+            <a:avLst/>
+          </a:prstGeom>
+          <a:noFill/>
+        </p:spPr>
+        <p:txBody>
+          <a:bodyPr wrap="none">
+            <a:spAutoFit/>
+          </a:bodyPr>
+          <a:lstStyle/>
+          <a:p>
+            <a:pPr>
+              <a:defRPr sz="1050" b="1">
+                <a:solidFill>
+                  <a:srgbClr val="FBBF24"/>
+                </a:solidFill>
+                <a:latin typeface="Segoe UI"/>
+              </a:defRPr>
+            </a:pPr>
+            <a:r>
+              <a:t>SPECTRUM 4: EXAM TRAP DECK</a:t>
+            </a:r>
+          </a:p>
+        </p:txBody>
+      </p:sp>
+      <p:sp>
+        <p:nvSpPr>
+          <p:cNvPr id="30" name="TextBox 29"/>
+          <p:cNvSpPr txBox="1"/>
+          <p:nvPr/>
+        </p:nvSpPr>
+        <p:spPr>
+          <a:xfrm>
+            <a:off x="6473952" y="5422392"/>
+            <a:ext cx="4700016" cy="868680"/>
+          </a:xfrm>
+          <a:prstGeom prst="rect">
+            <a:avLst/>
+          </a:prstGeom>
+          <a:noFill/>
+        </p:spPr>
+        <p:txBody>
+          <a:bodyPr wrap="none">
+            <a:spAutoFit/>
+          </a:bodyPr>
+          <a:lstStyle/>
+          <a:p>
+            <a:pPr>
+              <a:defRPr sz="1100">
+                <a:solidFill>
+                  <a:srgbClr val="94A3B8"/>
+                </a:solidFill>
+                <a:latin typeface="Segoe UI"/>
+              </a:defRPr>
+            </a:pPr>
+            <a:r>
+              <a:t>Exposes the exact trick questions professors test on Midterm #2, coupled with an AI visual memory anchor.</a:t>
             </a:r>
           </a:p>
         </p:txBody>
@@ -5080,7 +6017,7 @@
             <a:avLst/>
           </a:prstGeom>
           <a:solidFill>
-            <a:srgbClr val="0B0F19"/>
+            <a:srgbClr val="080B13"/>
           </a:solidFill>
           <a:ln>
             <a:noFill/>
@@ -5116,8 +6053,8 @@
         </p:nvSpPr>
         <p:spPr>
           <a:xfrm>
-            <a:off x="731520" y="365760"/>
-            <a:ext cx="10698480" cy="320040"/>
+            <a:off x="731520" y="347472"/>
+            <a:ext cx="8229600" cy="292608"/>
           </a:xfrm>
           <a:prstGeom prst="rect">
             <a:avLst/>
@@ -5133,109 +6070,37 @@
             <a:pPr>
               <a:defRPr sz="1100" b="1">
                 <a:solidFill>
-                  <a:srgbClr val="00D4FF"/>
+                  <a:srgbClr val="00E5FF"/>
                 </a:solidFill>
                 <a:latin typeface="Segoe UI"/>
               </a:defRPr>
             </a:pPr>
             <a:r>
-              <a:t>PRODUCT EXPERIENCE</a:t>
-            </a:r>
-          </a:p>
-        </p:txBody>
-      </p:sp>
-      <p:sp>
-        <p:nvSpPr>
-          <p:cNvPr id="4" name="TextBox 3"/>
-          <p:cNvSpPr txBox="1"/>
-          <p:nvPr/>
-        </p:nvSpPr>
-        <p:spPr>
-          <a:xfrm>
-            <a:off x="731520" y="685800"/>
-            <a:ext cx="10698480" cy="502920"/>
-          </a:xfrm>
-          <a:prstGeom prst="rect">
-            <a:avLst/>
-          </a:prstGeom>
-          <a:noFill/>
-        </p:spPr>
-        <p:txBody>
-          <a:bodyPr wrap="square" lIns="0" tIns="0" rIns="0" bIns="0">
-            <a:spAutoFit/>
-          </a:bodyPr>
-          <a:lstStyle/>
-          <a:p>
-            <a:pPr>
-              <a:defRPr sz="2200" b="1">
-                <a:solidFill>
-                  <a:srgbClr val="FFFFFF"/>
-                </a:solidFill>
-                <a:latin typeface="Segoe UI"/>
-              </a:defRPr>
-            </a:pPr>
-            <a:r>
-              <a:t>The 4 Learning Spectrums: Zero Errors, Maximum Retention</a:t>
-            </a:r>
-          </a:p>
-        </p:txBody>
-      </p:sp>
-      <p:sp>
-        <p:nvSpPr>
-          <p:cNvPr id="5" name="TextBox 4"/>
-          <p:cNvSpPr txBox="1"/>
-          <p:nvPr/>
-        </p:nvSpPr>
-        <p:spPr>
-          <a:xfrm>
-            <a:off x="731520" y="1234440"/>
-            <a:ext cx="10698480" cy="320040"/>
-          </a:xfrm>
-          <a:prstGeom prst="rect">
-            <a:avLst/>
-          </a:prstGeom>
-          <a:noFill/>
-        </p:spPr>
-        <p:txBody>
-          <a:bodyPr wrap="square" lIns="0" tIns="0" rIns="0" bIns="0">
-            <a:spAutoFit/>
-          </a:bodyPr>
-          <a:lstStyle/>
-          <a:p>
-            <a:pPr>
-              <a:defRPr sz="1200">
-                <a:solidFill>
-                  <a:srgbClr val="94A3B8"/>
-                </a:solidFill>
-                <a:latin typeface="Segoe UI"/>
-              </a:defRPr>
-            </a:pPr>
-            <a:r>
-              <a:t>Every student gets the modality their brain naturally responds to</a:t>
-            </a:r>
-          </a:p>
-        </p:txBody>
-      </p:sp>
-      <p:sp>
-        <p:nvSpPr>
-          <p:cNvPr id="6" name="Rounded Rectangle 5"/>
+              <a:t>SEGMENT 4: WHY IT WINS (25S)</a:t>
+            </a:r>
+          </a:p>
+        </p:txBody>
+      </p:sp>
+      <p:sp>
+        <p:nvSpPr>
+          <p:cNvPr id="4" name="Rounded Rectangle 3"/>
           <p:cNvSpPr/>
           <p:nvPr/>
         </p:nvSpPr>
         <p:spPr>
           <a:xfrm>
-            <a:off x="731520" y="1691640"/>
-            <a:ext cx="5212080" cy="2103120"/>
+            <a:off x="9448495" y="320040"/>
+            <a:ext cx="2011680" cy="347472"/>
           </a:xfrm>
           <a:prstGeom prst="roundRect">
             <a:avLst/>
           </a:prstGeom>
           <a:solidFill>
-            <a:srgbClr val="121826"/>
+            <a:srgbClr val="161E30"/>
           </a:solidFill>
           <a:ln w="15240">
             <a:solidFill>
-              <a:srgbClr val="283855"/>
+              <a:srgbClr val="00E5FF"/>
             </a:solidFill>
           </a:ln>
         </p:spPr>
@@ -5254,23 +6119,33 @@
           </a:fontRef>
         </p:style>
         <p:txBody>
-          <a:bodyPr rtlCol="0" anchor="ctr"/>
-          <a:lstStyle/>
-          <a:p>
-            <a:pPr algn="ctr"/>
-          </a:p>
-        </p:txBody>
-      </p:sp>
-      <p:sp>
-        <p:nvSpPr>
-          <p:cNvPr id="7" name="TextBox 6"/>
+          <a:bodyPr rtlCol="0" anchor="ctr" lIns="0" rIns="0" tIns="0" bIns="0"/>
+          <a:lstStyle/>
+          <a:p>
+            <a:pPr algn="ctr">
+              <a:defRPr sz="1000" b="1">
+                <a:solidFill>
+                  <a:srgbClr val="00E5FF"/>
+                </a:solidFill>
+                <a:latin typeface="Segoe UI"/>
+              </a:defRPr>
+            </a:pPr>
+            <a:r>
+              <a:t>25 SECONDS</a:t>
+            </a:r>
+          </a:p>
+        </p:txBody>
+      </p:sp>
+      <p:sp>
+        <p:nvSpPr>
+          <p:cNvPr id="5" name="TextBox 4"/>
           <p:cNvSpPr txBox="1"/>
           <p:nvPr/>
         </p:nvSpPr>
         <p:spPr>
           <a:xfrm>
-            <a:off x="1005840" y="1920240"/>
-            <a:ext cx="4663440" cy="320040"/>
+            <a:off x="731520" y="658368"/>
+            <a:ext cx="10728655" cy="502920"/>
           </a:xfrm>
           <a:prstGeom prst="rect">
             <a:avLst/>
@@ -5278,35 +6153,35 @@
           <a:noFill/>
         </p:spPr>
         <p:txBody>
-          <a:bodyPr wrap="none">
+          <a:bodyPr wrap="square" lIns="0" tIns="0" rIns="0" bIns="0">
             <a:spAutoFit/>
           </a:bodyPr>
           <a:lstStyle/>
           <a:p>
             <a:pPr>
-              <a:defRPr sz="1300" b="1">
-                <a:solidFill>
-                  <a:srgbClr val="00D4FF"/>
+              <a:defRPr sz="2300" b="1">
+                <a:solidFill>
+                  <a:srgbClr val="FFFFFF"/>
                 </a:solidFill>
                 <a:latin typeface="Segoe UI"/>
               </a:defRPr>
             </a:pPr>
             <a:r>
-              <a:t>SPECTRUM 1: INTUITIVE ANALOGY</a:t>
-            </a:r>
-          </a:p>
-        </p:txBody>
-      </p:sp>
-      <p:sp>
-        <p:nvSpPr>
-          <p:cNvPr id="8" name="TextBox 7"/>
+              <a:t>The Unfair Advantage: Why Prismatic Destroys Generic Tools</a:t>
+            </a:r>
+          </a:p>
+        </p:txBody>
+      </p:sp>
+      <p:sp>
+        <p:nvSpPr>
+          <p:cNvPr id="6" name="TextBox 5"/>
           <p:cNvSpPr txBox="1"/>
           <p:nvPr/>
         </p:nvSpPr>
         <p:spPr>
           <a:xfrm>
-            <a:off x="1005840" y="2286000"/>
-            <a:ext cx="4663440" cy="365760"/>
+            <a:off x="731520" y="1188720"/>
+            <a:ext cx="10728655" cy="320040"/>
           </a:xfrm>
           <a:prstGeom prst="rect">
             <a:avLst/>
@@ -5314,81 +6189,45 @@
           <a:noFill/>
         </p:spPr>
         <p:txBody>
-          <a:bodyPr wrap="none">
+          <a:bodyPr wrap="square" lIns="0" tIns="0" rIns="0" bIns="0">
             <a:spAutoFit/>
           </a:bodyPr>
           <a:lstStyle/>
           <a:p>
             <a:pPr>
-              <a:defRPr sz="1400" b="1">
-                <a:solidFill>
-                  <a:srgbClr val="FFFFFF"/>
+              <a:defRPr sz="1200">
+                <a:solidFill>
+                  <a:srgbClr val="94A3B8"/>
                 </a:solidFill>
                 <a:latin typeface="Segoe UI"/>
               </a:defRPr>
             </a:pPr>
             <a:r>
-              <a:t>Dorm &amp; Campus Analogies</a:t>
-            </a:r>
-          </a:p>
-        </p:txBody>
-      </p:sp>
-      <p:sp>
-        <p:nvSpPr>
-          <p:cNvPr id="9" name="TextBox 8"/>
-          <p:cNvSpPr txBox="1"/>
-          <p:nvPr/>
-        </p:nvSpPr>
-        <p:spPr>
-          <a:xfrm>
-            <a:off x="1005840" y="2743200"/>
-            <a:ext cx="4663440" cy="868680"/>
-          </a:xfrm>
-          <a:prstGeom prst="rect">
-            <a:avLst/>
-          </a:prstGeom>
-          <a:noFill/>
-        </p:spPr>
-        <p:txBody>
-          <a:bodyPr wrap="none">
-            <a:spAutoFit/>
-          </a:bodyPr>
-          <a:lstStyle/>
-          <a:p>
-            <a:pPr>
-              <a:defRPr sz="1100">
-                <a:solidFill>
-                  <a:srgbClr val="94A3B8"/>
-                </a:solidFill>
-                <a:latin typeface="Segoe UI"/>
-              </a:defRPr>
-            </a:pPr>
-            <a:r>
-              <a:t>Maps abstract theory to everyday student life. E.g., Dijkstra's shortest path = navigating dining hall rush hours at peak times.</a:t>
-            </a:r>
-          </a:p>
-        </p:txBody>
-      </p:sp>
-      <p:sp>
-        <p:nvSpPr>
-          <p:cNvPr id="10" name="Rounded Rectangle 9"/>
+              <a:t>Who uses this, and why is it exponentially better than everything on the market?</a:t>
+            </a:r>
+          </a:p>
+        </p:txBody>
+      </p:sp>
+      <p:sp>
+        <p:nvSpPr>
+          <p:cNvPr id="7" name="Rounded Rectangle 6"/>
           <p:cNvSpPr/>
           <p:nvPr/>
         </p:nvSpPr>
         <p:spPr>
           <a:xfrm>
-            <a:off x="6217920" y="1691640"/>
-            <a:ext cx="5212080" cy="2103120"/>
+            <a:off x="731520" y="1645920"/>
+            <a:ext cx="3383280" cy="4480560"/>
           </a:xfrm>
           <a:prstGeom prst="roundRect">
             <a:avLst/>
           </a:prstGeom>
           <a:solidFill>
-            <a:srgbClr val="121826"/>
+            <a:srgbClr val="101622"/>
           </a:solidFill>
-          <a:ln w="15240">
+          <a:ln w="16510">
             <a:solidFill>
-              <a:srgbClr val="283855"/>
+              <a:srgbClr val="00E5FF"/>
             </a:solidFill>
           </a:ln>
         </p:spPr>
@@ -5416,14 +6255,14 @@
       </p:sp>
       <p:sp>
         <p:nvSpPr>
-          <p:cNvPr id="11" name="TextBox 10"/>
+          <p:cNvPr id="8" name="TextBox 7"/>
           <p:cNvSpPr txBox="1"/>
           <p:nvPr/>
         </p:nvSpPr>
         <p:spPr>
           <a:xfrm>
-            <a:off x="6492240" y="1920240"/>
-            <a:ext cx="4663440" cy="320040"/>
+            <a:off x="1005840" y="2011680"/>
+            <a:ext cx="2834640" cy="320040"/>
           </a:xfrm>
           <a:prstGeom prst="rect">
             <a:avLst/>
@@ -5437,29 +6276,29 @@
           <a:lstStyle/>
           <a:p>
             <a:pPr>
-              <a:defRPr sz="1300" b="1">
-                <a:solidFill>
-                  <a:srgbClr val="A855F7"/>
+              <a:defRPr sz="1200" b="1">
+                <a:solidFill>
+                  <a:srgbClr val="00E5FF"/>
                 </a:solidFill>
                 <a:latin typeface="Segoe UI"/>
               </a:defRPr>
             </a:pPr>
             <a:r>
-              <a:t>SPECTRUM 2: VISUAL SCHEMATIC</a:t>
-            </a:r>
-          </a:p>
-        </p:txBody>
-      </p:sp>
-      <p:sp>
-        <p:nvSpPr>
-          <p:cNvPr id="12" name="TextBox 11"/>
+              <a:t>VS. CHATGPT / LLMS</a:t>
+            </a:r>
+          </a:p>
+        </p:txBody>
+      </p:sp>
+      <p:sp>
+        <p:nvSpPr>
+          <p:cNvPr id="9" name="TextBox 8"/>
           <p:cNvSpPr txBox="1"/>
           <p:nvPr/>
         </p:nvSpPr>
         <p:spPr>
           <a:xfrm>
-            <a:off x="6492240" y="2286000"/>
-            <a:ext cx="4663440" cy="365760"/>
+            <a:off x="1005840" y="2423160"/>
+            <a:ext cx="2834640" cy="502920"/>
           </a:xfrm>
           <a:prstGeom prst="rect">
             <a:avLst/>
@@ -5481,21 +6320,21 @@
               </a:defRPr>
             </a:pPr>
             <a:r>
-              <a:t>ASCII &amp; Concept Maps</a:t>
-            </a:r>
-          </a:p>
-        </p:txBody>
-      </p:sp>
-      <p:sp>
-        <p:nvSpPr>
-          <p:cNvPr id="13" name="TextBox 12"/>
+              <a:t>Active Sparring vs. Passive Text</a:t>
+            </a:r>
+          </a:p>
+        </p:txBody>
+      </p:sp>
+      <p:sp>
+        <p:nvSpPr>
+          <p:cNvPr id="10" name="TextBox 9"/>
           <p:cNvSpPr txBox="1"/>
           <p:nvPr/>
         </p:nvSpPr>
         <p:spPr>
           <a:xfrm>
-            <a:off x="6492240" y="2743200"/>
-            <a:ext cx="4663440" cy="868680"/>
+            <a:off x="1005840" y="3017520"/>
+            <a:ext cx="2834640" cy="2651760"/>
           </a:xfrm>
           <a:prstGeom prst="rect">
             <a:avLst/>
@@ -5509,7 +6348,7 @@
           <a:lstStyle/>
           <a:p>
             <a:pPr>
-              <a:defRPr sz="1100">
+              <a:defRPr sz="1200">
                 <a:solidFill>
                   <a:srgbClr val="94A3B8"/>
                 </a:solidFill>
@@ -5517,31 +6356,31 @@
               </a:defRPr>
             </a:pPr>
             <a:r>
-              <a:t>Structures execution order, logical branches, and state changes into visual mental architectures for STEM/CS.</a:t>
-            </a:r>
-          </a:p>
-        </p:txBody>
-      </p:sp>
-      <p:sp>
-        <p:nvSpPr>
-          <p:cNvPr id="14" name="Rounded Rectangle 13"/>
+              <a:t>ChatGPT dumps 800-word walls of text that cause immediate student eye glaze. Prismatic bounds answers to 2 sentences and forces active retrieval.</a:t>
+            </a:r>
+          </a:p>
+        </p:txBody>
+      </p:sp>
+      <p:sp>
+        <p:nvSpPr>
+          <p:cNvPr id="11" name="Rounded Rectangle 10"/>
           <p:cNvSpPr/>
           <p:nvPr/>
         </p:nvSpPr>
         <p:spPr>
           <a:xfrm>
-            <a:off x="731520" y="4069079"/>
-            <a:ext cx="5212080" cy="2103120"/>
+            <a:off x="4389120" y="1645920"/>
+            <a:ext cx="3383280" cy="4480560"/>
           </a:xfrm>
           <a:prstGeom prst="roundRect">
             <a:avLst/>
           </a:prstGeom>
           <a:solidFill>
-            <a:srgbClr val="121826"/>
+            <a:srgbClr val="101622"/>
           </a:solidFill>
-          <a:ln w="15240">
+          <a:ln w="16510">
             <a:solidFill>
-              <a:srgbClr val="283855"/>
+              <a:srgbClr val="202D46"/>
             </a:solidFill>
           </a:ln>
         </p:spPr>
@@ -5569,14 +6408,14 @@
       </p:sp>
       <p:sp>
         <p:nvSpPr>
-          <p:cNvPr id="15" name="TextBox 14"/>
+          <p:cNvPr id="12" name="TextBox 11"/>
           <p:cNvSpPr txBox="1"/>
           <p:nvPr/>
         </p:nvSpPr>
         <p:spPr>
           <a:xfrm>
-            <a:off x="1005840" y="4297679"/>
-            <a:ext cx="4663440" cy="320040"/>
+            <a:off x="4663440" y="2011680"/>
+            <a:ext cx="2834640" cy="320040"/>
           </a:xfrm>
           <a:prstGeom prst="rect">
             <a:avLst/>
@@ -5590,29 +6429,29 @@
           <a:lstStyle/>
           <a:p>
             <a:pPr>
-              <a:defRPr sz="1300" b="1">
-                <a:solidFill>
-                  <a:srgbClr val="10B981"/>
+              <a:defRPr sz="1200" b="1">
+                <a:solidFill>
+                  <a:srgbClr val="FF6B6B"/>
                 </a:solidFill>
                 <a:latin typeface="Segoe UI"/>
               </a:defRPr>
             </a:pPr>
             <a:r>
-              <a:t>SPECTRUM 3: SOCRATIC SPARRING</a:t>
-            </a:r>
-          </a:p>
-        </p:txBody>
-      </p:sp>
-      <p:sp>
-        <p:nvSpPr>
-          <p:cNvPr id="16" name="TextBox 15"/>
+              <a:t>VS. $80/HR TUTORING</a:t>
+            </a:r>
+          </a:p>
+        </p:txBody>
+      </p:sp>
+      <p:sp>
+        <p:nvSpPr>
+          <p:cNvPr id="13" name="TextBox 12"/>
           <p:cNvSpPr txBox="1"/>
           <p:nvPr/>
         </p:nvSpPr>
         <p:spPr>
           <a:xfrm>
-            <a:off x="1005840" y="4663439"/>
-            <a:ext cx="4663440" cy="365760"/>
+            <a:off x="4663440" y="2423160"/>
+            <a:ext cx="2834640" cy="502920"/>
           </a:xfrm>
           <a:prstGeom prst="rect">
             <a:avLst/>
@@ -5634,21 +6473,21 @@
               </a:defRPr>
             </a:pPr>
             <a:r>
-              <a:t>Active Retrieval Partner</a:t>
-            </a:r>
-          </a:p>
-        </p:txBody>
-      </p:sp>
-      <p:sp>
-        <p:nvSpPr>
-          <p:cNvPr id="17" name="TextBox 16"/>
+              <a:t>Zero Financial Gatekeeping</a:t>
+            </a:r>
+          </a:p>
+        </p:txBody>
+      </p:sp>
+      <p:sp>
+        <p:nvSpPr>
+          <p:cNvPr id="14" name="TextBox 13"/>
           <p:cNvSpPr txBox="1"/>
           <p:nvPr/>
         </p:nvSpPr>
         <p:spPr>
           <a:xfrm>
-            <a:off x="1005840" y="5120639"/>
-            <a:ext cx="4663440" cy="868680"/>
+            <a:off x="4663440" y="3017520"/>
+            <a:ext cx="2834640" cy="2651760"/>
           </a:xfrm>
           <a:prstGeom prst="rect">
             <a:avLst/>
@@ -5662,7 +6501,7 @@
           <a:lstStyle/>
           <a:p>
             <a:pPr>
-              <a:defRPr sz="1100">
+              <a:defRPr sz="1200">
                 <a:solidFill>
                   <a:srgbClr val="94A3B8"/>
                 </a:solidFill>
@@ -5670,31 +6509,31 @@
               </a:defRPr>
             </a:pPr>
             <a:r>
-              <a:t>Chatbot strictly limited to 2 sentences; never lectures; fires progressive edge cases to force active recall.</a:t>
-            </a:r>
-          </a:p>
-        </p:txBody>
-      </p:sp>
-      <p:sp>
-        <p:nvSpPr>
-          <p:cNvPr id="18" name="Rounded Rectangle 17"/>
+              <a:t>Private tutors cost $80/hr; university office hours are 2 hours a week. Prismatic gives every student 24/7 elite adaptive tutoring for pennies on Bedrock.</a:t>
+            </a:r>
+          </a:p>
+        </p:txBody>
+      </p:sp>
+      <p:sp>
+        <p:nvSpPr>
+          <p:cNvPr id="15" name="Rounded Rectangle 14"/>
           <p:cNvSpPr/>
           <p:nvPr/>
         </p:nvSpPr>
         <p:spPr>
           <a:xfrm>
-            <a:off x="6217920" y="4069079"/>
-            <a:ext cx="5212080" cy="2103120"/>
+            <a:off x="8046720" y="1645920"/>
+            <a:ext cx="3383280" cy="4480560"/>
           </a:xfrm>
           <a:prstGeom prst="roundRect">
             <a:avLst/>
           </a:prstGeom>
           <a:solidFill>
-            <a:srgbClr val="121826"/>
+            <a:srgbClr val="101622"/>
           </a:solidFill>
-          <a:ln w="15240">
+          <a:ln w="16510">
             <a:solidFill>
-              <a:srgbClr val="283855"/>
+              <a:srgbClr val="10B981"/>
             </a:solidFill>
           </a:ln>
         </p:spPr>
@@ -5722,14 +6561,14 @@
       </p:sp>
       <p:sp>
         <p:nvSpPr>
-          <p:cNvPr id="19" name="TextBox 18"/>
+          <p:cNvPr id="16" name="TextBox 15"/>
           <p:cNvSpPr txBox="1"/>
           <p:nvPr/>
         </p:nvSpPr>
         <p:spPr>
           <a:xfrm>
-            <a:off x="6492240" y="4297679"/>
-            <a:ext cx="4663440" cy="320040"/>
+            <a:off x="8321040" y="2011680"/>
+            <a:ext cx="2834640" cy="320040"/>
           </a:xfrm>
           <a:prstGeom prst="rect">
             <a:avLst/>
@@ -5743,29 +6582,29 @@
           <a:lstStyle/>
           <a:p>
             <a:pPr>
-              <a:defRPr sz="1300" b="1">
-                <a:solidFill>
-                  <a:srgbClr val="F59E0B"/>
+              <a:defRPr sz="1200" b="1">
+                <a:solidFill>
+                  <a:srgbClr val="34D399"/>
                 </a:solidFill>
                 <a:latin typeface="Segoe UI"/>
               </a:defRPr>
             </a:pPr>
             <a:r>
-              <a:t>SPECTRUM 4: EXAM TRAP DECK</a:t>
-            </a:r>
-          </a:p>
-        </p:txBody>
-      </p:sp>
-      <p:sp>
-        <p:nvSpPr>
-          <p:cNvPr id="20" name="TextBox 19"/>
+              <a:t>VS. STATIC SLIDES</a:t>
+            </a:r>
+          </a:p>
+        </p:txBody>
+      </p:sp>
+      <p:sp>
+        <p:nvSpPr>
+          <p:cNvPr id="17" name="TextBox 16"/>
           <p:cNvSpPr txBox="1"/>
           <p:nvPr/>
         </p:nvSpPr>
         <p:spPr>
           <a:xfrm>
-            <a:off x="6492240" y="4663439"/>
-            <a:ext cx="4663440" cy="365760"/>
+            <a:off x="8321040" y="2423160"/>
+            <a:ext cx="2834640" cy="502920"/>
           </a:xfrm>
           <a:prstGeom prst="rect">
             <a:avLst/>
@@ -5787,21 +6626,21 @@
               </a:defRPr>
             </a:pPr>
             <a:r>
-              <a:t>4-Slide Micro-Presentation</a:t>
-            </a:r>
-          </a:p>
-        </p:txBody>
-      </p:sp>
-      <p:sp>
-        <p:nvSpPr>
-          <p:cNvPr id="21" name="TextBox 20"/>
+              <a:t>Dynamic Cognitive Fit</a:t>
+            </a:r>
+          </a:p>
+        </p:txBody>
+      </p:sp>
+      <p:sp>
+        <p:nvSpPr>
+          <p:cNvPr id="18" name="TextBox 17"/>
           <p:cNvSpPr txBox="1"/>
           <p:nvPr/>
         </p:nvSpPr>
         <p:spPr>
           <a:xfrm>
-            <a:off x="6492240" y="5120639"/>
-            <a:ext cx="4663440" cy="868680"/>
+            <a:off x="8321040" y="3017520"/>
+            <a:ext cx="2834640" cy="2651760"/>
           </a:xfrm>
           <a:prstGeom prst="rect">
             <a:avLst/>
@@ -5815,7 +6654,7 @@
           <a:lstStyle/>
           <a:p>
             <a:pPr>
-              <a:defRPr sz="1100">
+              <a:defRPr sz="1200">
                 <a:solidFill>
                   <a:srgbClr val="94A3B8"/>
                 </a:solidFill>
@@ -5823,7 +6662,7 @@
               </a:defRPr>
             </a:pPr>
             <a:r>
-              <a:t>Distills the topic into 4 slides exposing the exact tricks and traps professors test on Midterm #2.</a:t>
+              <a:t>Eliminates task paralysis for ADHD, visual, and conceptual learners through a 30-second diagnostic triage.</a:t>
             </a:r>
           </a:p>
         </p:txBody>
@@ -5861,7 +6700,7 @@
             <a:avLst/>
           </a:prstGeom>
           <a:solidFill>
-            <a:srgbClr val="0B0F19"/>
+            <a:srgbClr val="080B13"/>
           </a:solidFill>
           <a:ln>
             <a:noFill/>
@@ -5897,8 +6736,8 @@
         </p:nvSpPr>
         <p:spPr>
           <a:xfrm>
-            <a:off x="731520" y="365760"/>
-            <a:ext cx="10698480" cy="320040"/>
+            <a:off x="731520" y="347472"/>
+            <a:ext cx="8229600" cy="292608"/>
           </a:xfrm>
           <a:prstGeom prst="rect">
             <a:avLst/>
@@ -5914,109 +6753,37 @@
             <a:pPr>
               <a:defRPr sz="1100" b="1">
                 <a:solidFill>
-                  <a:srgbClr val="00D4FF"/>
+                  <a:srgbClr val="00E5FF"/>
                 </a:solidFill>
                 <a:latin typeface="Segoe UI"/>
               </a:defRPr>
             </a:pPr>
             <a:r>
-              <a:t>MARKET OPPORTUNITY &amp; CLOSING ASK</a:t>
-            </a:r>
-          </a:p>
-        </p:txBody>
-      </p:sp>
-      <p:sp>
-        <p:nvSpPr>
-          <p:cNvPr id="4" name="TextBox 3"/>
-          <p:cNvSpPr txBox="1"/>
-          <p:nvPr/>
-        </p:nvSpPr>
-        <p:spPr>
-          <a:xfrm>
-            <a:off x="731520" y="685800"/>
-            <a:ext cx="10698480" cy="502920"/>
-          </a:xfrm>
-          <a:prstGeom prst="rect">
-            <a:avLst/>
-          </a:prstGeom>
-          <a:noFill/>
-        </p:spPr>
-        <p:txBody>
-          <a:bodyPr wrap="square" lIns="0" tIns="0" rIns="0" bIns="0">
-            <a:spAutoFit/>
-          </a:bodyPr>
-          <a:lstStyle/>
-          <a:p>
-            <a:pPr>
-              <a:defRPr sz="2200" b="1">
-                <a:solidFill>
-                  <a:srgbClr val="FFFFFF"/>
-                </a:solidFill>
-                <a:latin typeface="Segoe UI"/>
-              </a:defRPr>
-            </a:pPr>
-            <a:r>
-              <a:t>Democratizing Elite Tutoring: From Luxury to Student Right</a:t>
-            </a:r>
-          </a:p>
-        </p:txBody>
-      </p:sp>
-      <p:sp>
-        <p:nvSpPr>
-          <p:cNvPr id="5" name="TextBox 4"/>
-          <p:cNvSpPr txBox="1"/>
-          <p:nvPr/>
-        </p:nvSpPr>
-        <p:spPr>
-          <a:xfrm>
-            <a:off x="731520" y="1234440"/>
-            <a:ext cx="10698480" cy="320040"/>
-          </a:xfrm>
-          <a:prstGeom prst="rect">
-            <a:avLst/>
-          </a:prstGeom>
-          <a:noFill/>
-        </p:spPr>
-        <p:txBody>
-          <a:bodyPr wrap="square" lIns="0" tIns="0" rIns="0" bIns="0">
-            <a:spAutoFit/>
-          </a:bodyPr>
-          <a:lstStyle/>
-          <a:p>
-            <a:pPr>
-              <a:defRPr sz="1200">
-                <a:solidFill>
-                  <a:srgbClr val="94A3B8"/>
-                </a:solidFill>
-                <a:latin typeface="Segoe UI"/>
-              </a:defRPr>
-            </a:pPr>
-            <a:r>
-              <a:t>The $80/hr private tutor in every student's pocket on Amazon Quick</a:t>
-            </a:r>
-          </a:p>
-        </p:txBody>
-      </p:sp>
-      <p:sp>
-        <p:nvSpPr>
-          <p:cNvPr id="6" name="Rounded Rectangle 5"/>
+              <a:t>SEGMENT 5: THE CLOSE (15S)</a:t>
+            </a:r>
+          </a:p>
+        </p:txBody>
+      </p:sp>
+      <p:sp>
+        <p:nvSpPr>
+          <p:cNvPr id="4" name="Rounded Rectangle 3"/>
           <p:cNvSpPr/>
           <p:nvPr/>
         </p:nvSpPr>
         <p:spPr>
           <a:xfrm>
-            <a:off x="731520" y="1691640"/>
-            <a:ext cx="3383280" cy="2011680"/>
+            <a:off x="9448495" y="320040"/>
+            <a:ext cx="2011680" cy="347472"/>
           </a:xfrm>
           <a:prstGeom prst="roundRect">
             <a:avLst/>
           </a:prstGeom>
           <a:solidFill>
-            <a:srgbClr val="121826"/>
+            <a:srgbClr val="161E30"/>
           </a:solidFill>
           <a:ln w="15240">
             <a:solidFill>
-              <a:srgbClr val="283855"/>
+              <a:srgbClr val="00E5FF"/>
             </a:solidFill>
           </a:ln>
         </p:spPr>
@@ -6035,23 +6802,33 @@
           </a:fontRef>
         </p:style>
         <p:txBody>
-          <a:bodyPr rtlCol="0" anchor="ctr"/>
-          <a:lstStyle/>
-          <a:p>
-            <a:pPr algn="ctr"/>
-          </a:p>
-        </p:txBody>
-      </p:sp>
-      <p:sp>
-        <p:nvSpPr>
-          <p:cNvPr id="7" name="TextBox 6"/>
+          <a:bodyPr rtlCol="0" anchor="ctr" lIns="0" rIns="0" tIns="0" bIns="0"/>
+          <a:lstStyle/>
+          <a:p>
+            <a:pPr algn="ctr">
+              <a:defRPr sz="1000" b="1">
+                <a:solidFill>
+                  <a:srgbClr val="00E5FF"/>
+                </a:solidFill>
+                <a:latin typeface="Segoe UI"/>
+              </a:defRPr>
+            </a:pPr>
+            <a:r>
+              <a:t>15 SECONDS</a:t>
+            </a:r>
+          </a:p>
+        </p:txBody>
+      </p:sp>
+      <p:sp>
+        <p:nvSpPr>
+          <p:cNvPr id="5" name="TextBox 4"/>
           <p:cNvSpPr txBox="1"/>
           <p:nvPr/>
         </p:nvSpPr>
         <p:spPr>
           <a:xfrm>
-            <a:off x="960120" y="1920240"/>
-            <a:ext cx="2926080" cy="457200"/>
+            <a:off x="731520" y="658368"/>
+            <a:ext cx="10728655" cy="502920"/>
           </a:xfrm>
           <a:prstGeom prst="rect">
             <a:avLst/>
@@ -6059,35 +6836,35 @@
           <a:noFill/>
         </p:spPr>
         <p:txBody>
-          <a:bodyPr wrap="none">
+          <a:bodyPr wrap="square" lIns="0" tIns="0" rIns="0" bIns="0">
             <a:spAutoFit/>
           </a:bodyPr>
           <a:lstStyle/>
           <a:p>
             <a:pPr>
-              <a:defRPr sz="2400" b="1">
-                <a:solidFill>
-                  <a:srgbClr val="00D4FF"/>
+              <a:defRPr sz="2300" b="1">
+                <a:solidFill>
+                  <a:srgbClr val="FFFFFF"/>
                 </a:solidFill>
                 <a:latin typeface="Segoe UI"/>
               </a:defRPr>
             </a:pPr>
             <a:r>
-              <a:t>20M+</a:t>
-            </a:r>
-          </a:p>
-        </p:txBody>
-      </p:sp>
-      <p:sp>
-        <p:nvSpPr>
-          <p:cNvPr id="8" name="TextBox 7"/>
+              <a:t>'With More Time We'd Add...' &amp; The Shark Tank Verdict</a:t>
+            </a:r>
+          </a:p>
+        </p:txBody>
+      </p:sp>
+      <p:sp>
+        <p:nvSpPr>
+          <p:cNvPr id="6" name="TextBox 5"/>
           <p:cNvSpPr txBox="1"/>
           <p:nvPr/>
         </p:nvSpPr>
         <p:spPr>
           <a:xfrm>
-            <a:off x="960120" y="2423160"/>
-            <a:ext cx="2926080" cy="320040"/>
+            <a:off x="731520" y="1188720"/>
+            <a:ext cx="10728655" cy="320040"/>
           </a:xfrm>
           <a:prstGeom prst="rect">
             <a:avLst/>
@@ -6095,81 +6872,45 @@
           <a:noFill/>
         </p:spPr>
         <p:txBody>
-          <a:bodyPr wrap="none">
+          <a:bodyPr wrap="square" lIns="0" tIns="0" rIns="0" bIns="0">
             <a:spAutoFit/>
           </a:bodyPr>
           <a:lstStyle/>
           <a:p>
             <a:pPr>
-              <a:defRPr sz="1300" b="1">
-                <a:solidFill>
-                  <a:srgbClr val="FFFFFF"/>
+              <a:defRPr sz="1200">
+                <a:solidFill>
+                  <a:srgbClr val="94A3B8"/>
                 </a:solidFill>
                 <a:latin typeface="Segoe UI"/>
               </a:defRPr>
             </a:pPr>
             <a:r>
-              <a:t>U.S. Undergrads</a:t>
-            </a:r>
-          </a:p>
-        </p:txBody>
-      </p:sp>
-      <p:sp>
-        <p:nvSpPr>
-          <p:cNvPr id="9" name="TextBox 8"/>
-          <p:cNvSpPr txBox="1"/>
-          <p:nvPr/>
-        </p:nvSpPr>
-        <p:spPr>
-          <a:xfrm>
-            <a:off x="960120" y="2788920"/>
-            <a:ext cx="2926080" cy="777240"/>
-          </a:xfrm>
-          <a:prstGeom prst="rect">
-            <a:avLst/>
-          </a:prstGeom>
-          <a:noFill/>
-        </p:spPr>
-        <p:txBody>
-          <a:bodyPr wrap="none">
-            <a:spAutoFit/>
-          </a:bodyPr>
-          <a:lstStyle/>
-          <a:p>
-            <a:pPr>
-              <a:defRPr sz="1050">
-                <a:solidFill>
-                  <a:srgbClr val="94A3B8"/>
-                </a:solidFill>
-                <a:latin typeface="Segoe UI"/>
-              </a:defRPr>
-            </a:pPr>
-            <a:r>
-              <a:t>Struggling with post-AI curriculum shifts and dense, fast-moving lectures.</a:t>
-            </a:r>
-          </a:p>
-        </p:txBody>
-      </p:sp>
-      <p:sp>
-        <p:nvSpPr>
-          <p:cNvPr id="10" name="Rounded Rectangle 9"/>
+              <a:t>Scoring 100% across the 4 official Shark metrics: Creativity, Usefulness, Execution &amp; Teamwork</a:t>
+            </a:r>
+          </a:p>
+        </p:txBody>
+      </p:sp>
+      <p:sp>
+        <p:nvSpPr>
+          <p:cNvPr id="7" name="Rounded Rectangle 6"/>
           <p:cNvSpPr/>
           <p:nvPr/>
         </p:nvSpPr>
         <p:spPr>
           <a:xfrm>
-            <a:off x="4389120" y="1691640"/>
-            <a:ext cx="3383280" cy="2011680"/>
+            <a:off x="731520" y="1645920"/>
+            <a:ext cx="2468880" cy="1417320"/>
           </a:xfrm>
           <a:prstGeom prst="roundRect">
             <a:avLst/>
           </a:prstGeom>
           <a:solidFill>
-            <a:srgbClr val="121826"/>
+            <a:srgbClr val="101622"/>
           </a:solidFill>
-          <a:ln w="15240">
+          <a:ln w="12700">
             <a:solidFill>
-              <a:srgbClr val="283855"/>
+              <a:srgbClr val="202D46"/>
             </a:solidFill>
           </a:ln>
         </p:spPr>
@@ -6197,14 +6938,14 @@
       </p:sp>
       <p:sp>
         <p:nvSpPr>
-          <p:cNvPr id="11" name="TextBox 10"/>
+          <p:cNvPr id="8" name="TextBox 7"/>
           <p:cNvSpPr txBox="1"/>
           <p:nvPr/>
         </p:nvSpPr>
         <p:spPr>
           <a:xfrm>
-            <a:off x="4617720" y="1920240"/>
-            <a:ext cx="2926080" cy="457200"/>
+            <a:off x="914400" y="1783080"/>
+            <a:ext cx="2103120" cy="320040"/>
           </a:xfrm>
           <a:prstGeom prst="rect">
             <a:avLst/>
@@ -6218,29 +6959,29 @@
           <a:lstStyle/>
           <a:p>
             <a:pPr>
-              <a:defRPr sz="2400" b="1">
-                <a:solidFill>
-                  <a:srgbClr val="F43F5E"/>
+              <a:defRPr sz="1200" b="1">
+                <a:solidFill>
+                  <a:srgbClr val="00E5FF"/>
                 </a:solidFill>
                 <a:latin typeface="Segoe UI"/>
               </a:defRPr>
             </a:pPr>
             <a:r>
-              <a:t>$80 / HR</a:t>
-            </a:r>
-          </a:p>
-        </p:txBody>
-      </p:sp>
-      <p:sp>
-        <p:nvSpPr>
-          <p:cNvPr id="12" name="TextBox 11"/>
+              <a:t>CREATIVITY</a:t>
+            </a:r>
+          </a:p>
+        </p:txBody>
+      </p:sp>
+      <p:sp>
+        <p:nvSpPr>
+          <p:cNvPr id="9" name="TextBox 8"/>
           <p:cNvSpPr txBox="1"/>
           <p:nvPr/>
         </p:nvSpPr>
         <p:spPr>
           <a:xfrm>
-            <a:off x="4617720" y="2423160"/>
-            <a:ext cx="2926080" cy="320040"/>
+            <a:off x="914400" y="2148840"/>
+            <a:ext cx="2103120" cy="822960"/>
           </a:xfrm>
           <a:prstGeom prst="rect">
             <a:avLst/>
@@ -6254,75 +6995,39 @@
           <a:lstStyle/>
           <a:p>
             <a:pPr>
-              <a:defRPr sz="1300" b="1">
-                <a:solidFill>
-                  <a:srgbClr val="FFFFFF"/>
+              <a:defRPr sz="1050">
+                <a:solidFill>
+                  <a:srgbClr val="F1F5F9"/>
                 </a:solidFill>
                 <a:latin typeface="Segoe UI"/>
               </a:defRPr>
             </a:pPr>
             <a:r>
-              <a:t>Private Tutoring Cost</a:t>
-            </a:r>
-          </a:p>
-        </p:txBody>
-      </p:sp>
-      <p:sp>
-        <p:nvSpPr>
-          <p:cNvPr id="13" name="TextBox 12"/>
-          <p:cNvSpPr txBox="1"/>
-          <p:nvPr/>
-        </p:nvSpPr>
-        <p:spPr>
-          <a:xfrm>
-            <a:off x="4617720" y="2788920"/>
-            <a:ext cx="2926080" cy="777240"/>
-          </a:xfrm>
-          <a:prstGeom prst="rect">
-            <a:avLst/>
-          </a:prstGeom>
-          <a:noFill/>
-        </p:spPr>
-        <p:txBody>
-          <a:bodyPr wrap="none">
-            <a:spAutoFit/>
-          </a:bodyPr>
-          <a:lstStyle/>
-          <a:p>
-            <a:pPr>
-              <a:defRPr sz="1050">
-                <a:solidFill>
-                  <a:srgbClr val="94A3B8"/>
-                </a:solidFill>
-                <a:latin typeface="Segoe UI"/>
-              </a:defRPr>
-            </a:pPr>
-            <a:r>
-              <a:t>Traditional tutoring is financially gatekept; Prismatic costs pennies on Bedrock.</a:t>
-            </a:r>
-          </a:p>
-        </p:txBody>
-      </p:sp>
-      <p:sp>
-        <p:nvSpPr>
-          <p:cNvPr id="14" name="Rounded Rectangle 13"/>
+              <a:t>Fresh cognitive refraction metaphor</a:t>
+            </a:r>
+          </a:p>
+        </p:txBody>
+      </p:sp>
+      <p:sp>
+        <p:nvSpPr>
+          <p:cNvPr id="10" name="Rounded Rectangle 9"/>
           <p:cNvSpPr/>
           <p:nvPr/>
         </p:nvSpPr>
         <p:spPr>
           <a:xfrm>
-            <a:off x="8046720" y="1691640"/>
-            <a:ext cx="3383280" cy="2011680"/>
+            <a:off x="3474720" y="1645920"/>
+            <a:ext cx="2468880" cy="1417320"/>
           </a:xfrm>
           <a:prstGeom prst="roundRect">
             <a:avLst/>
           </a:prstGeom>
           <a:solidFill>
-            <a:srgbClr val="121826"/>
+            <a:srgbClr val="101622"/>
           </a:solidFill>
-          <a:ln w="15240">
+          <a:ln w="12700">
             <a:solidFill>
-              <a:srgbClr val="283855"/>
+              <a:srgbClr val="202D46"/>
             </a:solidFill>
           </a:ln>
         </p:spPr>
@@ -6350,14 +7055,14 @@
       </p:sp>
       <p:sp>
         <p:nvSpPr>
-          <p:cNvPr id="15" name="TextBox 14"/>
+          <p:cNvPr id="11" name="TextBox 10"/>
           <p:cNvSpPr txBox="1"/>
           <p:nvPr/>
         </p:nvSpPr>
         <p:spPr>
           <a:xfrm>
-            <a:off x="8275320" y="1920240"/>
-            <a:ext cx="2926080" cy="457200"/>
+            <a:off x="3657600" y="1783080"/>
+            <a:ext cx="2103120" cy="320040"/>
           </a:xfrm>
           <a:prstGeom prst="rect">
             <a:avLst/>
@@ -6371,29 +7076,29 @@
           <a:lstStyle/>
           <a:p>
             <a:pPr>
-              <a:defRPr sz="2400" b="1">
-                <a:solidFill>
-                  <a:srgbClr val="10B981"/>
+              <a:defRPr sz="1200" b="1">
+                <a:solidFill>
+                  <a:srgbClr val="34D399"/>
                 </a:solidFill>
                 <a:latin typeface="Segoe UI"/>
               </a:defRPr>
             </a:pPr>
             <a:r>
-              <a:t>100% NO-CODE</a:t>
-            </a:r>
-          </a:p>
-        </p:txBody>
-      </p:sp>
-      <p:sp>
-        <p:nvSpPr>
-          <p:cNvPr id="16" name="TextBox 15"/>
+              <a:t>USEFULNESS</a:t>
+            </a:r>
+          </a:p>
+        </p:txBody>
+      </p:sp>
+      <p:sp>
+        <p:nvSpPr>
+          <p:cNvPr id="12" name="TextBox 11"/>
           <p:cNvSpPr txBox="1"/>
           <p:nvPr/>
         </p:nvSpPr>
         <p:spPr>
           <a:xfrm>
-            <a:off x="8275320" y="2423160"/>
-            <a:ext cx="2926080" cy="320040"/>
+            <a:off x="3657600" y="2148840"/>
+            <a:ext cx="2103120" cy="822960"/>
           </a:xfrm>
           <a:prstGeom prst="rect">
             <a:avLst/>
@@ -6407,75 +7112,39 @@
           <a:lstStyle/>
           <a:p>
             <a:pPr>
-              <a:defRPr sz="1300" b="1">
-                <a:solidFill>
-                  <a:srgbClr val="FFFFFF"/>
+              <a:defRPr sz="1050">
+                <a:solidFill>
+                  <a:srgbClr val="F1F5F9"/>
                 </a:solidFill>
                 <a:latin typeface="Segoe UI"/>
               </a:defRPr>
             </a:pPr>
             <a:r>
-              <a:t>Amazon Quick Power</a:t>
-            </a:r>
-          </a:p>
-        </p:txBody>
-      </p:sp>
-      <p:sp>
-        <p:nvSpPr>
-          <p:cNvPr id="17" name="TextBox 16"/>
-          <p:cNvSpPr txBox="1"/>
-          <p:nvPr/>
-        </p:nvSpPr>
-        <p:spPr>
-          <a:xfrm>
-            <a:off x="8275320" y="2788920"/>
-            <a:ext cx="2926080" cy="777240"/>
-          </a:xfrm>
-          <a:prstGeom prst="rect">
-            <a:avLst/>
-          </a:prstGeom>
-          <a:noFill/>
-        </p:spPr>
-        <p:txBody>
-          <a:bodyPr wrap="none">
-            <a:spAutoFit/>
-          </a:bodyPr>
-          <a:lstStyle/>
-          <a:p>
-            <a:pPr>
-              <a:defRPr sz="1050">
-                <a:solidFill>
-                  <a:srgbClr val="94A3B8"/>
-                </a:solidFill>
-                <a:latin typeface="Segoe UI"/>
-              </a:defRPr>
-            </a:pPr>
-            <a:r>
-              <a:t>Shipped a working, interactive multi-widget app in 60 minutes flat.</a:t>
-            </a:r>
-          </a:p>
-        </p:txBody>
-      </p:sp>
-      <p:sp>
-        <p:nvSpPr>
-          <p:cNvPr id="18" name="Rounded Rectangle 17"/>
+              <a:t>Solves dorm paralysis &amp; exam panic</a:t>
+            </a:r>
+          </a:p>
+        </p:txBody>
+      </p:sp>
+      <p:sp>
+        <p:nvSpPr>
+          <p:cNvPr id="13" name="Rounded Rectangle 12"/>
           <p:cNvSpPr/>
           <p:nvPr/>
         </p:nvSpPr>
         <p:spPr>
           <a:xfrm>
-            <a:off x="731520" y="3977639"/>
-            <a:ext cx="10698480" cy="2194560"/>
+            <a:off x="6217920" y="1645920"/>
+            <a:ext cx="2468880" cy="1417320"/>
           </a:xfrm>
           <a:prstGeom prst="roundRect">
             <a:avLst/>
           </a:prstGeom>
           <a:solidFill>
-            <a:srgbClr val="1A2234"/>
+            <a:srgbClr val="101622"/>
           </a:solidFill>
-          <a:ln w="15240">
+          <a:ln w="12700">
             <a:solidFill>
-              <a:srgbClr val="00D4FF"/>
+              <a:srgbClr val="202D46"/>
             </a:solidFill>
           </a:ln>
         </p:spPr>
@@ -6503,14 +7172,248 @@
       </p:sp>
       <p:sp>
         <p:nvSpPr>
-          <p:cNvPr id="19" name="TextBox 18"/>
+          <p:cNvPr id="14" name="TextBox 13"/>
           <p:cNvSpPr txBox="1"/>
           <p:nvPr/>
         </p:nvSpPr>
         <p:spPr>
           <a:xfrm>
-            <a:off x="1097280" y="4206240"/>
-            <a:ext cx="9966960" cy="1737360"/>
+            <a:off x="6400800" y="1783080"/>
+            <a:ext cx="2103120" cy="320040"/>
+          </a:xfrm>
+          <a:prstGeom prst="rect">
+            <a:avLst/>
+          </a:prstGeom>
+          <a:noFill/>
+        </p:spPr>
+        <p:txBody>
+          <a:bodyPr wrap="none">
+            <a:spAutoFit/>
+          </a:bodyPr>
+          <a:lstStyle/>
+          <a:p>
+            <a:pPr>
+              <a:defRPr sz="1200" b="1">
+                <a:solidFill>
+                  <a:srgbClr val="B464FF"/>
+                </a:solidFill>
+                <a:latin typeface="Segoe UI"/>
+              </a:defRPr>
+            </a:pPr>
+            <a:r>
+              <a:t>EXECUTION</a:t>
+            </a:r>
+          </a:p>
+        </p:txBody>
+      </p:sp>
+      <p:sp>
+        <p:nvSpPr>
+          <p:cNvPr id="15" name="TextBox 14"/>
+          <p:cNvSpPr txBox="1"/>
+          <p:nvPr/>
+        </p:nvSpPr>
+        <p:spPr>
+          <a:xfrm>
+            <a:off x="6400800" y="2148840"/>
+            <a:ext cx="2103120" cy="822960"/>
+          </a:xfrm>
+          <a:prstGeom prst="rect">
+            <a:avLst/>
+          </a:prstGeom>
+          <a:noFill/>
+        </p:spPr>
+        <p:txBody>
+          <a:bodyPr wrap="none">
+            <a:spAutoFit/>
+          </a:bodyPr>
+          <a:lstStyle/>
+          <a:p>
+            <a:pPr>
+              <a:defRPr sz="1050">
+                <a:solidFill>
+                  <a:srgbClr val="F1F5F9"/>
+                </a:solidFill>
+                <a:latin typeface="Segoe UI"/>
+              </a:defRPr>
+            </a:pPr>
+            <a:r>
+              <a:t>6-widget pipeline on Amazon Quick</a:t>
+            </a:r>
+          </a:p>
+        </p:txBody>
+      </p:sp>
+      <p:sp>
+        <p:nvSpPr>
+          <p:cNvPr id="16" name="Rounded Rectangle 15"/>
+          <p:cNvSpPr/>
+          <p:nvPr/>
+        </p:nvSpPr>
+        <p:spPr>
+          <a:xfrm>
+            <a:off x="8961120" y="1645920"/>
+            <a:ext cx="2468880" cy="1417320"/>
+          </a:xfrm>
+          <a:prstGeom prst="roundRect">
+            <a:avLst/>
+          </a:prstGeom>
+          <a:solidFill>
+            <a:srgbClr val="101622"/>
+          </a:solidFill>
+          <a:ln w="12700">
+            <a:solidFill>
+              <a:srgbClr val="202D46"/>
+            </a:solidFill>
+          </a:ln>
+        </p:spPr>
+        <p:style>
+          <a:lnRef idx="1">
+            <a:schemeClr val="accent1"/>
+          </a:lnRef>
+          <a:fillRef idx="3">
+            <a:schemeClr val="accent1"/>
+          </a:fillRef>
+          <a:effectRef idx="2">
+            <a:schemeClr val="accent1"/>
+          </a:effectRef>
+          <a:fontRef idx="minor">
+            <a:schemeClr val="lt1"/>
+          </a:fontRef>
+        </p:style>
+        <p:txBody>
+          <a:bodyPr rtlCol="0" anchor="ctr"/>
+          <a:lstStyle/>
+          <a:p>
+            <a:pPr algn="ctr"/>
+          </a:p>
+        </p:txBody>
+      </p:sp>
+      <p:sp>
+        <p:nvSpPr>
+          <p:cNvPr id="17" name="TextBox 16"/>
+          <p:cNvSpPr txBox="1"/>
+          <p:nvPr/>
+        </p:nvSpPr>
+        <p:spPr>
+          <a:xfrm>
+            <a:off x="9144000" y="1783080"/>
+            <a:ext cx="2103120" cy="320040"/>
+          </a:xfrm>
+          <a:prstGeom prst="rect">
+            <a:avLst/>
+          </a:prstGeom>
+          <a:noFill/>
+        </p:spPr>
+        <p:txBody>
+          <a:bodyPr wrap="none">
+            <a:spAutoFit/>
+          </a:bodyPr>
+          <a:lstStyle/>
+          <a:p>
+            <a:pPr>
+              <a:defRPr sz="1200" b="1">
+                <a:solidFill>
+                  <a:srgbClr val="FBBF24"/>
+                </a:solidFill>
+                <a:latin typeface="Segoe UI"/>
+              </a:defRPr>
+            </a:pPr>
+            <a:r>
+              <a:t>TEAMWORK</a:t>
+            </a:r>
+          </a:p>
+        </p:txBody>
+      </p:sp>
+      <p:sp>
+        <p:nvSpPr>
+          <p:cNvPr id="18" name="TextBox 17"/>
+          <p:cNvSpPr txBox="1"/>
+          <p:nvPr/>
+        </p:nvSpPr>
+        <p:spPr>
+          <a:xfrm>
+            <a:off x="9144000" y="2148840"/>
+            <a:ext cx="2103120" cy="822960"/>
+          </a:xfrm>
+          <a:prstGeom prst="rect">
+            <a:avLst/>
+          </a:prstGeom>
+          <a:noFill/>
+        </p:spPr>
+        <p:txBody>
+          <a:bodyPr wrap="none">
+            <a:spAutoFit/>
+          </a:bodyPr>
+          <a:lstStyle/>
+          <a:p>
+            <a:pPr>
+              <a:defRPr sz="1050">
+                <a:solidFill>
+                  <a:srgbClr val="F1F5F9"/>
+                </a:solidFill>
+                <a:latin typeface="Segoe UI"/>
+              </a:defRPr>
+            </a:pPr>
+            <a:r>
+              <a:t>10 teammates with active stage roles</a:t>
+            </a:r>
+          </a:p>
+        </p:txBody>
+      </p:sp>
+      <p:sp>
+        <p:nvSpPr>
+          <p:cNvPr id="19" name="Rounded Rectangle 18"/>
+          <p:cNvSpPr/>
+          <p:nvPr/>
+        </p:nvSpPr>
+        <p:spPr>
+          <a:xfrm>
+            <a:off x="731520" y="3291840"/>
+            <a:ext cx="10728655" cy="3017520"/>
+          </a:xfrm>
+          <a:prstGeom prst="roundRect">
+            <a:avLst/>
+          </a:prstGeom>
+          <a:solidFill>
+            <a:srgbClr val="101622"/>
+          </a:solidFill>
+          <a:ln w="20320">
+            <a:solidFill>
+              <a:srgbClr val="00E5FF"/>
+            </a:solidFill>
+          </a:ln>
+        </p:spPr>
+        <p:style>
+          <a:lnRef idx="1">
+            <a:schemeClr val="accent1"/>
+          </a:lnRef>
+          <a:fillRef idx="3">
+            <a:schemeClr val="accent1"/>
+          </a:fillRef>
+          <a:effectRef idx="2">
+            <a:schemeClr val="accent1"/>
+          </a:effectRef>
+          <a:fontRef idx="minor">
+            <a:schemeClr val="lt1"/>
+          </a:fontRef>
+        </p:style>
+        <p:txBody>
+          <a:bodyPr rtlCol="0" anchor="ctr"/>
+          <a:lstStyle/>
+          <a:p>
+            <a:pPr algn="ctr"/>
+          </a:p>
+        </p:txBody>
+      </p:sp>
+      <p:sp>
+        <p:nvSpPr>
+          <p:cNvPr id="20" name="TextBox 19"/>
+          <p:cNvSpPr txBox="1"/>
+          <p:nvPr/>
+        </p:nvSpPr>
+        <p:spPr>
+          <a:xfrm>
+            <a:off x="1097280" y="3520440"/>
+            <a:ext cx="9966960" cy="2560320"/>
           </a:xfrm>
           <a:prstGeom prst="rect">
             <a:avLst/>
@@ -6526,13 +7429,13 @@
             <a:pPr>
               <a:defRPr sz="1200" b="1">
                 <a:solidFill>
-                  <a:srgbClr val="00D4FF"/>
+                  <a:srgbClr val="00E5FF"/>
                 </a:solidFill>
                 <a:latin typeface="Segoe UI"/>
               </a:defRPr>
             </a:pPr>
             <a:r>
-              <a:t>THE SHARK TANK VERDICT</a:t>
+              <a:t>OFFICIAL HANDOUT MANDATE: 'WITH MORE TIME WE'D ADD...'</a:t>
             </a:r>
           </a:p>
           <a:p>
@@ -6545,12 +7448,9 @@
               </a:defRPr>
             </a:pPr>
             <a:r>
-              <a:t>"Private tutors cost $80 an hour. Campus office hours are packed 2 hours a week.</a:t>
+              <a:t>"With more time, we’d add live Canvas and syllabus LMS integration, automatically syncing weekly exam dates and generating proactive 15-minute micro-sprints before every morning class.</a:t>
             </a:r>
             <a:br/>
-            <a:r>
-              <a:t>Prismatic makes world-class, adaptive cognitive education accessible to every student on campus.</a:t>
-            </a:r>
             <a:br/>
             <a:r>
               <a:t>We don't just help students pass exams; we eliminate academic paralysis and unlock confidence."</a:t>
@@ -6558,15 +7458,15 @@
           </a:p>
           <a:p>
             <a:pPr>
-              <a:defRPr sz="1250" b="1">
-                <a:solidFill>
-                  <a:srgbClr val="10B981"/>
+              <a:defRPr sz="1300" b="1">
+                <a:solidFill>
+                  <a:srgbClr val="34D399"/>
                 </a:solidFill>
                 <a:latin typeface="Segoe UI"/>
               </a:defRPr>
             </a:pPr>
             <a:r>
-              <a:t>WE ARE PRISMATIC — REFRACTING COMPLEX KNOWLEDGE INTO YOUR NATIVE SPECTRUM.</a:t>
+              <a:t>WE ARE PRISMATIC — REFRACTING COMPLEX KNOWLEDGE INTO YOUR NATIVE SPECTRUM. VOTE PRISMATIC!</a:t>
             </a:r>
           </a:p>
         </p:txBody>

</xml_diff>

<commit_message>
feat: harden deck builder (portable paths, scannable QR, robust PDF export) and ship web-app + presenter kit
</commit_message>
<xml_diff>
--- a/Prismatic_Shark_Tank_Pitch_Deck.pptx
+++ b/Prismatic_Shark_Tank_Pitch_Deck.pptx
@@ -3876,7 +3876,93 @@
       </p:sp>
       <p:sp>
         <p:nvSpPr>
-          <p:cNvPr id="3" name="Rounded Rectangle 2"/>
+          <p:cNvPr id="3" name="Rectangle 2"/>
+          <p:cNvSpPr/>
+          <p:nvPr/>
+        </p:nvSpPr>
+        <p:spPr>
+          <a:xfrm>
+            <a:off x="0" y="0"/>
+            <a:ext cx="6096304" cy="54864"/>
+          </a:xfrm>
+          <a:prstGeom prst="rect">
+            <a:avLst/>
+          </a:prstGeom>
+          <a:solidFill>
+            <a:srgbClr val="00E5FF"/>
+          </a:solidFill>
+          <a:ln>
+            <a:noFill/>
+          </a:ln>
+        </p:spPr>
+        <p:style>
+          <a:lnRef idx="1">
+            <a:schemeClr val="accent1"/>
+          </a:lnRef>
+          <a:fillRef idx="3">
+            <a:schemeClr val="accent1"/>
+          </a:fillRef>
+          <a:effectRef idx="2">
+            <a:schemeClr val="accent1"/>
+          </a:effectRef>
+          <a:fontRef idx="minor">
+            <a:schemeClr val="lt1"/>
+          </a:fontRef>
+        </p:style>
+        <p:txBody>
+          <a:bodyPr rtlCol="0" anchor="ctr"/>
+          <a:lstStyle/>
+          <a:p>
+            <a:pPr algn="ctr"/>
+          </a:p>
+        </p:txBody>
+      </p:sp>
+      <p:sp>
+        <p:nvSpPr>
+          <p:cNvPr id="4" name="Rectangle 3"/>
+          <p:cNvSpPr/>
+          <p:nvPr/>
+        </p:nvSpPr>
+        <p:spPr>
+          <a:xfrm>
+            <a:off x="6096304" y="0"/>
+            <a:ext cx="6095390" cy="54864"/>
+          </a:xfrm>
+          <a:prstGeom prst="rect">
+            <a:avLst/>
+          </a:prstGeom>
+          <a:solidFill>
+            <a:srgbClr val="B464FF"/>
+          </a:solidFill>
+          <a:ln>
+            <a:noFill/>
+          </a:ln>
+        </p:spPr>
+        <p:style>
+          <a:lnRef idx="1">
+            <a:schemeClr val="accent1"/>
+          </a:lnRef>
+          <a:fillRef idx="3">
+            <a:schemeClr val="accent1"/>
+          </a:fillRef>
+          <a:effectRef idx="2">
+            <a:schemeClr val="accent1"/>
+          </a:effectRef>
+          <a:fontRef idx="minor">
+            <a:schemeClr val="lt1"/>
+          </a:fontRef>
+        </p:style>
+        <p:txBody>
+          <a:bodyPr rtlCol="0" anchor="ctr"/>
+          <a:lstStyle/>
+          <a:p>
+            <a:pPr algn="ctr"/>
+          </a:p>
+        </p:txBody>
+      </p:sp>
+      <p:sp>
+        <p:nvSpPr>
+          <p:cNvPr id="5" name="Rounded Rectangle 4"/>
           <p:cNvSpPr/>
           <p:nvPr/>
         </p:nvSpPr>
@@ -3886,7 +3972,9 @@
             <a:ext cx="5120640" cy="384048"/>
           </a:xfrm>
           <a:prstGeom prst="roundRect">
-            <a:avLst/>
+            <a:avLst>
+              <a:gd name="adj" fmla="val 8000"/>
+            </a:avLst>
           </a:prstGeom>
           <a:solidFill>
             <a:srgbClr val="161E30"/>
@@ -3921,7 +4009,7 @@
       </p:sp>
       <p:sp>
         <p:nvSpPr>
-          <p:cNvPr id="4" name="TextBox 3"/>
+          <p:cNvPr id="6" name="TextBox 5"/>
           <p:cNvSpPr txBox="1"/>
           <p:nvPr/>
         </p:nvSpPr>
@@ -3936,13 +4024,13 @@
           <a:noFill/>
         </p:spPr>
         <p:txBody>
-          <a:bodyPr wrap="none">
-            <a:spAutoFit/>
+          <a:bodyPr wrap="square" lIns="0" tIns="0" rIns="0" bIns="0">
+            <a:normAutofit/>
           </a:bodyPr>
           <a:lstStyle/>
           <a:p>
-            <a:pPr>
-              <a:defRPr sz="950" b="1">
+            <a:pPr algn="l">
+              <a:defRPr sz="1050" b="1" i="0">
                 <a:solidFill>
                   <a:srgbClr val="00E5FF"/>
                 </a:solidFill>
@@ -3957,7 +4045,7 @@
       </p:sp>
       <p:sp>
         <p:nvSpPr>
-          <p:cNvPr id="5" name="TextBox 4"/>
+          <p:cNvPr id="7" name="TextBox 6"/>
           <p:cNvSpPr txBox="1"/>
           <p:nvPr/>
         </p:nvSpPr>
@@ -3973,7 +4061,7 @@
         </p:spPr>
         <p:txBody>
           <a:bodyPr wrap="square" lIns="0" tIns="0" rIns="0" bIns="0">
-            <a:spAutoFit/>
+            <a:normAutofit/>
           </a:bodyPr>
           <a:lstStyle/>
           <a:p>
@@ -4006,7 +4094,7 @@
       </p:sp>
       <p:sp>
         <p:nvSpPr>
-          <p:cNvPr id="6" name="Rounded Rectangle 5"/>
+          <p:cNvPr id="8" name="Rounded Rectangle 7"/>
           <p:cNvSpPr/>
           <p:nvPr/>
         </p:nvSpPr>
@@ -4016,7 +4104,9 @@
             <a:ext cx="2499055" cy="1920240"/>
           </a:xfrm>
           <a:prstGeom prst="roundRect">
-            <a:avLst/>
+            <a:avLst>
+              <a:gd name="adj" fmla="val 8000"/>
+            </a:avLst>
           </a:prstGeom>
           <a:solidFill>
             <a:srgbClr val="101622"/>
@@ -4051,7 +4141,7 @@
       </p:sp>
       <p:pic>
         <p:nvPicPr>
-          <p:cNvPr id="7" name="Picture 6" descr="prismatic_github_qr.png"/>
+          <p:cNvPr id="9" name="Picture 8" descr="prismatic_github_qr.png"/>
           <p:cNvPicPr>
             <a:picLocks noChangeAspect="1"/>
           </p:cNvPicPr>
@@ -4075,7 +4165,7 @@
       </p:pic>
       <p:sp>
         <p:nvSpPr>
-          <p:cNvPr id="8" name="TextBox 7"/>
+          <p:cNvPr id="10" name="TextBox 9"/>
           <p:cNvSpPr txBox="1"/>
           <p:nvPr/>
         </p:nvSpPr>
@@ -4091,7 +4181,7 @@
         </p:spPr>
         <p:txBody>
           <a:bodyPr wrap="square" lIns="0" tIns="0" rIns="0" bIns="0">
-            <a:spAutoFit/>
+            <a:normAutofit/>
           </a:bodyPr>
           <a:lstStyle/>
           <a:p>
@@ -4109,7 +4199,7 @@
           </a:p>
           <a:p>
             <a:pPr>
-              <a:defRPr sz="850">
+              <a:defRPr sz="1050">
                 <a:solidFill>
                   <a:srgbClr val="94A3B8"/>
                 </a:solidFill>
@@ -4124,7 +4214,7 @@
       </p:sp>
       <p:sp>
         <p:nvSpPr>
-          <p:cNvPr id="9" name="Rounded Rectangle 8"/>
+          <p:cNvPr id="11" name="Rounded Rectangle 10"/>
           <p:cNvSpPr/>
           <p:nvPr/>
         </p:nvSpPr>
@@ -4134,7 +4224,9 @@
             <a:ext cx="3383280" cy="3749039"/>
           </a:xfrm>
           <a:prstGeom prst="roundRect">
-            <a:avLst/>
+            <a:avLst>
+              <a:gd name="adj" fmla="val 8000"/>
+            </a:avLst>
           </a:prstGeom>
           <a:solidFill>
             <a:srgbClr val="101622"/>
@@ -4169,7 +4261,7 @@
       </p:sp>
       <p:sp>
         <p:nvSpPr>
-          <p:cNvPr id="10" name="Rounded Rectangle 9"/>
+          <p:cNvPr id="12" name="Rounded Rectangle 11"/>
           <p:cNvSpPr/>
           <p:nvPr/>
         </p:nvSpPr>
@@ -4179,7 +4271,9 @@
             <a:ext cx="2011680" cy="292608"/>
           </a:xfrm>
           <a:prstGeom prst="roundRect">
-            <a:avLst/>
+            <a:avLst>
+              <a:gd name="adj" fmla="val 8000"/>
+            </a:avLst>
           </a:prstGeom>
           <a:solidFill>
             <a:srgbClr val="161E30"/>
@@ -4214,7 +4308,7 @@
       </p:sp>
       <p:sp>
         <p:nvSpPr>
-          <p:cNvPr id="11" name="TextBox 10"/>
+          <p:cNvPr id="13" name="TextBox 12"/>
           <p:cNvSpPr txBox="1"/>
           <p:nvPr/>
         </p:nvSpPr>
@@ -4229,13 +4323,13 @@
           <a:noFill/>
         </p:spPr>
         <p:txBody>
-          <a:bodyPr wrap="none">
-            <a:spAutoFit/>
+          <a:bodyPr wrap="square" lIns="0" tIns="0" rIns="0" bIns="0">
+            <a:normAutofit/>
           </a:bodyPr>
           <a:lstStyle/>
           <a:p>
-            <a:pPr>
-              <a:defRPr sz="900" b="1">
+            <a:pPr algn="l">
+              <a:defRPr sz="1050" b="1" i="0">
                 <a:solidFill>
                   <a:srgbClr val="00E5FF"/>
                 </a:solidFill>
@@ -4250,7 +4344,7 @@
       </p:sp>
       <p:sp>
         <p:nvSpPr>
-          <p:cNvPr id="12" name="TextBox 11"/>
+          <p:cNvPr id="14" name="TextBox 13"/>
           <p:cNvSpPr txBox="1"/>
           <p:nvPr/>
         </p:nvSpPr>
@@ -4265,13 +4359,13 @@
           <a:noFill/>
         </p:spPr>
         <p:txBody>
-          <a:bodyPr wrap="none">
-            <a:spAutoFit/>
+          <a:bodyPr wrap="square" lIns="0" tIns="0" rIns="0" bIns="0">
+            <a:normAutofit/>
           </a:bodyPr>
           <a:lstStyle/>
           <a:p>
-            <a:pPr>
-              <a:defRPr sz="1200" b="1">
+            <a:pPr algn="l">
+              <a:defRPr sz="1200" b="1" i="0">
                 <a:solidFill>
                   <a:srgbClr val="00E5FF"/>
                 </a:solidFill>
@@ -4286,7 +4380,7 @@
       </p:sp>
       <p:sp>
         <p:nvSpPr>
-          <p:cNvPr id="13" name="TextBox 12"/>
+          <p:cNvPr id="15" name="TextBox 14"/>
           <p:cNvSpPr txBox="1"/>
           <p:nvPr/>
         </p:nvSpPr>
@@ -4301,13 +4395,13 @@
           <a:noFill/>
         </p:spPr>
         <p:txBody>
-          <a:bodyPr wrap="none">
-            <a:spAutoFit/>
+          <a:bodyPr wrap="square" lIns="0" tIns="0" rIns="0" bIns="0">
+            <a:normAutofit/>
           </a:bodyPr>
           <a:lstStyle/>
           <a:p>
-            <a:pPr>
-              <a:defRPr sz="1500" b="1">
+            <a:pPr algn="l">
+              <a:defRPr sz="1500" b="1" i="0">
                 <a:solidFill>
                   <a:srgbClr val="FFFFFF"/>
                 </a:solidFill>
@@ -4322,7 +4416,7 @@
       </p:sp>
       <p:sp>
         <p:nvSpPr>
-          <p:cNvPr id="14" name="TextBox 13"/>
+          <p:cNvPr id="16" name="TextBox 15"/>
           <p:cNvSpPr txBox="1"/>
           <p:nvPr/>
         </p:nvSpPr>
@@ -4337,13 +4431,13 @@
           <a:noFill/>
         </p:spPr>
         <p:txBody>
-          <a:bodyPr wrap="none">
-            <a:spAutoFit/>
+          <a:bodyPr wrap="square" lIns="0" tIns="0" rIns="0" bIns="0">
+            <a:normAutofit/>
           </a:bodyPr>
           <a:lstStyle/>
           <a:p>
-            <a:pPr>
-              <a:defRPr sz="1200">
+            <a:pPr algn="l">
+              <a:defRPr sz="1200" b="0" i="0">
                 <a:solidFill>
                   <a:srgbClr val="94A3B8"/>
                 </a:solidFill>
@@ -4358,7 +4452,7 @@
       </p:sp>
       <p:sp>
         <p:nvSpPr>
-          <p:cNvPr id="15" name="Rounded Rectangle 14"/>
+          <p:cNvPr id="17" name="Rounded Rectangle 16"/>
           <p:cNvSpPr/>
           <p:nvPr/>
         </p:nvSpPr>
@@ -4368,7 +4462,9 @@
             <a:ext cx="3383280" cy="3749039"/>
           </a:xfrm>
           <a:prstGeom prst="roundRect">
-            <a:avLst/>
+            <a:avLst>
+              <a:gd name="adj" fmla="val 8000"/>
+            </a:avLst>
           </a:prstGeom>
           <a:solidFill>
             <a:srgbClr val="101622"/>
@@ -4403,7 +4499,7 @@
       </p:sp>
       <p:sp>
         <p:nvSpPr>
-          <p:cNvPr id="16" name="Rounded Rectangle 15"/>
+          <p:cNvPr id="18" name="Rounded Rectangle 17"/>
           <p:cNvSpPr/>
           <p:nvPr/>
         </p:nvSpPr>
@@ -4413,7 +4509,9 @@
             <a:ext cx="2011680" cy="292608"/>
           </a:xfrm>
           <a:prstGeom prst="roundRect">
-            <a:avLst/>
+            <a:avLst>
+              <a:gd name="adj" fmla="val 8000"/>
+            </a:avLst>
           </a:prstGeom>
           <a:solidFill>
             <a:srgbClr val="161E30"/>
@@ -4448,7 +4546,7 @@
       </p:sp>
       <p:sp>
         <p:nvSpPr>
-          <p:cNvPr id="17" name="TextBox 16"/>
+          <p:cNvPr id="19" name="TextBox 18"/>
           <p:cNvSpPr txBox="1"/>
           <p:nvPr/>
         </p:nvSpPr>
@@ -4463,13 +4561,13 @@
           <a:noFill/>
         </p:spPr>
         <p:txBody>
-          <a:bodyPr wrap="none">
-            <a:spAutoFit/>
+          <a:bodyPr wrap="square" lIns="0" tIns="0" rIns="0" bIns="0">
+            <a:normAutofit/>
           </a:bodyPr>
           <a:lstStyle/>
           <a:p>
-            <a:pPr>
-              <a:defRPr sz="900" b="1">
+            <a:pPr algn="l">
+              <a:defRPr sz="1050" b="1" i="0">
                 <a:solidFill>
                   <a:srgbClr val="FF6B6B"/>
                 </a:solidFill>
@@ -4484,7 +4582,7 @@
       </p:sp>
       <p:sp>
         <p:nvSpPr>
-          <p:cNvPr id="18" name="TextBox 17"/>
+          <p:cNvPr id="20" name="TextBox 19"/>
           <p:cNvSpPr txBox="1"/>
           <p:nvPr/>
         </p:nvSpPr>
@@ -4499,13 +4597,13 @@
           <a:noFill/>
         </p:spPr>
         <p:txBody>
-          <a:bodyPr wrap="none">
-            <a:spAutoFit/>
+          <a:bodyPr wrap="square" lIns="0" tIns="0" rIns="0" bIns="0">
+            <a:normAutofit/>
           </a:bodyPr>
           <a:lstStyle/>
           <a:p>
-            <a:pPr>
-              <a:defRPr sz="1200" b="1">
+            <a:pPr algn="l">
+              <a:defRPr sz="1200" b="1" i="0">
                 <a:solidFill>
                   <a:srgbClr val="FF6B6B"/>
                 </a:solidFill>
@@ -4520,7 +4618,7 @@
       </p:sp>
       <p:sp>
         <p:nvSpPr>
-          <p:cNvPr id="19" name="TextBox 18"/>
+          <p:cNvPr id="21" name="TextBox 20"/>
           <p:cNvSpPr txBox="1"/>
           <p:nvPr/>
         </p:nvSpPr>
@@ -4535,13 +4633,13 @@
           <a:noFill/>
         </p:spPr>
         <p:txBody>
-          <a:bodyPr wrap="none">
-            <a:spAutoFit/>
+          <a:bodyPr wrap="square" lIns="0" tIns="0" rIns="0" bIns="0">
+            <a:normAutofit/>
           </a:bodyPr>
           <a:lstStyle/>
           <a:p>
-            <a:pPr>
-              <a:defRPr sz="1500" b="1">
+            <a:pPr algn="l">
+              <a:defRPr sz="1500" b="1" i="0">
                 <a:solidFill>
                   <a:srgbClr val="FFFFFF"/>
                 </a:solidFill>
@@ -4556,7 +4654,7 @@
       </p:sp>
       <p:sp>
         <p:nvSpPr>
-          <p:cNvPr id="20" name="TextBox 19"/>
+          <p:cNvPr id="22" name="TextBox 21"/>
           <p:cNvSpPr txBox="1"/>
           <p:nvPr/>
         </p:nvSpPr>
@@ -4571,13 +4669,13 @@
           <a:noFill/>
         </p:spPr>
         <p:txBody>
-          <a:bodyPr wrap="none">
-            <a:spAutoFit/>
+          <a:bodyPr wrap="square" lIns="0" tIns="0" rIns="0" bIns="0">
+            <a:normAutofit/>
           </a:bodyPr>
           <a:lstStyle/>
           <a:p>
-            <a:pPr>
-              <a:defRPr sz="1200">
+            <a:pPr algn="l">
+              <a:defRPr sz="1200" b="0" i="0">
                 <a:solidFill>
                   <a:srgbClr val="94A3B8"/>
                 </a:solidFill>
@@ -4592,7 +4690,7 @@
       </p:sp>
       <p:sp>
         <p:nvSpPr>
-          <p:cNvPr id="21" name="Rounded Rectangle 20"/>
+          <p:cNvPr id="23" name="Rounded Rectangle 22"/>
           <p:cNvSpPr/>
           <p:nvPr/>
         </p:nvSpPr>
@@ -4602,7 +4700,9 @@
             <a:ext cx="3383280" cy="3749039"/>
           </a:xfrm>
           <a:prstGeom prst="roundRect">
-            <a:avLst/>
+            <a:avLst>
+              <a:gd name="adj" fmla="val 8000"/>
+            </a:avLst>
           </a:prstGeom>
           <a:solidFill>
             <a:srgbClr val="101622"/>
@@ -4637,7 +4737,7 @@
       </p:sp>
       <p:sp>
         <p:nvSpPr>
-          <p:cNvPr id="22" name="Rounded Rectangle 21"/>
+          <p:cNvPr id="24" name="Rounded Rectangle 23"/>
           <p:cNvSpPr/>
           <p:nvPr/>
         </p:nvSpPr>
@@ -4647,7 +4747,9 @@
             <a:ext cx="2011680" cy="292608"/>
           </a:xfrm>
           <a:prstGeom prst="roundRect">
-            <a:avLst/>
+            <a:avLst>
+              <a:gd name="adj" fmla="val 8000"/>
+            </a:avLst>
           </a:prstGeom>
           <a:solidFill>
             <a:srgbClr val="161E30"/>
@@ -4682,7 +4784,7 @@
       </p:sp>
       <p:sp>
         <p:nvSpPr>
-          <p:cNvPr id="23" name="TextBox 22"/>
+          <p:cNvPr id="25" name="TextBox 24"/>
           <p:cNvSpPr txBox="1"/>
           <p:nvPr/>
         </p:nvSpPr>
@@ -4697,35 +4799,179 @@
           <a:noFill/>
         </p:spPr>
         <p:txBody>
-          <a:bodyPr wrap="none">
+          <a:bodyPr wrap="square" lIns="0" tIns="0" rIns="0" bIns="0">
+            <a:normAutofit/>
+          </a:bodyPr>
+          <a:lstStyle/>
+          <a:p>
+            <a:pPr algn="l">
+              <a:defRPr sz="1050" b="1" i="0">
+                <a:solidFill>
+                  <a:srgbClr val="34D399"/>
+                </a:solidFill>
+                <a:latin typeface="Segoe UI"/>
+              </a:defRPr>
+            </a:pPr>
+            <a:r>
+              <a:t>THE CORE MISSION</a:t>
+            </a:r>
+          </a:p>
+        </p:txBody>
+      </p:sp>
+      <p:sp>
+        <p:nvSpPr>
+          <p:cNvPr id="26" name="TextBox 25"/>
+          <p:cNvSpPr txBox="1"/>
+          <p:nvPr/>
+        </p:nvSpPr>
+        <p:spPr>
+          <a:xfrm>
+            <a:off x="8321040" y="3474720"/>
+            <a:ext cx="2834640" cy="320040"/>
+          </a:xfrm>
+          <a:prstGeom prst="rect">
+            <a:avLst/>
+          </a:prstGeom>
+          <a:noFill/>
+        </p:spPr>
+        <p:txBody>
+          <a:bodyPr wrap="square" lIns="0" tIns="0" rIns="0" bIns="0">
+            <a:normAutofit/>
+          </a:bodyPr>
+          <a:lstStyle/>
+          <a:p>
+            <a:pPr algn="l">
+              <a:defRPr sz="1200" b="1" i="0">
+                <a:solidFill>
+                  <a:srgbClr val="34D399"/>
+                </a:solidFill>
+                <a:latin typeface="Segoe UI"/>
+              </a:defRPr>
+            </a:pPr>
+            <a:r>
+              <a:t>THE EMOTIONAL TRUTH</a:t>
+            </a:r>
+          </a:p>
+        </p:txBody>
+      </p:sp>
+      <p:sp>
+        <p:nvSpPr>
+          <p:cNvPr id="27" name="TextBox 26"/>
+          <p:cNvSpPr txBox="1"/>
+          <p:nvPr/>
+        </p:nvSpPr>
+        <p:spPr>
+          <a:xfrm>
+            <a:off x="8321040" y="3840480"/>
+            <a:ext cx="2834640" cy="411480"/>
+          </a:xfrm>
+          <a:prstGeom prst="rect">
+            <a:avLst/>
+          </a:prstGeom>
+          <a:noFill/>
+        </p:spPr>
+        <p:txBody>
+          <a:bodyPr wrap="square" lIns="0" tIns="0" rIns="0" bIns="0">
+            <a:normAutofit/>
+          </a:bodyPr>
+          <a:lstStyle/>
+          <a:p>
+            <a:pPr algn="l">
+              <a:defRPr sz="1500" b="1" i="0">
+                <a:solidFill>
+                  <a:srgbClr val="FFFFFF"/>
+                </a:solidFill>
+                <a:latin typeface="Segoe UI"/>
+              </a:defRPr>
+            </a:pPr>
+            <a:r>
+              <a:t>Cognitive Mismatch</a:t>
+            </a:r>
+          </a:p>
+        </p:txBody>
+      </p:sp>
+      <p:sp>
+        <p:nvSpPr>
+          <p:cNvPr id="28" name="TextBox 27"/>
+          <p:cNvSpPr txBox="1"/>
+          <p:nvPr/>
+        </p:nvSpPr>
+        <p:spPr>
+          <a:xfrm>
+            <a:off x="8321040" y="4389120"/>
+            <a:ext cx="2834640" cy="1828800"/>
+          </a:xfrm>
+          <a:prstGeom prst="rect">
+            <a:avLst/>
+          </a:prstGeom>
+          <a:noFill/>
+        </p:spPr>
+        <p:txBody>
+          <a:bodyPr wrap="square" lIns="0" tIns="0" rIns="0" bIns="0">
+            <a:normAutofit/>
+          </a:bodyPr>
+          <a:lstStyle/>
+          <a:p>
+            <a:pPr algn="l">
+              <a:defRPr sz="1200" b="0" i="0">
+                <a:solidFill>
+                  <a:srgbClr val="94A3B8"/>
+                </a:solidFill>
+                <a:latin typeface="Segoe UI"/>
+              </a:defRPr>
+            </a:pPr>
+            <a:r>
+              <a:t>Students don't freeze from lack of intelligence; they freeze when raw syllabus format clashes with their brain.</a:t>
+            </a:r>
+          </a:p>
+        </p:txBody>
+      </p:sp>
+      <p:sp>
+        <p:nvSpPr>
+          <p:cNvPr id="29" name="TextBox 28"/>
+          <p:cNvSpPr txBox="1"/>
+          <p:nvPr/>
+        </p:nvSpPr>
+        <p:spPr>
+          <a:xfrm>
+            <a:off x="731520" y="6473952"/>
+            <a:ext cx="5486400" cy="228600"/>
+          </a:xfrm>
+          <a:prstGeom prst="rect">
+            <a:avLst/>
+          </a:prstGeom>
+          <a:noFill/>
+        </p:spPr>
+        <p:txBody>
+          <a:bodyPr wrap="square">
             <a:spAutoFit/>
           </a:bodyPr>
           <a:lstStyle/>
           <a:p>
             <a:pPr>
-              <a:defRPr sz="900" b="1">
-                <a:solidFill>
-                  <a:srgbClr val="34D399"/>
+              <a:defRPr sz="800">
+                <a:solidFill>
+                  <a:srgbClr val="64748B"/>
                 </a:solidFill>
                 <a:latin typeface="Segoe UI"/>
               </a:defRPr>
             </a:pPr>
             <a:r>
-              <a:t>THE CORE MISSION</a:t>
-            </a:r>
-          </a:p>
-        </p:txBody>
-      </p:sp>
-      <p:sp>
-        <p:nvSpPr>
-          <p:cNvPr id="24" name="TextBox 23"/>
+              <a:t>CLOUD CONNECT 2026  •  PRISMATIC</a:t>
+            </a:r>
+          </a:p>
+        </p:txBody>
+      </p:sp>
+      <p:sp>
+        <p:nvSpPr>
+          <p:cNvPr id="30" name="TextBox 29"/>
           <p:cNvSpPr txBox="1"/>
           <p:nvPr/>
         </p:nvSpPr>
         <p:spPr>
           <a:xfrm>
-            <a:off x="8321040" y="3474720"/>
-            <a:ext cx="2834640" cy="320040"/>
+            <a:off x="10515600" y="6473952"/>
+            <a:ext cx="914400" cy="228600"/>
           </a:xfrm>
           <a:prstGeom prst="rect">
             <a:avLst/>
@@ -4733,93 +4979,21 @@
           <a:noFill/>
         </p:spPr>
         <p:txBody>
-          <a:bodyPr wrap="none">
+          <a:bodyPr wrap="square">
             <a:spAutoFit/>
           </a:bodyPr>
           <a:lstStyle/>
           <a:p>
-            <a:pPr>
-              <a:defRPr sz="1200" b="1">
-                <a:solidFill>
-                  <a:srgbClr val="34D399"/>
+            <a:pPr algn="r">
+              <a:defRPr sz="800">
+                <a:solidFill>
+                  <a:srgbClr val="64748B"/>
                 </a:solidFill>
                 <a:latin typeface="Segoe UI"/>
               </a:defRPr>
             </a:pPr>
             <a:r>
-              <a:t>THE EMOTIONAL TRUTH</a:t>
-            </a:r>
-          </a:p>
-        </p:txBody>
-      </p:sp>
-      <p:sp>
-        <p:nvSpPr>
-          <p:cNvPr id="25" name="TextBox 24"/>
-          <p:cNvSpPr txBox="1"/>
-          <p:nvPr/>
-        </p:nvSpPr>
-        <p:spPr>
-          <a:xfrm>
-            <a:off x="8321040" y="3840480"/>
-            <a:ext cx="2834640" cy="411480"/>
-          </a:xfrm>
-          <a:prstGeom prst="rect">
-            <a:avLst/>
-          </a:prstGeom>
-          <a:noFill/>
-        </p:spPr>
-        <p:txBody>
-          <a:bodyPr wrap="none">
-            <a:spAutoFit/>
-          </a:bodyPr>
-          <a:lstStyle/>
-          <a:p>
-            <a:pPr>
-              <a:defRPr sz="1500" b="1">
-                <a:solidFill>
-                  <a:srgbClr val="FFFFFF"/>
-                </a:solidFill>
-                <a:latin typeface="Segoe UI"/>
-              </a:defRPr>
-            </a:pPr>
-            <a:r>
-              <a:t>Cognitive Mismatch</a:t>
-            </a:r>
-          </a:p>
-        </p:txBody>
-      </p:sp>
-      <p:sp>
-        <p:nvSpPr>
-          <p:cNvPr id="26" name="TextBox 25"/>
-          <p:cNvSpPr txBox="1"/>
-          <p:nvPr/>
-        </p:nvSpPr>
-        <p:spPr>
-          <a:xfrm>
-            <a:off x="8321040" y="4389120"/>
-            <a:ext cx="2834640" cy="1828800"/>
-          </a:xfrm>
-          <a:prstGeom prst="rect">
-            <a:avLst/>
-          </a:prstGeom>
-          <a:noFill/>
-        </p:spPr>
-        <p:txBody>
-          <a:bodyPr wrap="none">
-            <a:spAutoFit/>
-          </a:bodyPr>
-          <a:lstStyle/>
-          <a:p>
-            <a:pPr>
-              <a:defRPr sz="1200">
-                <a:solidFill>
-                  <a:srgbClr val="94A3B8"/>
-                </a:solidFill>
-                <a:latin typeface="Segoe UI"/>
-              </a:defRPr>
-            </a:pPr>
-            <a:r>
-              <a:t>Students don't freeze from lack of intelligence; they freeze when raw syllabus format clashes with their brain.</a:t>
+              <a:t>1 / 4</a:t>
             </a:r>
           </a:p>
         </p:txBody>
@@ -4887,7 +5061,93 @@
       </p:sp>
       <p:sp>
         <p:nvSpPr>
-          <p:cNvPr id="3" name="TextBox 2"/>
+          <p:cNvPr id="3" name="Rectangle 2"/>
+          <p:cNvSpPr/>
+          <p:nvPr/>
+        </p:nvSpPr>
+        <p:spPr>
+          <a:xfrm>
+            <a:off x="0" y="0"/>
+            <a:ext cx="6096304" cy="54864"/>
+          </a:xfrm>
+          <a:prstGeom prst="rect">
+            <a:avLst/>
+          </a:prstGeom>
+          <a:solidFill>
+            <a:srgbClr val="00E5FF"/>
+          </a:solidFill>
+          <a:ln>
+            <a:noFill/>
+          </a:ln>
+        </p:spPr>
+        <p:style>
+          <a:lnRef idx="1">
+            <a:schemeClr val="accent1"/>
+          </a:lnRef>
+          <a:fillRef idx="3">
+            <a:schemeClr val="accent1"/>
+          </a:fillRef>
+          <a:effectRef idx="2">
+            <a:schemeClr val="accent1"/>
+          </a:effectRef>
+          <a:fontRef idx="minor">
+            <a:schemeClr val="lt1"/>
+          </a:fontRef>
+        </p:style>
+        <p:txBody>
+          <a:bodyPr rtlCol="0" anchor="ctr"/>
+          <a:lstStyle/>
+          <a:p>
+            <a:pPr algn="ctr"/>
+          </a:p>
+        </p:txBody>
+      </p:sp>
+      <p:sp>
+        <p:nvSpPr>
+          <p:cNvPr id="4" name="Rectangle 3"/>
+          <p:cNvSpPr/>
+          <p:nvPr/>
+        </p:nvSpPr>
+        <p:spPr>
+          <a:xfrm>
+            <a:off x="6096304" y="0"/>
+            <a:ext cx="6095390" cy="54864"/>
+          </a:xfrm>
+          <a:prstGeom prst="rect">
+            <a:avLst/>
+          </a:prstGeom>
+          <a:solidFill>
+            <a:srgbClr val="B464FF"/>
+          </a:solidFill>
+          <a:ln>
+            <a:noFill/>
+          </a:ln>
+        </p:spPr>
+        <p:style>
+          <a:lnRef idx="1">
+            <a:schemeClr val="accent1"/>
+          </a:lnRef>
+          <a:fillRef idx="3">
+            <a:schemeClr val="accent1"/>
+          </a:fillRef>
+          <a:effectRef idx="2">
+            <a:schemeClr val="accent1"/>
+          </a:effectRef>
+          <a:fontRef idx="minor">
+            <a:schemeClr val="lt1"/>
+          </a:fontRef>
+        </p:style>
+        <p:txBody>
+          <a:bodyPr rtlCol="0" anchor="ctr"/>
+          <a:lstStyle/>
+          <a:p>
+            <a:pPr algn="ctr"/>
+          </a:p>
+        </p:txBody>
+      </p:sp>
+      <p:sp>
+        <p:nvSpPr>
+          <p:cNvPr id="5" name="TextBox 4"/>
           <p:cNvSpPr txBox="1"/>
           <p:nvPr/>
         </p:nvSpPr>
@@ -4903,12 +5163,12 @@
         </p:spPr>
         <p:txBody>
           <a:bodyPr wrap="square" lIns="0" tIns="0" rIns="0" bIns="0">
-            <a:spAutoFit/>
+            <a:normAutofit/>
           </a:bodyPr>
           <a:lstStyle/>
           <a:p>
-            <a:pPr>
-              <a:defRPr sz="1100" b="1">
+            <a:pPr algn="l">
+              <a:defRPr sz="1100" b="1" i="0">
                 <a:solidFill>
                   <a:srgbClr val="00E5FF"/>
                 </a:solidFill>
@@ -4923,7 +5183,7 @@
       </p:sp>
       <p:sp>
         <p:nvSpPr>
-          <p:cNvPr id="4" name="Rounded Rectangle 3"/>
+          <p:cNvPr id="6" name="Rounded Rectangle 5"/>
           <p:cNvSpPr/>
           <p:nvPr/>
         </p:nvSpPr>
@@ -4933,7 +5193,9 @@
             <a:ext cx="2011680" cy="347472"/>
           </a:xfrm>
           <a:prstGeom prst="roundRect">
-            <a:avLst/>
+            <a:avLst>
+              <a:gd name="adj" fmla="val 8000"/>
+            </a:avLst>
           </a:prstGeom>
           <a:solidFill>
             <a:srgbClr val="161E30"/>
@@ -4959,7 +5221,9 @@
           </a:fontRef>
         </p:style>
         <p:txBody>
-          <a:bodyPr rtlCol="0" anchor="ctr" lIns="0" rIns="0" tIns="0" bIns="0"/>
+          <a:bodyPr rtlCol="0" anchor="ctr" lIns="0" rIns="0" tIns="0" bIns="0" wrap="square">
+            <a:normAutofit/>
+          </a:bodyPr>
           <a:lstStyle/>
           <a:p>
             <a:pPr algn="ctr">
@@ -4978,7 +5242,7 @@
       </p:sp>
       <p:sp>
         <p:nvSpPr>
-          <p:cNvPr id="5" name="TextBox 4"/>
+          <p:cNvPr id="7" name="TextBox 6"/>
           <p:cNvSpPr txBox="1"/>
           <p:nvPr/>
         </p:nvSpPr>
@@ -4994,12 +5258,12 @@
         </p:spPr>
         <p:txBody>
           <a:bodyPr wrap="square" lIns="0" tIns="0" rIns="0" bIns="0">
-            <a:spAutoFit/>
+            <a:normAutofit/>
           </a:bodyPr>
           <a:lstStyle/>
           <a:p>
-            <a:pPr>
-              <a:defRPr sz="2300" b="1">
+            <a:pPr algn="l">
+              <a:defRPr sz="2300" b="1" i="0">
                 <a:solidFill>
                   <a:srgbClr val="FFFFFF"/>
                 </a:solidFill>
@@ -5014,7 +5278,7 @@
       </p:sp>
       <p:sp>
         <p:nvSpPr>
-          <p:cNvPr id="6" name="TextBox 5"/>
+          <p:cNvPr id="8" name="TextBox 7"/>
           <p:cNvSpPr txBox="1"/>
           <p:nvPr/>
         </p:nvSpPr>
@@ -5030,12 +5294,12 @@
         </p:spPr>
         <p:txBody>
           <a:bodyPr wrap="square" lIns="0" tIns="0" rIns="0" bIns="0">
-            <a:spAutoFit/>
+            <a:normAutofit/>
           </a:bodyPr>
           <a:lstStyle/>
           <a:p>
-            <a:pPr>
-              <a:defRPr sz="1200">
+            <a:pPr algn="l">
+              <a:defRPr sz="1050" b="0" i="0">
                 <a:solidFill>
                   <a:srgbClr val="94A3B8"/>
                 </a:solidFill>
@@ -5050,7 +5314,7 @@
       </p:sp>
       <p:sp>
         <p:nvSpPr>
-          <p:cNvPr id="7" name="Rounded Rectangle 6"/>
+          <p:cNvPr id="9" name="Rounded Rectangle 8"/>
           <p:cNvSpPr/>
           <p:nvPr/>
         </p:nvSpPr>
@@ -5060,7 +5324,9 @@
             <a:ext cx="5212080" cy="2240280"/>
           </a:xfrm>
           <a:prstGeom prst="roundRect">
-            <a:avLst/>
+            <a:avLst>
+              <a:gd name="adj" fmla="val 8000"/>
+            </a:avLst>
           </a:prstGeom>
           <a:solidFill>
             <a:srgbClr val="101622"/>
@@ -5095,7 +5361,7 @@
       </p:sp>
       <p:sp>
         <p:nvSpPr>
-          <p:cNvPr id="8" name="Rounded Rectangle 7"/>
+          <p:cNvPr id="10" name="Rounded Rectangle 9"/>
           <p:cNvSpPr/>
           <p:nvPr/>
         </p:nvSpPr>
@@ -5105,7 +5371,9 @@
             <a:ext cx="1645920" cy="256032"/>
           </a:xfrm>
           <a:prstGeom prst="roundRect">
-            <a:avLst/>
+            <a:avLst>
+              <a:gd name="adj" fmla="val 8000"/>
+            </a:avLst>
           </a:prstGeom>
           <a:solidFill>
             <a:srgbClr val="161E30"/>
@@ -5140,7 +5408,7 @@
       </p:sp>
       <p:sp>
         <p:nvSpPr>
-          <p:cNvPr id="9" name="TextBox 8"/>
+          <p:cNvPr id="11" name="TextBox 10"/>
           <p:cNvSpPr txBox="1"/>
           <p:nvPr/>
         </p:nvSpPr>
@@ -5155,13 +5423,13 @@
           <a:noFill/>
         </p:spPr>
         <p:txBody>
-          <a:bodyPr wrap="none">
-            <a:spAutoFit/>
+          <a:bodyPr wrap="square" lIns="0" tIns="0" rIns="0" bIns="0">
+            <a:normAutofit/>
           </a:bodyPr>
           <a:lstStyle/>
           <a:p>
             <a:pPr algn="ctr">
-              <a:defRPr sz="850" b="1">
+              <a:defRPr sz="1050" b="1" i="0">
                 <a:solidFill>
                   <a:srgbClr val="00E5FF"/>
                 </a:solidFill>
@@ -5176,7 +5444,7 @@
       </p:sp>
       <p:sp>
         <p:nvSpPr>
-          <p:cNvPr id="10" name="TextBox 9"/>
+          <p:cNvPr id="12" name="TextBox 11"/>
           <p:cNvSpPr txBox="1"/>
           <p:nvPr/>
         </p:nvSpPr>
@@ -5191,13 +5459,13 @@
           <a:noFill/>
         </p:spPr>
         <p:txBody>
-          <a:bodyPr wrap="none">
-            <a:spAutoFit/>
+          <a:bodyPr wrap="square" lIns="0" tIns="0" rIns="0" bIns="0">
+            <a:normAutofit/>
           </a:bodyPr>
           <a:lstStyle/>
           <a:p>
-            <a:pPr>
-              <a:defRPr sz="1450" b="1">
+            <a:pPr algn="l">
+              <a:defRPr sz="1450" b="1" i="0">
                 <a:solidFill>
                   <a:srgbClr val="FFFFFF"/>
                 </a:solidFill>
@@ -5212,7 +5480,7 @@
       </p:sp>
       <p:sp>
         <p:nvSpPr>
-          <p:cNvPr id="11" name="TextBox 10"/>
+          <p:cNvPr id="13" name="TextBox 12"/>
           <p:cNvSpPr txBox="1"/>
           <p:nvPr/>
         </p:nvSpPr>
@@ -5227,13 +5495,13 @@
           <a:noFill/>
         </p:spPr>
         <p:txBody>
-          <a:bodyPr wrap="none">
-            <a:spAutoFit/>
+          <a:bodyPr wrap="square" lIns="0" tIns="0" rIns="0" bIns="0">
+            <a:normAutofit/>
           </a:bodyPr>
           <a:lstStyle/>
           <a:p>
-            <a:pPr>
-              <a:defRPr sz="1050" b="1">
+            <a:pPr algn="l">
+              <a:defRPr sz="1050" b="1" i="0">
                 <a:solidFill>
                   <a:srgbClr val="00E5FF"/>
                 </a:solidFill>
@@ -5248,7 +5516,7 @@
       </p:sp>
       <p:sp>
         <p:nvSpPr>
-          <p:cNvPr id="12" name="TextBox 11"/>
+          <p:cNvPr id="14" name="TextBox 13"/>
           <p:cNvSpPr txBox="1"/>
           <p:nvPr/>
         </p:nvSpPr>
@@ -5263,13 +5531,13 @@
           <a:noFill/>
         </p:spPr>
         <p:txBody>
-          <a:bodyPr wrap="none">
-            <a:spAutoFit/>
+          <a:bodyPr wrap="square" lIns="0" tIns="0" rIns="0" bIns="0">
+            <a:normAutofit/>
           </a:bodyPr>
           <a:lstStyle/>
           <a:p>
-            <a:pPr>
-              <a:defRPr sz="1100">
+            <a:pPr algn="l">
+              <a:defRPr sz="1100" b="0" i="0">
                 <a:solidFill>
                   <a:srgbClr val="94A3B8"/>
                 </a:solidFill>
@@ -5284,7 +5552,7 @@
       </p:sp>
       <p:sp>
         <p:nvSpPr>
-          <p:cNvPr id="13" name="Rounded Rectangle 12"/>
+          <p:cNvPr id="15" name="Rounded Rectangle 14"/>
           <p:cNvSpPr/>
           <p:nvPr/>
         </p:nvSpPr>
@@ -5294,7 +5562,9 @@
             <a:ext cx="5212080" cy="2240280"/>
           </a:xfrm>
           <a:prstGeom prst="roundRect">
-            <a:avLst/>
+            <a:avLst>
+              <a:gd name="adj" fmla="val 8000"/>
+            </a:avLst>
           </a:prstGeom>
           <a:solidFill>
             <a:srgbClr val="101622"/>
@@ -5329,7 +5599,7 @@
       </p:sp>
       <p:sp>
         <p:nvSpPr>
-          <p:cNvPr id="14" name="Rounded Rectangle 13"/>
+          <p:cNvPr id="16" name="Rounded Rectangle 15"/>
           <p:cNvSpPr/>
           <p:nvPr/>
         </p:nvSpPr>
@@ -5339,7 +5609,9 @@
             <a:ext cx="1645920" cy="256032"/>
           </a:xfrm>
           <a:prstGeom prst="roundRect">
-            <a:avLst/>
+            <a:avLst>
+              <a:gd name="adj" fmla="val 8000"/>
+            </a:avLst>
           </a:prstGeom>
           <a:solidFill>
             <a:srgbClr val="161E30"/>
@@ -5374,7 +5646,7 @@
       </p:sp>
       <p:sp>
         <p:nvSpPr>
-          <p:cNvPr id="15" name="TextBox 14"/>
+          <p:cNvPr id="17" name="TextBox 16"/>
           <p:cNvSpPr txBox="1"/>
           <p:nvPr/>
         </p:nvSpPr>
@@ -5389,13 +5661,13 @@
           <a:noFill/>
         </p:spPr>
         <p:txBody>
-          <a:bodyPr wrap="none">
-            <a:spAutoFit/>
+          <a:bodyPr wrap="square" lIns="0" tIns="0" rIns="0" bIns="0">
+            <a:normAutofit/>
           </a:bodyPr>
           <a:lstStyle/>
           <a:p>
             <a:pPr algn="ctr">
-              <a:defRPr sz="850" b="1">
+              <a:defRPr sz="1050" b="1" i="0">
                 <a:solidFill>
                   <a:srgbClr val="B464FF"/>
                 </a:solidFill>
@@ -5410,7 +5682,7 @@
       </p:sp>
       <p:sp>
         <p:nvSpPr>
-          <p:cNvPr id="16" name="TextBox 15"/>
+          <p:cNvPr id="18" name="TextBox 17"/>
           <p:cNvSpPr txBox="1"/>
           <p:nvPr/>
         </p:nvSpPr>
@@ -5425,13 +5697,13 @@
           <a:noFill/>
         </p:spPr>
         <p:txBody>
-          <a:bodyPr wrap="none">
-            <a:spAutoFit/>
+          <a:bodyPr wrap="square" lIns="0" tIns="0" rIns="0" bIns="0">
+            <a:normAutofit/>
           </a:bodyPr>
           <a:lstStyle/>
           <a:p>
-            <a:pPr>
-              <a:defRPr sz="1450" b="1">
+            <a:pPr algn="l">
+              <a:defRPr sz="1450" b="1" i="0">
                 <a:solidFill>
                   <a:srgbClr val="FFFFFF"/>
                 </a:solidFill>
@@ -5446,7 +5718,7 @@
       </p:sp>
       <p:sp>
         <p:nvSpPr>
-          <p:cNvPr id="17" name="TextBox 16"/>
+          <p:cNvPr id="19" name="TextBox 18"/>
           <p:cNvSpPr txBox="1"/>
           <p:nvPr/>
         </p:nvSpPr>
@@ -5461,13 +5733,13 @@
           <a:noFill/>
         </p:spPr>
         <p:txBody>
-          <a:bodyPr wrap="none">
-            <a:spAutoFit/>
+          <a:bodyPr wrap="square" lIns="0" tIns="0" rIns="0" bIns="0">
+            <a:normAutofit/>
           </a:bodyPr>
           <a:lstStyle/>
           <a:p>
-            <a:pPr>
-              <a:defRPr sz="1050" b="1">
+            <a:pPr algn="l">
+              <a:defRPr sz="1050" b="1" i="0">
                 <a:solidFill>
                   <a:srgbClr val="B464FF"/>
                 </a:solidFill>
@@ -5482,7 +5754,7 @@
       </p:sp>
       <p:sp>
         <p:nvSpPr>
-          <p:cNvPr id="18" name="TextBox 17"/>
+          <p:cNvPr id="20" name="TextBox 19"/>
           <p:cNvSpPr txBox="1"/>
           <p:nvPr/>
         </p:nvSpPr>
@@ -5497,13 +5769,13 @@
           <a:noFill/>
         </p:spPr>
         <p:txBody>
-          <a:bodyPr wrap="none">
-            <a:spAutoFit/>
+          <a:bodyPr wrap="square" lIns="0" tIns="0" rIns="0" bIns="0">
+            <a:normAutofit/>
           </a:bodyPr>
           <a:lstStyle/>
           <a:p>
-            <a:pPr>
-              <a:defRPr sz="1100">
+            <a:pPr algn="l">
+              <a:defRPr sz="1100" b="0" i="0">
                 <a:solidFill>
                   <a:srgbClr val="94A3B8"/>
                 </a:solidFill>
@@ -5518,7 +5790,7 @@
       </p:sp>
       <p:sp>
         <p:nvSpPr>
-          <p:cNvPr id="19" name="Rounded Rectangle 18"/>
+          <p:cNvPr id="21" name="Rounded Rectangle 20"/>
           <p:cNvSpPr/>
           <p:nvPr/>
         </p:nvSpPr>
@@ -5528,7 +5800,9 @@
             <a:ext cx="5212080" cy="2240280"/>
           </a:xfrm>
           <a:prstGeom prst="roundRect">
-            <a:avLst/>
+            <a:avLst>
+              <a:gd name="adj" fmla="val 8000"/>
+            </a:avLst>
           </a:prstGeom>
           <a:solidFill>
             <a:srgbClr val="101622"/>
@@ -5563,7 +5837,7 @@
       </p:sp>
       <p:sp>
         <p:nvSpPr>
-          <p:cNvPr id="20" name="Rounded Rectangle 19"/>
+          <p:cNvPr id="22" name="Rounded Rectangle 21"/>
           <p:cNvSpPr/>
           <p:nvPr/>
         </p:nvSpPr>
@@ -5573,7 +5847,9 @@
             <a:ext cx="1645920" cy="256032"/>
           </a:xfrm>
           <a:prstGeom prst="roundRect">
-            <a:avLst/>
+            <a:avLst>
+              <a:gd name="adj" fmla="val 8000"/>
+            </a:avLst>
           </a:prstGeom>
           <a:solidFill>
             <a:srgbClr val="161E30"/>
@@ -5608,7 +5884,7 @@
       </p:sp>
       <p:sp>
         <p:nvSpPr>
-          <p:cNvPr id="21" name="TextBox 20"/>
+          <p:cNvPr id="23" name="TextBox 22"/>
           <p:cNvSpPr txBox="1"/>
           <p:nvPr/>
         </p:nvSpPr>
@@ -5623,13 +5899,13 @@
           <a:noFill/>
         </p:spPr>
         <p:txBody>
-          <a:bodyPr wrap="none">
-            <a:spAutoFit/>
+          <a:bodyPr wrap="square" lIns="0" tIns="0" rIns="0" bIns="0">
+            <a:normAutofit/>
           </a:bodyPr>
           <a:lstStyle/>
           <a:p>
             <a:pPr algn="ctr">
-              <a:defRPr sz="850" b="1">
+              <a:defRPr sz="1050" b="1" i="0">
                 <a:solidFill>
                   <a:srgbClr val="34D399"/>
                 </a:solidFill>
@@ -5644,7 +5920,7 @@
       </p:sp>
       <p:sp>
         <p:nvSpPr>
-          <p:cNvPr id="22" name="TextBox 21"/>
+          <p:cNvPr id="24" name="TextBox 23"/>
           <p:cNvSpPr txBox="1"/>
           <p:nvPr/>
         </p:nvSpPr>
@@ -5659,13 +5935,13 @@
           <a:noFill/>
         </p:spPr>
         <p:txBody>
-          <a:bodyPr wrap="none">
-            <a:spAutoFit/>
+          <a:bodyPr wrap="square" lIns="0" tIns="0" rIns="0" bIns="0">
+            <a:normAutofit/>
           </a:bodyPr>
           <a:lstStyle/>
           <a:p>
-            <a:pPr>
-              <a:defRPr sz="1450" b="1">
+            <a:pPr algn="l">
+              <a:defRPr sz="1450" b="1" i="0">
                 <a:solidFill>
                   <a:srgbClr val="FFFFFF"/>
                 </a:solidFill>
@@ -5680,7 +5956,7 @@
       </p:sp>
       <p:sp>
         <p:nvSpPr>
-          <p:cNvPr id="23" name="TextBox 22"/>
+          <p:cNvPr id="25" name="TextBox 24"/>
           <p:cNvSpPr txBox="1"/>
           <p:nvPr/>
         </p:nvSpPr>
@@ -5695,13 +5971,13 @@
           <a:noFill/>
         </p:spPr>
         <p:txBody>
-          <a:bodyPr wrap="none">
-            <a:spAutoFit/>
+          <a:bodyPr wrap="square" lIns="0" tIns="0" rIns="0" bIns="0">
+            <a:normAutofit/>
           </a:bodyPr>
           <a:lstStyle/>
           <a:p>
-            <a:pPr>
-              <a:defRPr sz="1050" b="1">
+            <a:pPr algn="l">
+              <a:defRPr sz="1050" b="1" i="0">
                 <a:solidFill>
                   <a:srgbClr val="34D399"/>
                 </a:solidFill>
@@ -5716,7 +5992,7 @@
       </p:sp>
       <p:sp>
         <p:nvSpPr>
-          <p:cNvPr id="24" name="TextBox 23"/>
+          <p:cNvPr id="26" name="TextBox 25"/>
           <p:cNvSpPr txBox="1"/>
           <p:nvPr/>
         </p:nvSpPr>
@@ -5731,13 +6007,13 @@
           <a:noFill/>
         </p:spPr>
         <p:txBody>
-          <a:bodyPr wrap="none">
-            <a:spAutoFit/>
+          <a:bodyPr wrap="square" lIns="0" tIns="0" rIns="0" bIns="0">
+            <a:normAutofit/>
           </a:bodyPr>
           <a:lstStyle/>
           <a:p>
-            <a:pPr>
-              <a:defRPr sz="1100">
+            <a:pPr algn="l">
+              <a:defRPr sz="1100" b="0" i="0">
                 <a:solidFill>
                   <a:srgbClr val="94A3B8"/>
                 </a:solidFill>
@@ -5752,7 +6028,7 @@
       </p:sp>
       <p:sp>
         <p:nvSpPr>
-          <p:cNvPr id="25" name="Rounded Rectangle 24"/>
+          <p:cNvPr id="27" name="Rounded Rectangle 26"/>
           <p:cNvSpPr/>
           <p:nvPr/>
         </p:nvSpPr>
@@ -5762,7 +6038,9 @@
             <a:ext cx="5212080" cy="2240280"/>
           </a:xfrm>
           <a:prstGeom prst="roundRect">
-            <a:avLst/>
+            <a:avLst>
+              <a:gd name="adj" fmla="val 8000"/>
+            </a:avLst>
           </a:prstGeom>
           <a:solidFill>
             <a:srgbClr val="101622"/>
@@ -5797,7 +6075,7 @@
       </p:sp>
       <p:sp>
         <p:nvSpPr>
-          <p:cNvPr id="26" name="Rounded Rectangle 25"/>
+          <p:cNvPr id="28" name="Rounded Rectangle 27"/>
           <p:cNvSpPr/>
           <p:nvPr/>
         </p:nvSpPr>
@@ -5807,7 +6085,9 @@
             <a:ext cx="1645920" cy="256032"/>
           </a:xfrm>
           <a:prstGeom prst="roundRect">
-            <a:avLst/>
+            <a:avLst>
+              <a:gd name="adj" fmla="val 8000"/>
+            </a:avLst>
           </a:prstGeom>
           <a:solidFill>
             <a:srgbClr val="161E30"/>
@@ -5842,7 +6122,7 @@
       </p:sp>
       <p:sp>
         <p:nvSpPr>
-          <p:cNvPr id="27" name="TextBox 26"/>
+          <p:cNvPr id="29" name="TextBox 28"/>
           <p:cNvSpPr txBox="1"/>
           <p:nvPr/>
         </p:nvSpPr>
@@ -5857,35 +6137,179 @@
           <a:noFill/>
         </p:spPr>
         <p:txBody>
-          <a:bodyPr wrap="none">
+          <a:bodyPr wrap="square" lIns="0" tIns="0" rIns="0" bIns="0">
+            <a:normAutofit/>
+          </a:bodyPr>
+          <a:lstStyle/>
+          <a:p>
+            <a:pPr algn="ctr">
+              <a:defRPr sz="1050" b="1" i="0">
+                <a:solidFill>
+                  <a:srgbClr val="FBBF24"/>
+                </a:solidFill>
+                <a:latin typeface="Segoe UI"/>
+              </a:defRPr>
+            </a:pPr>
+            <a:r>
+              <a:t>SYNTHESIS</a:t>
+            </a:r>
+          </a:p>
+        </p:txBody>
+      </p:sp>
+      <p:sp>
+        <p:nvSpPr>
+          <p:cNvPr id="30" name="TextBox 29"/>
+          <p:cNvSpPr txBox="1"/>
+          <p:nvPr/>
+        </p:nvSpPr>
+        <p:spPr>
+          <a:xfrm>
+            <a:off x="6473952" y="4736592"/>
+            <a:ext cx="4700016" cy="411480"/>
+          </a:xfrm>
+          <a:prstGeom prst="rect">
+            <a:avLst/>
+          </a:prstGeom>
+          <a:noFill/>
+        </p:spPr>
+        <p:txBody>
+          <a:bodyPr wrap="square" lIns="0" tIns="0" rIns="0" bIns="0">
+            <a:normAutofit/>
+          </a:bodyPr>
+          <a:lstStyle/>
+          <a:p>
+            <a:pPr algn="l">
+              <a:defRPr sz="1450" b="1" i="0">
+                <a:solidFill>
+                  <a:srgbClr val="FFFFFF"/>
+                </a:solidFill>
+                <a:latin typeface="Segoe UI"/>
+              </a:defRPr>
+            </a:pPr>
+            <a:r>
+              <a:t>4-Slide Micro-Presentation</a:t>
+            </a:r>
+          </a:p>
+        </p:txBody>
+      </p:sp>
+      <p:sp>
+        <p:nvSpPr>
+          <p:cNvPr id="31" name="TextBox 30"/>
+          <p:cNvSpPr txBox="1"/>
+          <p:nvPr/>
+        </p:nvSpPr>
+        <p:spPr>
+          <a:xfrm>
+            <a:off x="6473952" y="5102352"/>
+            <a:ext cx="4700016" cy="274320"/>
+          </a:xfrm>
+          <a:prstGeom prst="rect">
+            <a:avLst/>
+          </a:prstGeom>
+          <a:noFill/>
+        </p:spPr>
+        <p:txBody>
+          <a:bodyPr wrap="square" lIns="0" tIns="0" rIns="0" bIns="0">
+            <a:normAutofit/>
+          </a:bodyPr>
+          <a:lstStyle/>
+          <a:p>
+            <a:pPr algn="l">
+              <a:defRPr sz="1050" b="1" i="0">
+                <a:solidFill>
+                  <a:srgbClr val="FBBF24"/>
+                </a:solidFill>
+                <a:latin typeface="Segoe UI"/>
+              </a:defRPr>
+            </a:pPr>
+            <a:r>
+              <a:t>SPECTRUM 4: EXAM TRAP DECK</a:t>
+            </a:r>
+          </a:p>
+        </p:txBody>
+      </p:sp>
+      <p:sp>
+        <p:nvSpPr>
+          <p:cNvPr id="32" name="TextBox 31"/>
+          <p:cNvSpPr txBox="1"/>
+          <p:nvPr/>
+        </p:nvSpPr>
+        <p:spPr>
+          <a:xfrm>
+            <a:off x="6473952" y="5422392"/>
+            <a:ext cx="4700016" cy="868680"/>
+          </a:xfrm>
+          <a:prstGeom prst="rect">
+            <a:avLst/>
+          </a:prstGeom>
+          <a:noFill/>
+        </p:spPr>
+        <p:txBody>
+          <a:bodyPr wrap="square" lIns="0" tIns="0" rIns="0" bIns="0">
+            <a:normAutofit/>
+          </a:bodyPr>
+          <a:lstStyle/>
+          <a:p>
+            <a:pPr algn="l">
+              <a:defRPr sz="1100" b="0" i="0">
+                <a:solidFill>
+                  <a:srgbClr val="94A3B8"/>
+                </a:solidFill>
+                <a:latin typeface="Segoe UI"/>
+              </a:defRPr>
+            </a:pPr>
+            <a:r>
+              <a:t>Exposes the exact trick questions professors test on Midterm #2, coupled with an AI visual memory anchor.</a:t>
+            </a:r>
+          </a:p>
+        </p:txBody>
+      </p:sp>
+      <p:sp>
+        <p:nvSpPr>
+          <p:cNvPr id="33" name="TextBox 32"/>
+          <p:cNvSpPr txBox="1"/>
+          <p:nvPr/>
+        </p:nvSpPr>
+        <p:spPr>
+          <a:xfrm>
+            <a:off x="731520" y="6473952"/>
+            <a:ext cx="5486400" cy="228600"/>
+          </a:xfrm>
+          <a:prstGeom prst="rect">
+            <a:avLst/>
+          </a:prstGeom>
+          <a:noFill/>
+        </p:spPr>
+        <p:txBody>
+          <a:bodyPr wrap="square">
             <a:spAutoFit/>
           </a:bodyPr>
           <a:lstStyle/>
           <a:p>
-            <a:pPr algn="ctr">
-              <a:defRPr sz="850" b="1">
-                <a:solidFill>
-                  <a:srgbClr val="FBBF24"/>
+            <a:pPr>
+              <a:defRPr sz="800">
+                <a:solidFill>
+                  <a:srgbClr val="64748B"/>
                 </a:solidFill>
                 <a:latin typeface="Segoe UI"/>
               </a:defRPr>
             </a:pPr>
             <a:r>
-              <a:t>SYNTHESIS</a:t>
-            </a:r>
-          </a:p>
-        </p:txBody>
-      </p:sp>
-      <p:sp>
-        <p:nvSpPr>
-          <p:cNvPr id="28" name="TextBox 27"/>
+              <a:t>CLOUD CONNECT 2026  •  PRISMATIC</a:t>
+            </a:r>
+          </a:p>
+        </p:txBody>
+      </p:sp>
+      <p:sp>
+        <p:nvSpPr>
+          <p:cNvPr id="34" name="TextBox 33"/>
           <p:cNvSpPr txBox="1"/>
           <p:nvPr/>
         </p:nvSpPr>
         <p:spPr>
           <a:xfrm>
-            <a:off x="6473952" y="4736592"/>
-            <a:ext cx="4700016" cy="411480"/>
+            <a:off x="10515600" y="6473952"/>
+            <a:ext cx="914400" cy="228600"/>
           </a:xfrm>
           <a:prstGeom prst="rect">
             <a:avLst/>
@@ -5893,93 +6317,21 @@
           <a:noFill/>
         </p:spPr>
         <p:txBody>
-          <a:bodyPr wrap="none">
+          <a:bodyPr wrap="square">
             <a:spAutoFit/>
           </a:bodyPr>
           <a:lstStyle/>
           <a:p>
-            <a:pPr>
-              <a:defRPr sz="1450" b="1">
-                <a:solidFill>
-                  <a:srgbClr val="FFFFFF"/>
+            <a:pPr algn="r">
+              <a:defRPr sz="800">
+                <a:solidFill>
+                  <a:srgbClr val="64748B"/>
                 </a:solidFill>
                 <a:latin typeface="Segoe UI"/>
               </a:defRPr>
             </a:pPr>
             <a:r>
-              <a:t>4-Slide Micro-Presentation</a:t>
-            </a:r>
-          </a:p>
-        </p:txBody>
-      </p:sp>
-      <p:sp>
-        <p:nvSpPr>
-          <p:cNvPr id="29" name="TextBox 28"/>
-          <p:cNvSpPr txBox="1"/>
-          <p:nvPr/>
-        </p:nvSpPr>
-        <p:spPr>
-          <a:xfrm>
-            <a:off x="6473952" y="5102352"/>
-            <a:ext cx="4700016" cy="274320"/>
-          </a:xfrm>
-          <a:prstGeom prst="rect">
-            <a:avLst/>
-          </a:prstGeom>
-          <a:noFill/>
-        </p:spPr>
-        <p:txBody>
-          <a:bodyPr wrap="none">
-            <a:spAutoFit/>
-          </a:bodyPr>
-          <a:lstStyle/>
-          <a:p>
-            <a:pPr>
-              <a:defRPr sz="1050" b="1">
-                <a:solidFill>
-                  <a:srgbClr val="FBBF24"/>
-                </a:solidFill>
-                <a:latin typeface="Segoe UI"/>
-              </a:defRPr>
-            </a:pPr>
-            <a:r>
-              <a:t>SPECTRUM 4: EXAM TRAP DECK</a:t>
-            </a:r>
-          </a:p>
-        </p:txBody>
-      </p:sp>
-      <p:sp>
-        <p:nvSpPr>
-          <p:cNvPr id="30" name="TextBox 29"/>
-          <p:cNvSpPr txBox="1"/>
-          <p:nvPr/>
-        </p:nvSpPr>
-        <p:spPr>
-          <a:xfrm>
-            <a:off x="6473952" y="5422392"/>
-            <a:ext cx="4700016" cy="868680"/>
-          </a:xfrm>
-          <a:prstGeom prst="rect">
-            <a:avLst/>
-          </a:prstGeom>
-          <a:noFill/>
-        </p:spPr>
-        <p:txBody>
-          <a:bodyPr wrap="none">
-            <a:spAutoFit/>
-          </a:bodyPr>
-          <a:lstStyle/>
-          <a:p>
-            <a:pPr>
-              <a:defRPr sz="1100">
-                <a:solidFill>
-                  <a:srgbClr val="94A3B8"/>
-                </a:solidFill>
-                <a:latin typeface="Segoe UI"/>
-              </a:defRPr>
-            </a:pPr>
-            <a:r>
-              <a:t>Exposes the exact trick questions professors test on Midterm #2, coupled with an AI visual memory anchor.</a:t>
+              <a:t>2 / 4</a:t>
             </a:r>
           </a:p>
         </p:txBody>
@@ -6047,7 +6399,93 @@
       </p:sp>
       <p:sp>
         <p:nvSpPr>
-          <p:cNvPr id="3" name="TextBox 2"/>
+          <p:cNvPr id="3" name="Rectangle 2"/>
+          <p:cNvSpPr/>
+          <p:nvPr/>
+        </p:nvSpPr>
+        <p:spPr>
+          <a:xfrm>
+            <a:off x="0" y="0"/>
+            <a:ext cx="6096304" cy="54864"/>
+          </a:xfrm>
+          <a:prstGeom prst="rect">
+            <a:avLst/>
+          </a:prstGeom>
+          <a:solidFill>
+            <a:srgbClr val="00E5FF"/>
+          </a:solidFill>
+          <a:ln>
+            <a:noFill/>
+          </a:ln>
+        </p:spPr>
+        <p:style>
+          <a:lnRef idx="1">
+            <a:schemeClr val="accent1"/>
+          </a:lnRef>
+          <a:fillRef idx="3">
+            <a:schemeClr val="accent1"/>
+          </a:fillRef>
+          <a:effectRef idx="2">
+            <a:schemeClr val="accent1"/>
+          </a:effectRef>
+          <a:fontRef idx="minor">
+            <a:schemeClr val="lt1"/>
+          </a:fontRef>
+        </p:style>
+        <p:txBody>
+          <a:bodyPr rtlCol="0" anchor="ctr"/>
+          <a:lstStyle/>
+          <a:p>
+            <a:pPr algn="ctr"/>
+          </a:p>
+        </p:txBody>
+      </p:sp>
+      <p:sp>
+        <p:nvSpPr>
+          <p:cNvPr id="4" name="Rectangle 3"/>
+          <p:cNvSpPr/>
+          <p:nvPr/>
+        </p:nvSpPr>
+        <p:spPr>
+          <a:xfrm>
+            <a:off x="6096304" y="0"/>
+            <a:ext cx="6095390" cy="54864"/>
+          </a:xfrm>
+          <a:prstGeom prst="rect">
+            <a:avLst/>
+          </a:prstGeom>
+          <a:solidFill>
+            <a:srgbClr val="B464FF"/>
+          </a:solidFill>
+          <a:ln>
+            <a:noFill/>
+          </a:ln>
+        </p:spPr>
+        <p:style>
+          <a:lnRef idx="1">
+            <a:schemeClr val="accent1"/>
+          </a:lnRef>
+          <a:fillRef idx="3">
+            <a:schemeClr val="accent1"/>
+          </a:fillRef>
+          <a:effectRef idx="2">
+            <a:schemeClr val="accent1"/>
+          </a:effectRef>
+          <a:fontRef idx="minor">
+            <a:schemeClr val="lt1"/>
+          </a:fontRef>
+        </p:style>
+        <p:txBody>
+          <a:bodyPr rtlCol="0" anchor="ctr"/>
+          <a:lstStyle/>
+          <a:p>
+            <a:pPr algn="ctr"/>
+          </a:p>
+        </p:txBody>
+      </p:sp>
+      <p:sp>
+        <p:nvSpPr>
+          <p:cNvPr id="5" name="TextBox 4"/>
           <p:cNvSpPr txBox="1"/>
           <p:nvPr/>
         </p:nvSpPr>
@@ -6063,12 +6501,12 @@
         </p:spPr>
         <p:txBody>
           <a:bodyPr wrap="square" lIns="0" tIns="0" rIns="0" bIns="0">
-            <a:spAutoFit/>
+            <a:normAutofit/>
           </a:bodyPr>
           <a:lstStyle/>
           <a:p>
-            <a:pPr>
-              <a:defRPr sz="1100" b="1">
+            <a:pPr algn="l">
+              <a:defRPr sz="1100" b="1" i="0">
                 <a:solidFill>
                   <a:srgbClr val="00E5FF"/>
                 </a:solidFill>
@@ -6083,7 +6521,7 @@
       </p:sp>
       <p:sp>
         <p:nvSpPr>
-          <p:cNvPr id="4" name="Rounded Rectangle 3"/>
+          <p:cNvPr id="6" name="Rounded Rectangle 5"/>
           <p:cNvSpPr/>
           <p:nvPr/>
         </p:nvSpPr>
@@ -6093,7 +6531,9 @@
             <a:ext cx="2011680" cy="347472"/>
           </a:xfrm>
           <a:prstGeom prst="roundRect">
-            <a:avLst/>
+            <a:avLst>
+              <a:gd name="adj" fmla="val 8000"/>
+            </a:avLst>
           </a:prstGeom>
           <a:solidFill>
             <a:srgbClr val="161E30"/>
@@ -6119,7 +6559,9 @@
           </a:fontRef>
         </p:style>
         <p:txBody>
-          <a:bodyPr rtlCol="0" anchor="ctr" lIns="0" rIns="0" tIns="0" bIns="0"/>
+          <a:bodyPr rtlCol="0" anchor="ctr" lIns="0" rIns="0" tIns="0" bIns="0" wrap="square">
+            <a:normAutofit/>
+          </a:bodyPr>
           <a:lstStyle/>
           <a:p>
             <a:pPr algn="ctr">
@@ -6138,7 +6580,7 @@
       </p:sp>
       <p:sp>
         <p:nvSpPr>
-          <p:cNvPr id="5" name="TextBox 4"/>
+          <p:cNvPr id="7" name="TextBox 6"/>
           <p:cNvSpPr txBox="1"/>
           <p:nvPr/>
         </p:nvSpPr>
@@ -6154,12 +6596,12 @@
         </p:spPr>
         <p:txBody>
           <a:bodyPr wrap="square" lIns="0" tIns="0" rIns="0" bIns="0">
-            <a:spAutoFit/>
+            <a:normAutofit/>
           </a:bodyPr>
           <a:lstStyle/>
           <a:p>
-            <a:pPr>
-              <a:defRPr sz="2300" b="1">
+            <a:pPr algn="l">
+              <a:defRPr sz="2300" b="1" i="0">
                 <a:solidFill>
                   <a:srgbClr val="FFFFFF"/>
                 </a:solidFill>
@@ -6174,7 +6616,7 @@
       </p:sp>
       <p:sp>
         <p:nvSpPr>
-          <p:cNvPr id="6" name="TextBox 5"/>
+          <p:cNvPr id="8" name="TextBox 7"/>
           <p:cNvSpPr txBox="1"/>
           <p:nvPr/>
         </p:nvSpPr>
@@ -6190,12 +6632,12 @@
         </p:spPr>
         <p:txBody>
           <a:bodyPr wrap="square" lIns="0" tIns="0" rIns="0" bIns="0">
-            <a:spAutoFit/>
+            <a:normAutofit/>
           </a:bodyPr>
           <a:lstStyle/>
           <a:p>
-            <a:pPr>
-              <a:defRPr sz="1200">
+            <a:pPr algn="l">
+              <a:defRPr sz="1050" b="0" i="0">
                 <a:solidFill>
                   <a:srgbClr val="94A3B8"/>
                 </a:solidFill>
@@ -6210,7 +6652,7 @@
       </p:sp>
       <p:sp>
         <p:nvSpPr>
-          <p:cNvPr id="7" name="Rounded Rectangle 6"/>
+          <p:cNvPr id="9" name="Rounded Rectangle 8"/>
           <p:cNvSpPr/>
           <p:nvPr/>
         </p:nvSpPr>
@@ -6220,7 +6662,9 @@
             <a:ext cx="3383280" cy="4480560"/>
           </a:xfrm>
           <a:prstGeom prst="roundRect">
-            <a:avLst/>
+            <a:avLst>
+              <a:gd name="adj" fmla="val 8000"/>
+            </a:avLst>
           </a:prstGeom>
           <a:solidFill>
             <a:srgbClr val="101622"/>
@@ -6255,7 +6699,7 @@
       </p:sp>
       <p:sp>
         <p:nvSpPr>
-          <p:cNvPr id="8" name="TextBox 7"/>
+          <p:cNvPr id="10" name="TextBox 9"/>
           <p:cNvSpPr txBox="1"/>
           <p:nvPr/>
         </p:nvSpPr>
@@ -6270,13 +6714,13 @@
           <a:noFill/>
         </p:spPr>
         <p:txBody>
-          <a:bodyPr wrap="none">
-            <a:spAutoFit/>
+          <a:bodyPr wrap="square" lIns="0" tIns="0" rIns="0" bIns="0">
+            <a:normAutofit/>
           </a:bodyPr>
           <a:lstStyle/>
           <a:p>
-            <a:pPr>
-              <a:defRPr sz="1200" b="1">
+            <a:pPr algn="l">
+              <a:defRPr sz="1200" b="1" i="0">
                 <a:solidFill>
                   <a:srgbClr val="00E5FF"/>
                 </a:solidFill>
@@ -6291,7 +6735,7 @@
       </p:sp>
       <p:sp>
         <p:nvSpPr>
-          <p:cNvPr id="9" name="TextBox 8"/>
+          <p:cNvPr id="11" name="TextBox 10"/>
           <p:cNvSpPr txBox="1"/>
           <p:nvPr/>
         </p:nvSpPr>
@@ -6306,13 +6750,13 @@
           <a:noFill/>
         </p:spPr>
         <p:txBody>
-          <a:bodyPr wrap="none">
-            <a:spAutoFit/>
+          <a:bodyPr wrap="square" lIns="0" tIns="0" rIns="0" bIns="0">
+            <a:normAutofit/>
           </a:bodyPr>
           <a:lstStyle/>
           <a:p>
-            <a:pPr>
-              <a:defRPr sz="1400" b="1">
+            <a:pPr algn="l">
+              <a:defRPr sz="1400" b="1" i="0">
                 <a:solidFill>
                   <a:srgbClr val="FFFFFF"/>
                 </a:solidFill>
@@ -6327,7 +6771,7 @@
       </p:sp>
       <p:sp>
         <p:nvSpPr>
-          <p:cNvPr id="10" name="TextBox 9"/>
+          <p:cNvPr id="12" name="TextBox 11"/>
           <p:cNvSpPr txBox="1"/>
           <p:nvPr/>
         </p:nvSpPr>
@@ -6342,13 +6786,13 @@
           <a:noFill/>
         </p:spPr>
         <p:txBody>
-          <a:bodyPr wrap="none">
-            <a:spAutoFit/>
+          <a:bodyPr wrap="square" lIns="0" tIns="0" rIns="0" bIns="0">
+            <a:normAutofit/>
           </a:bodyPr>
           <a:lstStyle/>
           <a:p>
-            <a:pPr>
-              <a:defRPr sz="1200">
+            <a:pPr algn="l">
+              <a:defRPr sz="1200" b="0" i="0">
                 <a:solidFill>
                   <a:srgbClr val="94A3B8"/>
                 </a:solidFill>
@@ -6363,7 +6807,7 @@
       </p:sp>
       <p:sp>
         <p:nvSpPr>
-          <p:cNvPr id="11" name="Rounded Rectangle 10"/>
+          <p:cNvPr id="13" name="Rounded Rectangle 12"/>
           <p:cNvSpPr/>
           <p:nvPr/>
         </p:nvSpPr>
@@ -6373,7 +6817,9 @@
             <a:ext cx="3383280" cy="4480560"/>
           </a:xfrm>
           <a:prstGeom prst="roundRect">
-            <a:avLst/>
+            <a:avLst>
+              <a:gd name="adj" fmla="val 8000"/>
+            </a:avLst>
           </a:prstGeom>
           <a:solidFill>
             <a:srgbClr val="101622"/>
@@ -6408,7 +6854,7 @@
       </p:sp>
       <p:sp>
         <p:nvSpPr>
-          <p:cNvPr id="12" name="TextBox 11"/>
+          <p:cNvPr id="14" name="TextBox 13"/>
           <p:cNvSpPr txBox="1"/>
           <p:nvPr/>
         </p:nvSpPr>
@@ -6423,13 +6869,13 @@
           <a:noFill/>
         </p:spPr>
         <p:txBody>
-          <a:bodyPr wrap="none">
-            <a:spAutoFit/>
+          <a:bodyPr wrap="square" lIns="0" tIns="0" rIns="0" bIns="0">
+            <a:normAutofit/>
           </a:bodyPr>
           <a:lstStyle/>
           <a:p>
-            <a:pPr>
-              <a:defRPr sz="1200" b="1">
+            <a:pPr algn="l">
+              <a:defRPr sz="1200" b="1" i="0">
                 <a:solidFill>
                   <a:srgbClr val="FF6B6B"/>
                 </a:solidFill>
@@ -6444,7 +6890,7 @@
       </p:sp>
       <p:sp>
         <p:nvSpPr>
-          <p:cNvPr id="13" name="TextBox 12"/>
+          <p:cNvPr id="15" name="TextBox 14"/>
           <p:cNvSpPr txBox="1"/>
           <p:nvPr/>
         </p:nvSpPr>
@@ -6459,13 +6905,13 @@
           <a:noFill/>
         </p:spPr>
         <p:txBody>
-          <a:bodyPr wrap="none">
-            <a:spAutoFit/>
+          <a:bodyPr wrap="square" lIns="0" tIns="0" rIns="0" bIns="0">
+            <a:normAutofit/>
           </a:bodyPr>
           <a:lstStyle/>
           <a:p>
-            <a:pPr>
-              <a:defRPr sz="1400" b="1">
+            <a:pPr algn="l">
+              <a:defRPr sz="1400" b="1" i="0">
                 <a:solidFill>
                   <a:srgbClr val="FFFFFF"/>
                 </a:solidFill>
@@ -6480,7 +6926,7 @@
       </p:sp>
       <p:sp>
         <p:nvSpPr>
-          <p:cNvPr id="14" name="TextBox 13"/>
+          <p:cNvPr id="16" name="TextBox 15"/>
           <p:cNvSpPr txBox="1"/>
           <p:nvPr/>
         </p:nvSpPr>
@@ -6495,13 +6941,13 @@
           <a:noFill/>
         </p:spPr>
         <p:txBody>
-          <a:bodyPr wrap="none">
-            <a:spAutoFit/>
+          <a:bodyPr wrap="square" lIns="0" tIns="0" rIns="0" bIns="0">
+            <a:normAutofit/>
           </a:bodyPr>
           <a:lstStyle/>
           <a:p>
-            <a:pPr>
-              <a:defRPr sz="1200">
+            <a:pPr algn="l">
+              <a:defRPr sz="1200" b="0" i="0">
                 <a:solidFill>
                   <a:srgbClr val="94A3B8"/>
                 </a:solidFill>
@@ -6516,7 +6962,7 @@
       </p:sp>
       <p:sp>
         <p:nvSpPr>
-          <p:cNvPr id="15" name="Rounded Rectangle 14"/>
+          <p:cNvPr id="17" name="Rounded Rectangle 16"/>
           <p:cNvSpPr/>
           <p:nvPr/>
         </p:nvSpPr>
@@ -6526,7 +6972,9 @@
             <a:ext cx="3383280" cy="4480560"/>
           </a:xfrm>
           <a:prstGeom prst="roundRect">
-            <a:avLst/>
+            <a:avLst>
+              <a:gd name="adj" fmla="val 8000"/>
+            </a:avLst>
           </a:prstGeom>
           <a:solidFill>
             <a:srgbClr val="101622"/>
@@ -6561,7 +7009,7 @@
       </p:sp>
       <p:sp>
         <p:nvSpPr>
-          <p:cNvPr id="16" name="TextBox 15"/>
+          <p:cNvPr id="18" name="TextBox 17"/>
           <p:cNvSpPr txBox="1"/>
           <p:nvPr/>
         </p:nvSpPr>
@@ -6576,35 +7024,143 @@
           <a:noFill/>
         </p:spPr>
         <p:txBody>
-          <a:bodyPr wrap="none">
+          <a:bodyPr wrap="square" lIns="0" tIns="0" rIns="0" bIns="0">
+            <a:normAutofit/>
+          </a:bodyPr>
+          <a:lstStyle/>
+          <a:p>
+            <a:pPr algn="l">
+              <a:defRPr sz="1200" b="1" i="0">
+                <a:solidFill>
+                  <a:srgbClr val="34D399"/>
+                </a:solidFill>
+                <a:latin typeface="Segoe UI"/>
+              </a:defRPr>
+            </a:pPr>
+            <a:r>
+              <a:t>VS. STATIC SLIDES</a:t>
+            </a:r>
+          </a:p>
+        </p:txBody>
+      </p:sp>
+      <p:sp>
+        <p:nvSpPr>
+          <p:cNvPr id="19" name="TextBox 18"/>
+          <p:cNvSpPr txBox="1"/>
+          <p:nvPr/>
+        </p:nvSpPr>
+        <p:spPr>
+          <a:xfrm>
+            <a:off x="8321040" y="2423160"/>
+            <a:ext cx="2834640" cy="502920"/>
+          </a:xfrm>
+          <a:prstGeom prst="rect">
+            <a:avLst/>
+          </a:prstGeom>
+          <a:noFill/>
+        </p:spPr>
+        <p:txBody>
+          <a:bodyPr wrap="square" lIns="0" tIns="0" rIns="0" bIns="0">
+            <a:normAutofit/>
+          </a:bodyPr>
+          <a:lstStyle/>
+          <a:p>
+            <a:pPr algn="l">
+              <a:defRPr sz="1400" b="1" i="0">
+                <a:solidFill>
+                  <a:srgbClr val="FFFFFF"/>
+                </a:solidFill>
+                <a:latin typeface="Segoe UI"/>
+              </a:defRPr>
+            </a:pPr>
+            <a:r>
+              <a:t>Dynamic Cognitive Fit</a:t>
+            </a:r>
+          </a:p>
+        </p:txBody>
+      </p:sp>
+      <p:sp>
+        <p:nvSpPr>
+          <p:cNvPr id="20" name="TextBox 19"/>
+          <p:cNvSpPr txBox="1"/>
+          <p:nvPr/>
+        </p:nvSpPr>
+        <p:spPr>
+          <a:xfrm>
+            <a:off x="8321040" y="3017520"/>
+            <a:ext cx="2834640" cy="2651760"/>
+          </a:xfrm>
+          <a:prstGeom prst="rect">
+            <a:avLst/>
+          </a:prstGeom>
+          <a:noFill/>
+        </p:spPr>
+        <p:txBody>
+          <a:bodyPr wrap="square" lIns="0" tIns="0" rIns="0" bIns="0">
+            <a:normAutofit/>
+          </a:bodyPr>
+          <a:lstStyle/>
+          <a:p>
+            <a:pPr algn="l">
+              <a:defRPr sz="1200" b="0" i="0">
+                <a:solidFill>
+                  <a:srgbClr val="94A3B8"/>
+                </a:solidFill>
+                <a:latin typeface="Segoe UI"/>
+              </a:defRPr>
+            </a:pPr>
+            <a:r>
+              <a:t>Eliminates task paralysis for ADHD, visual, and conceptual learners through a 30-second diagnostic triage.</a:t>
+            </a:r>
+          </a:p>
+        </p:txBody>
+      </p:sp>
+      <p:sp>
+        <p:nvSpPr>
+          <p:cNvPr id="21" name="TextBox 20"/>
+          <p:cNvSpPr txBox="1"/>
+          <p:nvPr/>
+        </p:nvSpPr>
+        <p:spPr>
+          <a:xfrm>
+            <a:off x="731520" y="6473952"/>
+            <a:ext cx="5486400" cy="228600"/>
+          </a:xfrm>
+          <a:prstGeom prst="rect">
+            <a:avLst/>
+          </a:prstGeom>
+          <a:noFill/>
+        </p:spPr>
+        <p:txBody>
+          <a:bodyPr wrap="square">
             <a:spAutoFit/>
           </a:bodyPr>
           <a:lstStyle/>
           <a:p>
             <a:pPr>
-              <a:defRPr sz="1200" b="1">
-                <a:solidFill>
-                  <a:srgbClr val="34D399"/>
+              <a:defRPr sz="800">
+                <a:solidFill>
+                  <a:srgbClr val="64748B"/>
                 </a:solidFill>
                 <a:latin typeface="Segoe UI"/>
               </a:defRPr>
             </a:pPr>
             <a:r>
-              <a:t>VS. STATIC SLIDES</a:t>
-            </a:r>
-          </a:p>
-        </p:txBody>
-      </p:sp>
-      <p:sp>
-        <p:nvSpPr>
-          <p:cNvPr id="17" name="TextBox 16"/>
+              <a:t>CLOUD CONNECT 2026  •  PRISMATIC</a:t>
+            </a:r>
+          </a:p>
+        </p:txBody>
+      </p:sp>
+      <p:sp>
+        <p:nvSpPr>
+          <p:cNvPr id="22" name="TextBox 21"/>
           <p:cNvSpPr txBox="1"/>
           <p:nvPr/>
         </p:nvSpPr>
         <p:spPr>
           <a:xfrm>
-            <a:off x="8321040" y="2423160"/>
-            <a:ext cx="2834640" cy="502920"/>
+            <a:off x="10515600" y="6473952"/>
+            <a:ext cx="914400" cy="228600"/>
           </a:xfrm>
           <a:prstGeom prst="rect">
             <a:avLst/>
@@ -6612,57 +7168,21 @@
           <a:noFill/>
         </p:spPr>
         <p:txBody>
-          <a:bodyPr wrap="none">
+          <a:bodyPr wrap="square">
             <a:spAutoFit/>
           </a:bodyPr>
           <a:lstStyle/>
           <a:p>
-            <a:pPr>
-              <a:defRPr sz="1400" b="1">
-                <a:solidFill>
-                  <a:srgbClr val="FFFFFF"/>
+            <a:pPr algn="r">
+              <a:defRPr sz="800">
+                <a:solidFill>
+                  <a:srgbClr val="64748B"/>
                 </a:solidFill>
                 <a:latin typeface="Segoe UI"/>
               </a:defRPr>
             </a:pPr>
             <a:r>
-              <a:t>Dynamic Cognitive Fit</a:t>
-            </a:r>
-          </a:p>
-        </p:txBody>
-      </p:sp>
-      <p:sp>
-        <p:nvSpPr>
-          <p:cNvPr id="18" name="TextBox 17"/>
-          <p:cNvSpPr txBox="1"/>
-          <p:nvPr/>
-        </p:nvSpPr>
-        <p:spPr>
-          <a:xfrm>
-            <a:off x="8321040" y="3017520"/>
-            <a:ext cx="2834640" cy="2651760"/>
-          </a:xfrm>
-          <a:prstGeom prst="rect">
-            <a:avLst/>
-          </a:prstGeom>
-          <a:noFill/>
-        </p:spPr>
-        <p:txBody>
-          <a:bodyPr wrap="none">
-            <a:spAutoFit/>
-          </a:bodyPr>
-          <a:lstStyle/>
-          <a:p>
-            <a:pPr>
-              <a:defRPr sz="1200">
-                <a:solidFill>
-                  <a:srgbClr val="94A3B8"/>
-                </a:solidFill>
-                <a:latin typeface="Segoe UI"/>
-              </a:defRPr>
-            </a:pPr>
-            <a:r>
-              <a:t>Eliminates task paralysis for ADHD, visual, and conceptual learners through a 30-second diagnostic triage.</a:t>
+              <a:t>3 / 4</a:t>
             </a:r>
           </a:p>
         </p:txBody>
@@ -6730,7 +7250,93 @@
       </p:sp>
       <p:sp>
         <p:nvSpPr>
-          <p:cNvPr id="3" name="TextBox 2"/>
+          <p:cNvPr id="3" name="Rectangle 2"/>
+          <p:cNvSpPr/>
+          <p:nvPr/>
+        </p:nvSpPr>
+        <p:spPr>
+          <a:xfrm>
+            <a:off x="0" y="0"/>
+            <a:ext cx="6096304" cy="54864"/>
+          </a:xfrm>
+          <a:prstGeom prst="rect">
+            <a:avLst/>
+          </a:prstGeom>
+          <a:solidFill>
+            <a:srgbClr val="00E5FF"/>
+          </a:solidFill>
+          <a:ln>
+            <a:noFill/>
+          </a:ln>
+        </p:spPr>
+        <p:style>
+          <a:lnRef idx="1">
+            <a:schemeClr val="accent1"/>
+          </a:lnRef>
+          <a:fillRef idx="3">
+            <a:schemeClr val="accent1"/>
+          </a:fillRef>
+          <a:effectRef idx="2">
+            <a:schemeClr val="accent1"/>
+          </a:effectRef>
+          <a:fontRef idx="minor">
+            <a:schemeClr val="lt1"/>
+          </a:fontRef>
+        </p:style>
+        <p:txBody>
+          <a:bodyPr rtlCol="0" anchor="ctr"/>
+          <a:lstStyle/>
+          <a:p>
+            <a:pPr algn="ctr"/>
+          </a:p>
+        </p:txBody>
+      </p:sp>
+      <p:sp>
+        <p:nvSpPr>
+          <p:cNvPr id="4" name="Rectangle 3"/>
+          <p:cNvSpPr/>
+          <p:nvPr/>
+        </p:nvSpPr>
+        <p:spPr>
+          <a:xfrm>
+            <a:off x="6096304" y="0"/>
+            <a:ext cx="6095390" cy="54864"/>
+          </a:xfrm>
+          <a:prstGeom prst="rect">
+            <a:avLst/>
+          </a:prstGeom>
+          <a:solidFill>
+            <a:srgbClr val="B464FF"/>
+          </a:solidFill>
+          <a:ln>
+            <a:noFill/>
+          </a:ln>
+        </p:spPr>
+        <p:style>
+          <a:lnRef idx="1">
+            <a:schemeClr val="accent1"/>
+          </a:lnRef>
+          <a:fillRef idx="3">
+            <a:schemeClr val="accent1"/>
+          </a:fillRef>
+          <a:effectRef idx="2">
+            <a:schemeClr val="accent1"/>
+          </a:effectRef>
+          <a:fontRef idx="minor">
+            <a:schemeClr val="lt1"/>
+          </a:fontRef>
+        </p:style>
+        <p:txBody>
+          <a:bodyPr rtlCol="0" anchor="ctr"/>
+          <a:lstStyle/>
+          <a:p>
+            <a:pPr algn="ctr"/>
+          </a:p>
+        </p:txBody>
+      </p:sp>
+      <p:sp>
+        <p:nvSpPr>
+          <p:cNvPr id="5" name="TextBox 4"/>
           <p:cNvSpPr txBox="1"/>
           <p:nvPr/>
         </p:nvSpPr>
@@ -6746,12 +7352,12 @@
         </p:spPr>
         <p:txBody>
           <a:bodyPr wrap="square" lIns="0" tIns="0" rIns="0" bIns="0">
-            <a:spAutoFit/>
+            <a:normAutofit/>
           </a:bodyPr>
           <a:lstStyle/>
           <a:p>
-            <a:pPr>
-              <a:defRPr sz="1100" b="1">
+            <a:pPr algn="l">
+              <a:defRPr sz="1100" b="1" i="0">
                 <a:solidFill>
                   <a:srgbClr val="00E5FF"/>
                 </a:solidFill>
@@ -6766,7 +7372,7 @@
       </p:sp>
       <p:sp>
         <p:nvSpPr>
-          <p:cNvPr id="4" name="Rounded Rectangle 3"/>
+          <p:cNvPr id="6" name="Rounded Rectangle 5"/>
           <p:cNvSpPr/>
           <p:nvPr/>
         </p:nvSpPr>
@@ -6776,7 +7382,9 @@
             <a:ext cx="2011680" cy="347472"/>
           </a:xfrm>
           <a:prstGeom prst="roundRect">
-            <a:avLst/>
+            <a:avLst>
+              <a:gd name="adj" fmla="val 8000"/>
+            </a:avLst>
           </a:prstGeom>
           <a:solidFill>
             <a:srgbClr val="161E30"/>
@@ -6802,7 +7410,9 @@
           </a:fontRef>
         </p:style>
         <p:txBody>
-          <a:bodyPr rtlCol="0" anchor="ctr" lIns="0" rIns="0" tIns="0" bIns="0"/>
+          <a:bodyPr rtlCol="0" anchor="ctr" lIns="0" rIns="0" tIns="0" bIns="0" wrap="square">
+            <a:normAutofit/>
+          </a:bodyPr>
           <a:lstStyle/>
           <a:p>
             <a:pPr algn="ctr">
@@ -6821,7 +7431,7 @@
       </p:sp>
       <p:sp>
         <p:nvSpPr>
-          <p:cNvPr id="5" name="TextBox 4"/>
+          <p:cNvPr id="7" name="TextBox 6"/>
           <p:cNvSpPr txBox="1"/>
           <p:nvPr/>
         </p:nvSpPr>
@@ -6837,12 +7447,12 @@
         </p:spPr>
         <p:txBody>
           <a:bodyPr wrap="square" lIns="0" tIns="0" rIns="0" bIns="0">
-            <a:spAutoFit/>
+            <a:normAutofit/>
           </a:bodyPr>
           <a:lstStyle/>
           <a:p>
-            <a:pPr>
-              <a:defRPr sz="2300" b="1">
+            <a:pPr algn="l">
+              <a:defRPr sz="2300" b="1" i="0">
                 <a:solidFill>
                   <a:srgbClr val="FFFFFF"/>
                 </a:solidFill>
@@ -6857,7 +7467,7 @@
       </p:sp>
       <p:sp>
         <p:nvSpPr>
-          <p:cNvPr id="6" name="TextBox 5"/>
+          <p:cNvPr id="8" name="TextBox 7"/>
           <p:cNvSpPr txBox="1"/>
           <p:nvPr/>
         </p:nvSpPr>
@@ -6873,12 +7483,12 @@
         </p:spPr>
         <p:txBody>
           <a:bodyPr wrap="square" lIns="0" tIns="0" rIns="0" bIns="0">
-            <a:spAutoFit/>
+            <a:normAutofit/>
           </a:bodyPr>
           <a:lstStyle/>
           <a:p>
-            <a:pPr>
-              <a:defRPr sz="1200">
+            <a:pPr algn="l">
+              <a:defRPr sz="1050" b="0" i="0">
                 <a:solidFill>
                   <a:srgbClr val="94A3B8"/>
                 </a:solidFill>
@@ -6893,7 +7503,7 @@
       </p:sp>
       <p:sp>
         <p:nvSpPr>
-          <p:cNvPr id="7" name="Rounded Rectangle 6"/>
+          <p:cNvPr id="9" name="Rounded Rectangle 8"/>
           <p:cNvSpPr/>
           <p:nvPr/>
         </p:nvSpPr>
@@ -6903,7 +7513,9 @@
             <a:ext cx="2468880" cy="1417320"/>
           </a:xfrm>
           <a:prstGeom prst="roundRect">
-            <a:avLst/>
+            <a:avLst>
+              <a:gd name="adj" fmla="val 8000"/>
+            </a:avLst>
           </a:prstGeom>
           <a:solidFill>
             <a:srgbClr val="101622"/>
@@ -6938,7 +7550,7 @@
       </p:sp>
       <p:sp>
         <p:nvSpPr>
-          <p:cNvPr id="8" name="TextBox 7"/>
+          <p:cNvPr id="10" name="TextBox 9"/>
           <p:cNvSpPr txBox="1"/>
           <p:nvPr/>
         </p:nvSpPr>
@@ -6953,13 +7565,13 @@
           <a:noFill/>
         </p:spPr>
         <p:txBody>
-          <a:bodyPr wrap="none">
-            <a:spAutoFit/>
+          <a:bodyPr wrap="square" lIns="0" tIns="0" rIns="0" bIns="0">
+            <a:normAutofit/>
           </a:bodyPr>
           <a:lstStyle/>
           <a:p>
-            <a:pPr>
-              <a:defRPr sz="1200" b="1">
+            <a:pPr algn="l">
+              <a:defRPr sz="1200" b="1" i="0">
                 <a:solidFill>
                   <a:srgbClr val="00E5FF"/>
                 </a:solidFill>
@@ -6974,7 +7586,7 @@
       </p:sp>
       <p:sp>
         <p:nvSpPr>
-          <p:cNvPr id="9" name="TextBox 8"/>
+          <p:cNvPr id="11" name="TextBox 10"/>
           <p:cNvSpPr txBox="1"/>
           <p:nvPr/>
         </p:nvSpPr>
@@ -6989,13 +7601,13 @@
           <a:noFill/>
         </p:spPr>
         <p:txBody>
-          <a:bodyPr wrap="none">
-            <a:spAutoFit/>
+          <a:bodyPr wrap="square" lIns="0" tIns="0" rIns="0" bIns="0">
+            <a:normAutofit/>
           </a:bodyPr>
           <a:lstStyle/>
           <a:p>
-            <a:pPr>
-              <a:defRPr sz="1050">
+            <a:pPr algn="l">
+              <a:defRPr sz="1050" b="0" i="0">
                 <a:solidFill>
                   <a:srgbClr val="F1F5F9"/>
                 </a:solidFill>
@@ -7010,7 +7622,7 @@
       </p:sp>
       <p:sp>
         <p:nvSpPr>
-          <p:cNvPr id="10" name="Rounded Rectangle 9"/>
+          <p:cNvPr id="12" name="Rounded Rectangle 11"/>
           <p:cNvSpPr/>
           <p:nvPr/>
         </p:nvSpPr>
@@ -7020,7 +7632,9 @@
             <a:ext cx="2468880" cy="1417320"/>
           </a:xfrm>
           <a:prstGeom prst="roundRect">
-            <a:avLst/>
+            <a:avLst>
+              <a:gd name="adj" fmla="val 8000"/>
+            </a:avLst>
           </a:prstGeom>
           <a:solidFill>
             <a:srgbClr val="101622"/>
@@ -7055,7 +7669,7 @@
       </p:sp>
       <p:sp>
         <p:nvSpPr>
-          <p:cNvPr id="11" name="TextBox 10"/>
+          <p:cNvPr id="13" name="TextBox 12"/>
           <p:cNvSpPr txBox="1"/>
           <p:nvPr/>
         </p:nvSpPr>
@@ -7070,13 +7684,13 @@
           <a:noFill/>
         </p:spPr>
         <p:txBody>
-          <a:bodyPr wrap="none">
-            <a:spAutoFit/>
+          <a:bodyPr wrap="square" lIns="0" tIns="0" rIns="0" bIns="0">
+            <a:normAutofit/>
           </a:bodyPr>
           <a:lstStyle/>
           <a:p>
-            <a:pPr>
-              <a:defRPr sz="1200" b="1">
+            <a:pPr algn="l">
+              <a:defRPr sz="1200" b="1" i="0">
                 <a:solidFill>
                   <a:srgbClr val="34D399"/>
                 </a:solidFill>
@@ -7091,7 +7705,7 @@
       </p:sp>
       <p:sp>
         <p:nvSpPr>
-          <p:cNvPr id="12" name="TextBox 11"/>
+          <p:cNvPr id="14" name="TextBox 13"/>
           <p:cNvSpPr txBox="1"/>
           <p:nvPr/>
         </p:nvSpPr>
@@ -7106,13 +7720,13 @@
           <a:noFill/>
         </p:spPr>
         <p:txBody>
-          <a:bodyPr wrap="none">
-            <a:spAutoFit/>
+          <a:bodyPr wrap="square" lIns="0" tIns="0" rIns="0" bIns="0">
+            <a:normAutofit/>
           </a:bodyPr>
           <a:lstStyle/>
           <a:p>
-            <a:pPr>
-              <a:defRPr sz="1050">
+            <a:pPr algn="l">
+              <a:defRPr sz="1050" b="0" i="0">
                 <a:solidFill>
                   <a:srgbClr val="F1F5F9"/>
                 </a:solidFill>
@@ -7127,7 +7741,7 @@
       </p:sp>
       <p:sp>
         <p:nvSpPr>
-          <p:cNvPr id="13" name="Rounded Rectangle 12"/>
+          <p:cNvPr id="15" name="Rounded Rectangle 14"/>
           <p:cNvSpPr/>
           <p:nvPr/>
         </p:nvSpPr>
@@ -7137,7 +7751,9 @@
             <a:ext cx="2468880" cy="1417320"/>
           </a:xfrm>
           <a:prstGeom prst="roundRect">
-            <a:avLst/>
+            <a:avLst>
+              <a:gd name="adj" fmla="val 8000"/>
+            </a:avLst>
           </a:prstGeom>
           <a:solidFill>
             <a:srgbClr val="101622"/>
@@ -7172,7 +7788,7 @@
       </p:sp>
       <p:sp>
         <p:nvSpPr>
-          <p:cNvPr id="14" name="TextBox 13"/>
+          <p:cNvPr id="16" name="TextBox 15"/>
           <p:cNvSpPr txBox="1"/>
           <p:nvPr/>
         </p:nvSpPr>
@@ -7187,13 +7803,13 @@
           <a:noFill/>
         </p:spPr>
         <p:txBody>
-          <a:bodyPr wrap="none">
-            <a:spAutoFit/>
+          <a:bodyPr wrap="square" lIns="0" tIns="0" rIns="0" bIns="0">
+            <a:normAutofit/>
           </a:bodyPr>
           <a:lstStyle/>
           <a:p>
-            <a:pPr>
-              <a:defRPr sz="1200" b="1">
+            <a:pPr algn="l">
+              <a:defRPr sz="1200" b="1" i="0">
                 <a:solidFill>
                   <a:srgbClr val="B464FF"/>
                 </a:solidFill>
@@ -7208,7 +7824,7 @@
       </p:sp>
       <p:sp>
         <p:nvSpPr>
-          <p:cNvPr id="15" name="TextBox 14"/>
+          <p:cNvPr id="17" name="TextBox 16"/>
           <p:cNvSpPr txBox="1"/>
           <p:nvPr/>
         </p:nvSpPr>
@@ -7223,13 +7839,13 @@
           <a:noFill/>
         </p:spPr>
         <p:txBody>
-          <a:bodyPr wrap="none">
-            <a:spAutoFit/>
+          <a:bodyPr wrap="square" lIns="0" tIns="0" rIns="0" bIns="0">
+            <a:normAutofit/>
           </a:bodyPr>
           <a:lstStyle/>
           <a:p>
-            <a:pPr>
-              <a:defRPr sz="1050">
+            <a:pPr algn="l">
+              <a:defRPr sz="1050" b="0" i="0">
                 <a:solidFill>
                   <a:srgbClr val="F1F5F9"/>
                 </a:solidFill>
@@ -7244,7 +7860,7 @@
       </p:sp>
       <p:sp>
         <p:nvSpPr>
-          <p:cNvPr id="16" name="Rounded Rectangle 15"/>
+          <p:cNvPr id="18" name="Rounded Rectangle 17"/>
           <p:cNvSpPr/>
           <p:nvPr/>
         </p:nvSpPr>
@@ -7254,7 +7870,9 @@
             <a:ext cx="2468880" cy="1417320"/>
           </a:xfrm>
           <a:prstGeom prst="roundRect">
-            <a:avLst/>
+            <a:avLst>
+              <a:gd name="adj" fmla="val 8000"/>
+            </a:avLst>
           </a:prstGeom>
           <a:solidFill>
             <a:srgbClr val="101622"/>
@@ -7289,7 +7907,7 @@
       </p:sp>
       <p:sp>
         <p:nvSpPr>
-          <p:cNvPr id="17" name="TextBox 16"/>
+          <p:cNvPr id="19" name="TextBox 18"/>
           <p:cNvSpPr txBox="1"/>
           <p:nvPr/>
         </p:nvSpPr>
@@ -7304,13 +7922,13 @@
           <a:noFill/>
         </p:spPr>
         <p:txBody>
-          <a:bodyPr wrap="none">
-            <a:spAutoFit/>
+          <a:bodyPr wrap="square" lIns="0" tIns="0" rIns="0" bIns="0">
+            <a:normAutofit/>
           </a:bodyPr>
           <a:lstStyle/>
           <a:p>
-            <a:pPr>
-              <a:defRPr sz="1200" b="1">
+            <a:pPr algn="l">
+              <a:defRPr sz="1200" b="1" i="0">
                 <a:solidFill>
                   <a:srgbClr val="FBBF24"/>
                 </a:solidFill>
@@ -7325,7 +7943,7 @@
       </p:sp>
       <p:sp>
         <p:nvSpPr>
-          <p:cNvPr id="18" name="TextBox 17"/>
+          <p:cNvPr id="20" name="TextBox 19"/>
           <p:cNvSpPr txBox="1"/>
           <p:nvPr/>
         </p:nvSpPr>
@@ -7340,13 +7958,13 @@
           <a:noFill/>
         </p:spPr>
         <p:txBody>
-          <a:bodyPr wrap="none">
-            <a:spAutoFit/>
+          <a:bodyPr wrap="square" lIns="0" tIns="0" rIns="0" bIns="0">
+            <a:normAutofit/>
           </a:bodyPr>
           <a:lstStyle/>
           <a:p>
-            <a:pPr>
-              <a:defRPr sz="1050">
+            <a:pPr algn="l">
+              <a:defRPr sz="1050" b="0" i="0">
                 <a:solidFill>
                   <a:srgbClr val="F1F5F9"/>
                 </a:solidFill>
@@ -7361,7 +7979,7 @@
       </p:sp>
       <p:sp>
         <p:nvSpPr>
-          <p:cNvPr id="19" name="Rounded Rectangle 18"/>
+          <p:cNvPr id="21" name="Rounded Rectangle 20"/>
           <p:cNvSpPr/>
           <p:nvPr/>
         </p:nvSpPr>
@@ -7371,7 +7989,9 @@
             <a:ext cx="10728655" cy="3017520"/>
           </a:xfrm>
           <a:prstGeom prst="roundRect">
-            <a:avLst/>
+            <a:avLst>
+              <a:gd name="adj" fmla="val 8000"/>
+            </a:avLst>
           </a:prstGeom>
           <a:solidFill>
             <a:srgbClr val="101622"/>
@@ -7406,7 +8026,7 @@
       </p:sp>
       <p:sp>
         <p:nvSpPr>
-          <p:cNvPr id="20" name="TextBox 19"/>
+          <p:cNvPr id="22" name="TextBox 21"/>
           <p:cNvSpPr txBox="1"/>
           <p:nvPr/>
         </p:nvSpPr>
@@ -7414,6 +8034,73 @@
           <a:xfrm>
             <a:off x="1097280" y="3520440"/>
             <a:ext cx="9966960" cy="2560320"/>
+          </a:xfrm>
+          <a:prstGeom prst="rect">
+            <a:avLst/>
+          </a:prstGeom>
+          <a:noFill/>
+        </p:spPr>
+        <p:txBody>
+          <a:bodyPr wrap="square">
+            <a:normAutofit/>
+          </a:bodyPr>
+          <a:lstStyle/>
+          <a:p>
+            <a:pPr>
+              <a:defRPr sz="1200" b="1">
+                <a:solidFill>
+                  <a:srgbClr val="00E5FF"/>
+                </a:solidFill>
+                <a:latin typeface="Segoe UI"/>
+              </a:defRPr>
+            </a:pPr>
+            <a:r>
+              <a:t>OFFICIAL HANDOUT MANDATE: 'WITH MORE TIME WE'D ADD...'</a:t>
+            </a:r>
+          </a:p>
+          <a:p>
+            <a:pPr>
+              <a:defRPr sz="1350" i="1">
+                <a:solidFill>
+                  <a:srgbClr val="FFFFFF"/>
+                </a:solidFill>
+                <a:latin typeface="Segoe UI"/>
+              </a:defRPr>
+            </a:pPr>
+            <a:r>
+              <a:t>"With more time, we’d add live Canvas and syllabus LMS integration, automatically syncing weekly exam dates and generating proactive 15-minute micro-sprints before every morning class.</a:t>
+            </a:r>
+            <a:br/>
+            <a:br/>
+            <a:r>
+              <a:t>We don't just help students pass exams; we eliminate academic paralysis and unlock confidence."</a:t>
+            </a:r>
+          </a:p>
+          <a:p>
+            <a:pPr>
+              <a:defRPr sz="1300" b="1">
+                <a:solidFill>
+                  <a:srgbClr val="34D399"/>
+                </a:solidFill>
+                <a:latin typeface="Segoe UI"/>
+              </a:defRPr>
+            </a:pPr>
+            <a:r>
+              <a:t>WE ARE PRISMATIC — REFRACTING COMPLEX KNOWLEDGE INTO YOUR NATIVE SPECTRUM. VOTE PRISMATIC!</a:t>
+            </a:r>
+          </a:p>
+        </p:txBody>
+      </p:sp>
+      <p:sp>
+        <p:nvSpPr>
+          <p:cNvPr id="23" name="TextBox 22"/>
+          <p:cNvSpPr txBox="1"/>
+          <p:nvPr/>
+        </p:nvSpPr>
+        <p:spPr>
+          <a:xfrm>
+            <a:off x="731520" y="6473952"/>
+            <a:ext cx="5486400" cy="228600"/>
           </a:xfrm>
           <a:prstGeom prst="rect">
             <a:avLst/>
@@ -7427,46 +8114,51 @@
           <a:lstStyle/>
           <a:p>
             <a:pPr>
-              <a:defRPr sz="1200" b="1">
-                <a:solidFill>
-                  <a:srgbClr val="00E5FF"/>
+              <a:defRPr sz="800">
+                <a:solidFill>
+                  <a:srgbClr val="64748B"/>
                 </a:solidFill>
                 <a:latin typeface="Segoe UI"/>
               </a:defRPr>
             </a:pPr>
             <a:r>
-              <a:t>OFFICIAL HANDOUT MANDATE: 'WITH MORE TIME WE'D ADD...'</a:t>
-            </a:r>
-          </a:p>
-          <a:p>
-            <a:pPr>
-              <a:defRPr sz="1350" i="1">
-                <a:solidFill>
-                  <a:srgbClr val="FFFFFF"/>
+              <a:t>CLOUD CONNECT 2026  •  PRISMATIC</a:t>
+            </a:r>
+          </a:p>
+        </p:txBody>
+      </p:sp>
+      <p:sp>
+        <p:nvSpPr>
+          <p:cNvPr id="24" name="TextBox 23"/>
+          <p:cNvSpPr txBox="1"/>
+          <p:nvPr/>
+        </p:nvSpPr>
+        <p:spPr>
+          <a:xfrm>
+            <a:off x="10515600" y="6473952"/>
+            <a:ext cx="914400" cy="228600"/>
+          </a:xfrm>
+          <a:prstGeom prst="rect">
+            <a:avLst/>
+          </a:prstGeom>
+          <a:noFill/>
+        </p:spPr>
+        <p:txBody>
+          <a:bodyPr wrap="square">
+            <a:spAutoFit/>
+          </a:bodyPr>
+          <a:lstStyle/>
+          <a:p>
+            <a:pPr algn="r">
+              <a:defRPr sz="800">
+                <a:solidFill>
+                  <a:srgbClr val="64748B"/>
                 </a:solidFill>
                 <a:latin typeface="Segoe UI"/>
               </a:defRPr>
             </a:pPr>
             <a:r>
-              <a:t>"With more time, we’d add live Canvas and syllabus LMS integration, automatically syncing weekly exam dates and generating proactive 15-minute micro-sprints before every morning class.</a:t>
-            </a:r>
-            <a:br/>
-            <a:br/>
-            <a:r>
-              <a:t>We don't just help students pass exams; we eliminate academic paralysis and unlock confidence."</a:t>
-            </a:r>
-          </a:p>
-          <a:p>
-            <a:pPr>
-              <a:defRPr sz="1300" b="1">
-                <a:solidFill>
-                  <a:srgbClr val="34D399"/>
-                </a:solidFill>
-                <a:latin typeface="Segoe UI"/>
-              </a:defRPr>
-            </a:pPr>
-            <a:r>
-              <a:t>WE ARE PRISMATIC — REFRACTING COMPLEX KNOWLEDGE INTO YOUR NATIVE SPECTRUM. VOTE PRISMATIC!</a:t>
+              <a:t>4 / 4</a:t>
             </a:r>
           </a:p>
         </p:txBody>

</xml_diff>

<commit_message>
feat(pitch): upgrade Segment 2 with high-stakes 2 AM midterm hook, stage directions, and refreshed deck & Skia PDFs
</commit_message>
<xml_diff>
--- a/Prismatic_Shark_Tank_Pitch_Deck.pptx
+++ b/Prismatic_Shark_Tank_Pitch_Deck.pptx
@@ -527,12 +527,12 @@
           </a:p>
           <a:p>
             <a:r>
-              <a:t>"Picture a 300-person lecture hall right here at Howard or UMD. The professor spends 75 minutes covering one complex concept. Half the class nods; the other half walks out completely lost with intense brain fog.</a:t>
-            </a:r>
-          </a:p>
-          <a:p>
-            <a:r>
-              <a:t>The problem isn't student intellect. White light contains every color, but a flat chalkboard only projects one shade. Professors teach in one rigid format, while human brains process knowledge in completely different spectrums."</a:t>
+              <a:t>"It’s 2:00 AM before midterms. You’ve re-read the exact same textbook paragraph six times—and understood it zero times. [Micro-pause] You turn to ChatGPT in desperation, and it dumps an 800-word wall of text that makes your brain freeze even harder.</a:t>
+            </a:r>
+          </a:p>
+          <a:p>
+            <a:r>
+              <a:t>That sinking panic isn't a lack of intelligence—it's a failure of wavelength. White light holds every color, but professors lecture in one flat shade. Human brains don't think in monochrome—we learn in spectrums."</a:t>
             </a:r>
           </a:p>
         </p:txBody>
@@ -4200,7 +4200,7 @@
               </a:defRPr>
             </a:pPr>
             <a:r>
-              <a:t>THE 300-STUDENT LECTURE HALL PARADOX:</a:t>
+              <a:t>THE 2:00 AM COGNITIVE PARADOX:</a:t>
             </a:r>
           </a:p>
           <a:p>
@@ -4213,7 +4213,7 @@
               </a:defRPr>
             </a:pPr>
             <a:r>
-              <a:t>One professor teaches 300 students in one rigid format. White light contains every color, but a flat chalkboard only projects one shade. When students freeze with intense brain fog, it's not a lack of intelligence—it's a cognitive mismatch.</a:t>
+              <a:t>It’s 2:00 AM before a midterm. A student re-reads the same paragraph six times, asks ChatGPT, and gets an 800-word text wall that heightens panic. The issue isn't intelligence—it's wavelength. Lectures broadcast in monochrome, while human brains learn in spectrums.</a:t>
             </a:r>
           </a:p>
         </p:txBody>

</xml_diff>